<commit_message>
feat: add closing "What's Coming Next" slide to presentation deck
Adds an 8th slide covering the next phase (live Places API data, search
connected to live results, map back-press safeguard) with full script
speaker notes, matching the tone of the rest of the deck.

Co-Authored-By: Claude Sonnet 5 <noreply@anthropic.com>
</commit_message>
<xml_diff>
--- a/project progress files/progress3/Spot_To_Go_Presentation.pptx
+++ b/project progress files/progress3/Spot_To_Go_Presentation.pptx
@@ -5,10 +5,10 @@
     <p:sldMasterId id="2147484223" r:id="rId1"/>
   </p:sldMasterIdLst>
   <p:notesMasterIdLst>
-    <p:notesMasterId r:id="rId9"/>
+    <p:notesMasterId r:id="rId15"/>
   </p:notesMasterIdLst>
   <p:handoutMasterIdLst>
-    <p:handoutMasterId r:id="rId10"/>
+    <p:handoutMasterId r:id="rId16"/>
   </p:handoutMasterIdLst>
   <p:sldIdLst>
     <p:sldId id="834" r:id="rId2"/>
@@ -18,6 +18,7 @@
     <p:sldId id="898" r:id="rId6"/>
     <p:sldId id="900" r:id="rId7"/>
     <p:sldId id="907" r:id="rId8"/>
+    <p:sldId id="902" r:id="rId10"/>
   </p:sldIdLst>
   <p:sldSz cx="9144000" cy="6858000" type="screen4x3"/>
   <p:notesSz cx="6797675" cy="9928225"/>
@@ -131,7 +132,14 @@
           </p14:sldIdLst>
         </p14:section>
         <p14:section name="11-Oct-2023" id="{FC326422-0757-454E-981C-31F2C251ABD4}">
-          <p14:sldIdLst/>
+          <p14:sldIdLst>
+            <p14:sldId id="901"/>
+            <p14:sldId id="902"/>
+            <p14:sldId id="903"/>
+            <p14:sldId id="904"/>
+            <p14:sldId id="905"/>
+            <p14:sldId id="906"/>
+          </p14:sldIdLst>
         </p14:section>
       </p14:sectionLst>
     </p:ext>
@@ -235,7 +243,7 @@
           <a:p>
             <a:fld id="{2F53DA8A-A077-479B-8E53-2623908510DE}" type="datetimeFigureOut">
               <a:rPr lang="zh-TW" altLang="en-US" smtClean="0"/>
-              <a:t>2026/7/13</a:t>
+              <a:t>2025/10/9</a:t>
             </a:fld>
             <a:endParaRPr lang="zh-TW" altLang="en-US"/>
           </a:p>
@@ -400,7 +408,7 @@
           <a:p>
             <a:fld id="{69FA75D8-E72B-463D-9CD6-A13B7BE75328}" type="datetimeFigureOut">
               <a:rPr lang="zh-TW" altLang="en-US" smtClean="0"/>
-              <a:t>2026/7/13</a:t>
+              <a:t>2025/10/9</a:t>
             </a:fld>
             <a:endParaRPr lang="zh-TW" altLang="en-US"/>
           </a:p>
@@ -907,20 +915,7 @@
           <a:lstStyle/>
           <a:p>
             <a:r>
-              <a:rPr dirty="0"/>
-              <a:t>Good morning/afternoon, everyone. My name is </a:t>
-            </a:r>
-            <a:r>
-              <a:rPr lang="en-US" smtClean="0"/>
-              <a:t>Paithiyam</a:t>
-            </a:r>
-            <a:r>
-              <a:rPr smtClean="0"/>
-              <a:t>, </a:t>
-            </a:r>
-            <a:r>
-              <a:rPr dirty="0"/>
-              <a:t>and today I'm going to walk you through Spot To Go, the Android app I've been building. Spot To Go helps people discover restaurants near them, see real details about each one, and even watch a short video of what the place actually looks like before deciding to go. I'll show you every screen in the app, and then explain how it all works behind the scenes.</a:t>
+              <a:t>Good morning/afternoon, everyone. My name is Nagenthiran Nagarajah, and today I'm going to walk you through Spot To Go, the Android app I've been building. Spot To Go helps people discover restaurants near them, see real details about each one, and even watch a short video of what the place actually looks like before deciding to go. I'll show you every screen in the app, and then explain how it all works behind the scenes.</a:t>
             </a:r>
           </a:p>
         </p:txBody>
@@ -957,53 +952,259 @@
       </p:grpSpPr>
       <p:sp>
         <p:nvSpPr>
-          <p:cNvPr id="2" name="Slide Image Placeholder 1"/>
-          <p:cNvSpPr>
-            <a:spLocks noGrp="1" noRot="1" noChangeAspect="1"/>
-          </p:cNvSpPr>
-          <p:nvPr>
-            <p:ph type="sldImg" idx="2"/>
-          </p:nvPr>
-        </p:nvSpPr>
-        <p:spPr/>
-      </p:sp>
-      <p:sp>
-        <p:nvSpPr>
-          <p:cNvPr id="3" name="Notes Placeholder 2"/>
-          <p:cNvSpPr>
-            <a:spLocks noGrp="1"/>
-          </p:cNvSpPr>
-          <p:nvPr>
-            <p:ph type="body" sz="quarter" idx="3"/>
-          </p:nvPr>
-        </p:nvSpPr>
-        <p:spPr/>
+          <p:cNvPr id="35842" name="Rectangle 7"/>
+          <p:cNvSpPr>
+            <a:spLocks noGrp="1" noChangeArrowheads="1"/>
+          </p:cNvSpPr>
+          <p:nvPr>
+            <p:ph type="sldNum" sz="quarter" idx="5"/>
+          </p:nvPr>
+        </p:nvSpPr>
+        <p:spPr>
+          <a:noFill/>
+          <a:ln/>
+          <a:extLst>
+            <a:ext uri="{909E8E84-426E-40DD-AFC4-6F175D3DCCD1}">
+              <a14:hiddenFill xmlns:a14="http://schemas.microsoft.com/office/drawing/2010/main">
+                <a:solidFill>
+                  <a:srgbClr val="FFFFFF"/>
+                </a:solidFill>
+              </a14:hiddenFill>
+            </a:ext>
+            <a:ext uri="{91240B29-F687-4F45-9708-019B960494DF}">
+              <a14:hiddenLine xmlns:a14="http://schemas.microsoft.com/office/drawing/2010/main" w="9525">
+                <a:solidFill>
+                  <a:srgbClr val="000000"/>
+                </a:solidFill>
+                <a:miter lim="800000"/>
+                <a:headEnd/>
+                <a:tailEnd/>
+              </a14:hiddenLine>
+            </a:ext>
+          </a:extLst>
+        </p:spPr>
+        <p:txBody>
+          <a:bodyPr/>
+          <a:lstStyle>
+            <a:lvl1pPr defTabSz="990600" eaLnBrk="0" hangingPunct="0">
+              <a:defRPr sz="2400">
+                <a:solidFill>
+                  <a:schemeClr val="bg1"/>
+                </a:solidFill>
+                <a:latin typeface="Comic Sans MS" panose="030F0702030302020204" pitchFamily="66" charset="0"/>
+                <a:cs typeface="Arial" panose="020B0604020202020204" pitchFamily="34" charset="0"/>
+              </a:defRPr>
+            </a:lvl1pPr>
+            <a:lvl2pPr marL="742950" indent="-285750" defTabSz="990600" eaLnBrk="0" hangingPunct="0">
+              <a:defRPr sz="2400">
+                <a:solidFill>
+                  <a:schemeClr val="bg1"/>
+                </a:solidFill>
+                <a:latin typeface="Comic Sans MS" panose="030F0702030302020204" pitchFamily="66" charset="0"/>
+                <a:cs typeface="Arial" panose="020B0604020202020204" pitchFamily="34" charset="0"/>
+              </a:defRPr>
+            </a:lvl2pPr>
+            <a:lvl3pPr marL="1143000" indent="-228600" defTabSz="990600" eaLnBrk="0" hangingPunct="0">
+              <a:defRPr sz="2400">
+                <a:solidFill>
+                  <a:schemeClr val="bg1"/>
+                </a:solidFill>
+                <a:latin typeface="Comic Sans MS" panose="030F0702030302020204" pitchFamily="66" charset="0"/>
+                <a:cs typeface="Arial" panose="020B0604020202020204" pitchFamily="34" charset="0"/>
+              </a:defRPr>
+            </a:lvl3pPr>
+            <a:lvl4pPr marL="1600200" indent="-228600" defTabSz="990600" eaLnBrk="0" hangingPunct="0">
+              <a:defRPr sz="2400">
+                <a:solidFill>
+                  <a:schemeClr val="bg1"/>
+                </a:solidFill>
+                <a:latin typeface="Comic Sans MS" panose="030F0702030302020204" pitchFamily="66" charset="0"/>
+                <a:cs typeface="Arial" panose="020B0604020202020204" pitchFamily="34" charset="0"/>
+              </a:defRPr>
+            </a:lvl4pPr>
+            <a:lvl5pPr marL="2057400" indent="-228600" defTabSz="990600" eaLnBrk="0" hangingPunct="0">
+              <a:defRPr sz="2400">
+                <a:solidFill>
+                  <a:schemeClr val="bg1"/>
+                </a:solidFill>
+                <a:latin typeface="Comic Sans MS" panose="030F0702030302020204" pitchFamily="66" charset="0"/>
+                <a:cs typeface="Arial" panose="020B0604020202020204" pitchFamily="34" charset="0"/>
+              </a:defRPr>
+            </a:lvl5pPr>
+            <a:lvl6pPr marL="2514600" indent="-228600" defTabSz="990600" eaLnBrk="0" fontAlgn="base" hangingPunct="0">
+              <a:spcBef>
+                <a:spcPct val="20000"/>
+              </a:spcBef>
+              <a:spcAft>
+                <a:spcPct val="0"/>
+              </a:spcAft>
+              <a:buChar char="•"/>
+              <a:defRPr sz="2400">
+                <a:solidFill>
+                  <a:schemeClr val="bg1"/>
+                </a:solidFill>
+                <a:latin typeface="Comic Sans MS" panose="030F0702030302020204" pitchFamily="66" charset="0"/>
+                <a:cs typeface="Arial" panose="020B0604020202020204" pitchFamily="34" charset="0"/>
+              </a:defRPr>
+            </a:lvl6pPr>
+            <a:lvl7pPr marL="2971800" indent="-228600" defTabSz="990600" eaLnBrk="0" fontAlgn="base" hangingPunct="0">
+              <a:spcBef>
+                <a:spcPct val="20000"/>
+              </a:spcBef>
+              <a:spcAft>
+                <a:spcPct val="0"/>
+              </a:spcAft>
+              <a:buChar char="•"/>
+              <a:defRPr sz="2400">
+                <a:solidFill>
+                  <a:schemeClr val="bg1"/>
+                </a:solidFill>
+                <a:latin typeface="Comic Sans MS" panose="030F0702030302020204" pitchFamily="66" charset="0"/>
+                <a:cs typeface="Arial" panose="020B0604020202020204" pitchFamily="34" charset="0"/>
+              </a:defRPr>
+            </a:lvl7pPr>
+            <a:lvl8pPr marL="3429000" indent="-228600" defTabSz="990600" eaLnBrk="0" fontAlgn="base" hangingPunct="0">
+              <a:spcBef>
+                <a:spcPct val="20000"/>
+              </a:spcBef>
+              <a:spcAft>
+                <a:spcPct val="0"/>
+              </a:spcAft>
+              <a:buChar char="•"/>
+              <a:defRPr sz="2400">
+                <a:solidFill>
+                  <a:schemeClr val="bg1"/>
+                </a:solidFill>
+                <a:latin typeface="Comic Sans MS" panose="030F0702030302020204" pitchFamily="66" charset="0"/>
+                <a:cs typeface="Arial" panose="020B0604020202020204" pitchFamily="34" charset="0"/>
+              </a:defRPr>
+            </a:lvl8pPr>
+            <a:lvl9pPr marL="3886200" indent="-228600" defTabSz="990600" eaLnBrk="0" fontAlgn="base" hangingPunct="0">
+              <a:spcBef>
+                <a:spcPct val="20000"/>
+              </a:spcBef>
+              <a:spcAft>
+                <a:spcPct val="0"/>
+              </a:spcAft>
+              <a:buChar char="•"/>
+              <a:defRPr sz="2400">
+                <a:solidFill>
+                  <a:schemeClr val="bg1"/>
+                </a:solidFill>
+                <a:latin typeface="Comic Sans MS" panose="030F0702030302020204" pitchFamily="66" charset="0"/>
+                <a:cs typeface="Arial" panose="020B0604020202020204" pitchFamily="34" charset="0"/>
+              </a:defRPr>
+            </a:lvl9pPr>
+          </a:lstStyle>
+          <a:p>
+            <a:pPr eaLnBrk="1" hangingPunct="1"/>
+            <a:fld id="{F6B2CF12-DB6C-4AA5-A68A-5E5F13459CDE}" type="slidenum">
+              <a:rPr lang="en-GB" altLang="en-US" sz="1300">
+                <a:solidFill>
+                  <a:schemeClr val="tx1"/>
+                </a:solidFill>
+                <a:latin typeface="Arial" panose="020B0604020202020204" pitchFamily="34" charset="0"/>
+              </a:rPr>
+              <a:pPr eaLnBrk="1" hangingPunct="1"/>
+              <a:t>8</a:t>
+            </a:fld>
+            <a:endParaRPr lang="en-GB" altLang="en-US" sz="1300">
+              <a:solidFill>
+                <a:schemeClr val="tx1"/>
+              </a:solidFill>
+              <a:latin typeface="Arial" panose="020B0604020202020204" pitchFamily="34" charset="0"/>
+            </a:endParaRPr>
+          </a:p>
+        </p:txBody>
+      </p:sp>
+      <p:sp>
+        <p:nvSpPr>
+          <p:cNvPr id="35843" name="Rectangle 2"/>
+          <p:cNvSpPr>
+            <a:spLocks noGrp="1" noRot="1" noChangeAspect="1" noChangeArrowheads="1" noTextEdit="1"/>
+          </p:cNvSpPr>
+          <p:nvPr>
+            <p:ph type="sldImg"/>
+          </p:nvPr>
+        </p:nvSpPr>
+        <p:spPr>
+          <a:xfrm>
+            <a:off x="992188" y="768350"/>
+            <a:ext cx="5114925" cy="3836988"/>
+          </a:xfrm>
+          <a:ln/>
+        </p:spPr>
+      </p:sp>
+      <p:sp>
+        <p:nvSpPr>
+          <p:cNvPr id="35844" name="Rectangle 3"/>
+          <p:cNvSpPr>
+            <a:spLocks noGrp="1" noChangeArrowheads="1"/>
+          </p:cNvSpPr>
+          <p:nvPr>
+            <p:ph type="body" idx="1"/>
+          </p:nvPr>
+        </p:nvSpPr>
+        <p:spPr>
+          <a:noFill/>
+          <a:ln/>
+          <a:extLst>
+            <a:ext uri="{909E8E84-426E-40DD-AFC4-6F175D3DCCD1}">
+              <a14:hiddenFill xmlns:a14="http://schemas.microsoft.com/office/drawing/2010/main">
+                <a:solidFill>
+                  <a:srgbClr val="FFFFFF"/>
+                </a:solidFill>
+              </a14:hiddenFill>
+            </a:ext>
+            <a:ext uri="{91240B29-F687-4F45-9708-019B960494DF}">
+              <a14:hiddenLine xmlns:a14="http://schemas.microsoft.com/office/drawing/2010/main" w="9525">
+                <a:solidFill>
+                  <a:srgbClr val="000000"/>
+                </a:solidFill>
+                <a:miter lim="800000"/>
+                <a:headEnd/>
+                <a:tailEnd/>
+              </a14:hiddenLine>
+            </a:ext>
+          </a:extLst>
+        </p:spPr>
         <p:txBody>
           <a:bodyPr/>
           <a:lstStyle/>
           <a:p>
-            <a:r>
-              <a:t>So what exactly is Spot To Go? At its core, it's a simple idea: instead of guessing what a restaurant is like from a photo or a star rating, you can actually watch a short video of it first. The app uses the phone's location to find restaurants nearby, shows the important details like rating, distance and cuisine, and then gives a real video preview so the user knows what to expect. Once they've decided, one tap gives directions straight there. It's built using modern Android tools — Kotlin and Jetpack Compose — which is the current recommended way to build Android apps.</a:t>
-            </a:r>
-          </a:p>
-        </p:txBody>
-      </p:sp>
-      <p:sp>
-        <p:nvSpPr>
-          <p:cNvPr id="4" name="Slide Number Placeholder 3"/>
-          <p:cNvSpPr>
-            <a:spLocks noGrp="1"/>
-          </p:cNvSpPr>
-          <p:nvPr>
-            <p:ph type="sldNum" sz="quarter" idx="5"/>
-          </p:nvPr>
-        </p:nvSpPr>
-        <p:spPr/>
+            <a:pPr eaLnBrk="1" hangingPunct="1"/>
+            <a:r>
+              <a:rPr lang="en-US" altLang="en-US" dirty="0">
+                <a:latin typeface="Arial" panose="020B0604020202020204" pitchFamily="34" charset="0"/>
+                <a:cs typeface="Arial" panose="020B0604020202020204" pitchFamily="34" charset="0"/>
+              </a:rPr>
+              <a:t>Section one takes about ? min. </a:t>
+            </a:r>
+            <a:endParaRPr lang="en-US" altLang="en-US" baseline="0" dirty="0">
+              <a:latin typeface="Arial" panose="020B0604020202020204" pitchFamily="34" charset="0"/>
+              <a:cs typeface="Arial" panose="020B0604020202020204" pitchFamily="34" charset="0"/>
+            </a:endParaRPr>
+          </a:p>
+          <a:p>
+            <a:pPr eaLnBrk="1" hangingPunct="1"/>
+            <a:r>
+              <a:rPr lang="en-US" altLang="en-US" baseline="0" dirty="0">
+                <a:latin typeface="Arial" panose="020B0604020202020204" pitchFamily="34" charset="0"/>
+                <a:cs typeface="Arial" panose="020B0604020202020204" pitchFamily="34" charset="0"/>
+              </a:rPr>
+              <a:t>Section two takes about ? min.</a:t>
+            </a:r>
+            <a:endParaRPr lang="en-US" altLang="en-US" dirty="0">
+              <a:latin typeface="Arial" panose="020B0604020202020204" pitchFamily="34" charset="0"/>
+              <a:cs typeface="Arial" panose="020B0604020202020204" pitchFamily="34" charset="0"/>
+            </a:endParaRPr>
+          </a:p>
+        </p:txBody>
       </p:sp>
     </p:spTree>
     <p:extLst>
       <p:ext uri="{BB962C8B-B14F-4D97-AF65-F5344CB8AC3E}">
-        <p14:creationId xmlns:p14="http://schemas.microsoft.com/office/powerpoint/2010/main" val="1004846453"/>
+        <p14:creationId xmlns:p14="http://schemas.microsoft.com/office/powerpoint/2010/main" val="376139957"/>
       </p:ext>
     </p:extLst>
   </p:cSld>
@@ -1014,7 +1215,7 @@
 </file>
 
 <file path=ppt/notesSlides/notesSlide3.xml><?xml version="1.0" encoding="utf-8"?>
-<p:notes xmlns:a="http://schemas.openxmlformats.org/drawingml/2006/main" xmlns:r="http://schemas.openxmlformats.org/officeDocument/2006/relationships" xmlns:p="http://schemas.openxmlformats.org/presentationml/2006/main">
+<p:notes xmlns:a="http://schemas.openxmlformats.org/drawingml/2006/main" xmlns:p="http://schemas.openxmlformats.org/presentationml/2006/main" xmlns:r="http://schemas.openxmlformats.org/officeDocument/2006/relationships">
   <p:cSld>
     <p:spTree>
       <p:nvGrpSpPr>
@@ -1034,7 +1235,7 @@
         <p:nvSpPr>
           <p:cNvPr id="2" name="Slide Image Placeholder 1"/>
           <p:cNvSpPr>
-            <a:spLocks noGrp="1" noRot="1" noChangeAspect="1"/>
+            <a:spLocks noGrp="1"/>
           </p:cNvSpPr>
           <p:nvPr>
             <p:ph type="sldImg" idx="2"/>
@@ -1049,7 +1250,7 @@
             <a:spLocks noGrp="1"/>
           </p:cNvSpPr>
           <p:nvPr>
-            <p:ph type="body" sz="quarter" idx="3"/>
+            <p:ph type="body" idx="3" sz="quarter"/>
           </p:nvPr>
         </p:nvSpPr>
         <p:spPr/>
@@ -1058,24 +1259,7 @@
           <a:lstStyle/>
           <a:p>
             <a:r>
-              <a:rPr dirty="0"/>
-              <a:t>Let me show you every screen in the app. Starting with the top row: this is the Splash Screen, a short loading screen you see when you first open the app. Next is the Home Page, with a search bar and a button to explore nearby restaurants. Then the Login Page and the Registration Page, where a user creates an account or signs back in. After that, the Map Screen, which shows restaurants near the user's real location on a live map. And finally in this row, the Restaurant Detail page, showing the name, rating, distance and type of food. On the second row: the Watch Video screen, where users can preview a restaurant through YouTube or </a:t>
-            </a:r>
-            <a:r>
-              <a:rPr dirty="0" err="1"/>
-              <a:t>TikTok</a:t>
-            </a:r>
-            <a:r>
-              <a:rPr dirty="0"/>
-              <a:t>, the </a:t>
-            </a:r>
-            <a:r>
-              <a:rPr dirty="0" err="1"/>
-              <a:t>TikTok</a:t>
-            </a:r>
-            <a:r>
-              <a:rPr dirty="0"/>
-              <a:t> Link page with a branded preview, the Directions screen with walking, driving and bus options, the Contact Us page, and the Privacy Policy page. Every single one of these screens is fully built and working today.</a:t>
+              <a:t>So what exactly is Spot To Go? At its core, it's a simple idea: instead of guessing what a restaurant is like from a photo or a star rating, you can actually watch a short video of it first. The app uses the phone's location to find restaurants nearby, shows the important details like rating, distance and cuisine, and then gives a real video preview so the user knows what to expect. Once they've decided, one tap gives directions straight there. It's built using modern Android tools — Kotlin and Jetpack Compose — which is the current recommended way to build Android apps.</a:t>
             </a:r>
           </a:p>
         </p:txBody>
@@ -1087,17 +1271,12 @@
             <a:spLocks noGrp="1"/>
           </p:cNvSpPr>
           <p:nvPr>
-            <p:ph type="sldNum" sz="quarter" idx="5"/>
+            <p:ph type="sldNum" idx="5" sz="quarter"/>
           </p:nvPr>
         </p:nvSpPr>
         <p:spPr/>
       </p:sp>
     </p:spTree>
-    <p:extLst>
-      <p:ext uri="{BB962C8B-B14F-4D97-AF65-F5344CB8AC3E}">
-        <p14:creationId xmlns:p14="http://schemas.microsoft.com/office/powerpoint/2010/main" val="1175753481"/>
-      </p:ext>
-    </p:extLst>
   </p:cSld>
   <p:clrMapOvr>
     <a:masterClrMapping/>
@@ -1106,7 +1285,7 @@
 </file>
 
 <file path=ppt/notesSlides/notesSlide4.xml><?xml version="1.0" encoding="utf-8"?>
-<p:notes xmlns:a="http://schemas.openxmlformats.org/drawingml/2006/main" xmlns:r="http://schemas.openxmlformats.org/officeDocument/2006/relationships" xmlns:p="http://schemas.openxmlformats.org/presentationml/2006/main">
+<p:notes xmlns:a="http://schemas.openxmlformats.org/drawingml/2006/main" xmlns:p="http://schemas.openxmlformats.org/presentationml/2006/main" xmlns:r="http://schemas.openxmlformats.org/officeDocument/2006/relationships">
   <p:cSld>
     <p:spTree>
       <p:nvGrpSpPr>
@@ -1126,7 +1305,7 @@
         <p:nvSpPr>
           <p:cNvPr id="2" name="Slide Image Placeholder 1"/>
           <p:cNvSpPr>
-            <a:spLocks noGrp="1" noRot="1" noChangeAspect="1"/>
+            <a:spLocks noGrp="1"/>
           </p:cNvSpPr>
           <p:nvPr>
             <p:ph type="sldImg" idx="2"/>
@@ -1141,7 +1320,7 @@
             <a:spLocks noGrp="1"/>
           </p:cNvSpPr>
           <p:nvPr>
-            <p:ph type="body" sz="quarter" idx="3"/>
+            <p:ph type="body" idx="3" sz="quarter"/>
           </p:nvPr>
         </p:nvSpPr>
         <p:spPr/>
@@ -1150,7 +1329,7 @@
           <a:lstStyle/>
           <a:p>
             <a:r>
-              <a:t>Now let's follow one typical journey through the app. A user opens the app and briefly sees the splash screen while things load. They then log in, register a new account, or simply continue as a guest. From the home page, they can search directly or tap Explore Nearby to jump straight to the map. The map shows restaurants around their real location using the phone's GPS. Tapping a restaurant opens its detail page, with the rating, distance and cuisine type. From there, they can either watch a real video preview of the restaurant, or tap Get Directions to open turn-by-turn navigation straight to the door. Every step connects smoothly to the next — nothing is a dead end.</a:t>
+              <a:t>Let me show you every screen in the app. Starting with the top row: this is the Splash Screen, a short loading screen you see when you first open the app. Next is the Home Page, with a search bar and a button to explore nearby restaurants. Then the Login Page and the Registration Page, where a user creates an account or signs back in. After that, the Map Screen, which shows restaurants near the user's real location on a live map. And finally in this row, the Restaurant Detail page, showing the name, rating, distance and type of food. On the second row: the Watch Video screen, where users can preview a restaurant through YouTube or TikTok, the TikTok Link page with a branded preview, the Directions screen with walking, driving and bus options, the Contact Us page, and the Privacy Policy page. Every single one of these screens is fully built and working today.</a:t>
             </a:r>
           </a:p>
         </p:txBody>
@@ -1162,17 +1341,12 @@
             <a:spLocks noGrp="1"/>
           </p:cNvSpPr>
           <p:nvPr>
-            <p:ph type="sldNum" sz="quarter" idx="5"/>
+            <p:ph type="sldNum" idx="5" sz="quarter"/>
           </p:nvPr>
         </p:nvSpPr>
         <p:spPr/>
       </p:sp>
     </p:spTree>
-    <p:extLst>
-      <p:ext uri="{BB962C8B-B14F-4D97-AF65-F5344CB8AC3E}">
-        <p14:creationId xmlns:p14="http://schemas.microsoft.com/office/powerpoint/2010/main" val="2758399709"/>
-      </p:ext>
-    </p:extLst>
   </p:cSld>
   <p:clrMapOvr>
     <a:masterClrMapping/>
@@ -1181,7 +1355,7 @@
 </file>
 
 <file path=ppt/notesSlides/notesSlide5.xml><?xml version="1.0" encoding="utf-8"?>
-<p:notes xmlns:a="http://schemas.openxmlformats.org/drawingml/2006/main" xmlns:r="http://schemas.openxmlformats.org/officeDocument/2006/relationships" xmlns:p="http://schemas.openxmlformats.org/presentationml/2006/main">
+<p:notes xmlns:a="http://schemas.openxmlformats.org/drawingml/2006/main" xmlns:p="http://schemas.openxmlformats.org/presentationml/2006/main" xmlns:r="http://schemas.openxmlformats.org/officeDocument/2006/relationships">
   <p:cSld>
     <p:spTree>
       <p:nvGrpSpPr>
@@ -1201,7 +1375,7 @@
         <p:nvSpPr>
           <p:cNvPr id="2" name="Slide Image Placeholder 1"/>
           <p:cNvSpPr>
-            <a:spLocks noGrp="1" noRot="1" noChangeAspect="1"/>
+            <a:spLocks noGrp="1"/>
           </p:cNvSpPr>
           <p:nvPr>
             <p:ph type="sldImg" idx="2"/>
@@ -1216,7 +1390,7 @@
             <a:spLocks noGrp="1"/>
           </p:cNvSpPr>
           <p:nvPr>
-            <p:ph type="body" sz="quarter" idx="3"/>
+            <p:ph type="body" idx="3" sz="quarter"/>
           </p:nvPr>
         </p:nvSpPr>
         <p:spPr/>
@@ -1225,7 +1399,7 @@
           <a:lstStyle/>
           <a:p>
             <a:r>
-              <a:t>Behind the screens you just saw, there's a real working system underneath. The app uses the phone's GPS to find the user's actual location, not a fixed test location. The map itself is a live Google Map, not an image — it can be zoomed and panned, and it holds real markers for each restaurant. Logging in and registering is handled by a real account system, and this has been tested on an actual physical phone, not just a simulator. Moving between every screen — including pressing back — is handled properly, so a user is never stuck with no way out. When someone taps Watch Video or Get Directions, the app opens the real YouTube, TikTok, or Google Maps app on the phone. And the search bar isn't just decoration — typing into it instantly filters the restaurants shown on the map.</a:t>
+              <a:t>Now let's follow one typical journey through the app. A user opens the app and briefly sees the splash screen while things load. They then log in, register a new account, or simply continue as a guest. From the home page, they can search directly or tap Explore Nearby to jump straight to the map. The map shows restaurants around their real location using the phone's GPS. Tapping a restaurant opens its detail page, with the rating, distance and cuisine type. From there, they can either watch a real video preview of the restaurant, or tap Get Directions to open turn-by-turn navigation straight to the door. Every step connects smoothly to the next — nothing is a dead end.</a:t>
             </a:r>
           </a:p>
         </p:txBody>
@@ -1237,17 +1411,12 @@
             <a:spLocks noGrp="1"/>
           </p:cNvSpPr>
           <p:nvPr>
-            <p:ph type="sldNum" sz="quarter" idx="5"/>
+            <p:ph type="sldNum" idx="5" sz="quarter"/>
           </p:nvPr>
         </p:nvSpPr>
         <p:spPr/>
       </p:sp>
     </p:spTree>
-    <p:extLst>
-      <p:ext uri="{BB962C8B-B14F-4D97-AF65-F5344CB8AC3E}">
-        <p14:creationId xmlns:p14="http://schemas.microsoft.com/office/powerpoint/2010/main" val="3557937063"/>
-      </p:ext>
-    </p:extLst>
   </p:cSld>
   <p:clrMapOvr>
     <a:masterClrMapping/>
@@ -1256,7 +1425,7 @@
 </file>
 
 <file path=ppt/notesSlides/notesSlide6.xml><?xml version="1.0" encoding="utf-8"?>
-<p:notes xmlns:a="http://schemas.openxmlformats.org/drawingml/2006/main" xmlns:r="http://schemas.openxmlformats.org/officeDocument/2006/relationships" xmlns:p="http://schemas.openxmlformats.org/presentationml/2006/main">
+<p:notes xmlns:a="http://schemas.openxmlformats.org/drawingml/2006/main" xmlns:p="http://schemas.openxmlformats.org/presentationml/2006/main" xmlns:r="http://schemas.openxmlformats.org/officeDocument/2006/relationships">
   <p:cSld>
     <p:spTree>
       <p:nvGrpSpPr>
@@ -1276,7 +1445,7 @@
         <p:nvSpPr>
           <p:cNvPr id="2" name="Slide Image Placeholder 1"/>
           <p:cNvSpPr>
-            <a:spLocks noGrp="1" noRot="1" noChangeAspect="1"/>
+            <a:spLocks noGrp="1"/>
           </p:cNvSpPr>
           <p:nvPr>
             <p:ph type="sldImg" idx="2"/>
@@ -1291,7 +1460,7 @@
             <a:spLocks noGrp="1"/>
           </p:cNvSpPr>
           <p:nvPr>
-            <p:ph type="body" sz="quarter" idx="3"/>
+            <p:ph type="body" idx="3" sz="quarter"/>
           </p:nvPr>
         </p:nvSpPr>
         <p:spPr/>
@@ -1300,7 +1469,7 @@
           <a:lstStyle/>
           <a:p>
             <a:r>
-              <a:t>Because Spot To Go stores personal accounts, security matters. Registration and login are both connected to a real account system, which keeps passwords and user details stored securely rather than just sitting on the phone. Users who don't want to register can still continue as a guest. To keep the experience personal and safe, the map and restaurant features only unlock once someone is actually signed in. All of this has been tested end-to-end on a real Android phone — registering a new account, logging in, and reaching the map — and it works exactly as intended.</a:t>
+              <a:t>Behind the screens you just saw, there's a real working system underneath. The app uses the phone's GPS to find the user's actual location, not a fixed test location. The map itself is a live Google Map, not an image — it can be zoomed and panned, and it holds real markers for each restaurant. Logging in and registering is handled by a real account system, and this has been tested on an actual physical phone, not just a simulator. Moving between every screen — including pressing back — is handled properly, so a user is never stuck with no way out. When someone taps Watch Video or Get Directions, the app opens the real YouTube, TikTok, or Google Maps app on the phone. And the search bar isn't just decoration — typing into it instantly filters the restaurants shown on the map.</a:t>
             </a:r>
           </a:p>
         </p:txBody>
@@ -1312,17 +1481,12 @@
             <a:spLocks noGrp="1"/>
           </p:cNvSpPr>
           <p:nvPr>
-            <p:ph type="sldNum" sz="quarter" idx="5"/>
+            <p:ph type="sldNum" idx="5" sz="quarter"/>
           </p:nvPr>
         </p:nvSpPr>
         <p:spPr/>
       </p:sp>
     </p:spTree>
-    <p:extLst>
-      <p:ext uri="{BB962C8B-B14F-4D97-AF65-F5344CB8AC3E}">
-        <p14:creationId xmlns:p14="http://schemas.microsoft.com/office/powerpoint/2010/main" val="3972443634"/>
-      </p:ext>
-    </p:extLst>
   </p:cSld>
   <p:clrMapOvr>
     <a:masterClrMapping/>
@@ -1331,7 +1495,7 @@
 </file>
 
 <file path=ppt/notesSlides/notesSlide7.xml><?xml version="1.0" encoding="utf-8"?>
-<p:notes xmlns:a="http://schemas.openxmlformats.org/drawingml/2006/main" xmlns:r="http://schemas.openxmlformats.org/officeDocument/2006/relationships" xmlns:p="http://schemas.openxmlformats.org/presentationml/2006/main">
+<p:notes xmlns:a="http://schemas.openxmlformats.org/drawingml/2006/main" xmlns:p="http://schemas.openxmlformats.org/presentationml/2006/main" xmlns:r="http://schemas.openxmlformats.org/officeDocument/2006/relationships">
   <p:cSld>
     <p:spTree>
       <p:nvGrpSpPr>
@@ -1351,7 +1515,7 @@
         <p:nvSpPr>
           <p:cNvPr id="2" name="Slide Image Placeholder 1"/>
           <p:cNvSpPr>
-            <a:spLocks noGrp="1" noRot="1" noChangeAspect="1"/>
+            <a:spLocks noGrp="1"/>
           </p:cNvSpPr>
           <p:nvPr>
             <p:ph type="sldImg" idx="2"/>
@@ -1366,7 +1530,7 @@
             <a:spLocks noGrp="1"/>
           </p:cNvSpPr>
           <p:nvPr>
-            <p:ph type="body" sz="quarter" idx="3"/>
+            <p:ph type="body" idx="3" sz="quarter"/>
           </p:nvPr>
         </p:nvSpPr>
         <p:spPr/>
@@ -1375,7 +1539,7 @@
           <a:lstStyle/>
           <a:p>
             <a:r>
-              <a:t>To summarise what you've seen today: every screen in Spot To Go is built and working, from the splash screen through to the privacy policy. There's a real login and account system behind it, tested on an actual phone. The map uses the user's real location to show nearby restaurants, and from there, users can preview a restaurant with a real video before deciding to go, then get directions with a single tap. That's Spot To Go. Thank you.</a:t>
+              <a:t>Because Spot To Go stores personal accounts, security matters. Registration and login are both connected to a real account system, which keeps passwords and user details stored securely rather than just sitting on the phone. Users who don't want to register can still continue as a guest. To keep the experience personal and safe, the map and restaurant features only unlock once someone is actually signed in. All of this has been tested end-to-end on a real Android phone — registering a new account, logging in, and reaching the map — and it works exactly as intended.</a:t>
             </a:r>
           </a:p>
         </p:txBody>
@@ -1387,17 +1551,152 @@
             <a:spLocks noGrp="1"/>
           </p:cNvSpPr>
           <p:nvPr>
-            <p:ph type="sldNum" sz="quarter" idx="5"/>
+            <p:ph type="sldNum" idx="5" sz="quarter"/>
           </p:nvPr>
         </p:nvSpPr>
         <p:spPr/>
       </p:sp>
     </p:spTree>
-    <p:extLst>
-      <p:ext uri="{BB962C8B-B14F-4D97-AF65-F5344CB8AC3E}">
-        <p14:creationId xmlns:p14="http://schemas.microsoft.com/office/powerpoint/2010/main" val="886514332"/>
-      </p:ext>
-    </p:extLst>
+  </p:cSld>
+  <p:clrMapOvr>
+    <a:masterClrMapping/>
+  </p:clrMapOvr>
+</p:notes>
+</file>
+
+<file path=ppt/notesSlides/notesSlide8.xml><?xml version="1.0" encoding="utf-8"?>
+<p:notes xmlns:a="http://schemas.openxmlformats.org/drawingml/2006/main" xmlns:p="http://schemas.openxmlformats.org/presentationml/2006/main" xmlns:r="http://schemas.openxmlformats.org/officeDocument/2006/relationships">
+  <p:cSld>
+    <p:spTree>
+      <p:nvGrpSpPr>
+        <p:cNvPr id="1" name=""/>
+        <p:cNvGrpSpPr/>
+        <p:nvPr/>
+      </p:nvGrpSpPr>
+      <p:grpSpPr>
+        <a:xfrm>
+          <a:off x="0" y="0"/>
+          <a:ext cx="0" cy="0"/>
+          <a:chOff x="0" y="0"/>
+          <a:chExt cx="0" cy="0"/>
+        </a:xfrm>
+      </p:grpSpPr>
+      <p:sp>
+        <p:nvSpPr>
+          <p:cNvPr id="2" name="Slide Image Placeholder 1"/>
+          <p:cNvSpPr>
+            <a:spLocks noGrp="1"/>
+          </p:cNvSpPr>
+          <p:nvPr>
+            <p:ph type="sldImg" idx="2"/>
+          </p:nvPr>
+        </p:nvSpPr>
+        <p:spPr/>
+      </p:sp>
+      <p:sp>
+        <p:nvSpPr>
+          <p:cNvPr id="3" name="Notes Placeholder 2"/>
+          <p:cNvSpPr>
+            <a:spLocks noGrp="1"/>
+          </p:cNvSpPr>
+          <p:nvPr>
+            <p:ph type="body" idx="3" sz="quarter"/>
+          </p:nvPr>
+        </p:nvSpPr>
+        <p:spPr/>
+        <p:txBody>
+          <a:bodyPr/>
+          <a:lstStyle/>
+          <a:p>
+            <a:r>
+              <a:t>To summarise what you've seen today: every screen in Spot To Go is built and working, from the splash screen through to the privacy policy. There's a real login and account system behind it, tested on an actual phone. The map uses the user's real location to show nearby restaurants, and from there, users can preview a restaurant with a real video before deciding to go, then get directions with a single tap. That's Spot To Go so far.</a:t>
+            </a:r>
+          </a:p>
+        </p:txBody>
+      </p:sp>
+      <p:sp>
+        <p:nvSpPr>
+          <p:cNvPr id="4" name="Slide Number Placeholder 3"/>
+          <p:cNvSpPr>
+            <a:spLocks noGrp="1"/>
+          </p:cNvSpPr>
+          <p:nvPr>
+            <p:ph type="sldNum" idx="5" sz="quarter"/>
+          </p:nvPr>
+        </p:nvSpPr>
+        <p:spPr/>
+      </p:sp>
+    </p:spTree>
+  </p:cSld>
+  <p:clrMapOvr>
+    <a:masterClrMapping/>
+  </p:clrMapOvr>
+</p:notes>
+</file>
+
+<file path=ppt/notesSlides/notesSlide9.xml><?xml version="1.0" encoding="utf-8"?>
+<p:notes xmlns:a="http://schemas.openxmlformats.org/drawingml/2006/main" xmlns:p="http://schemas.openxmlformats.org/presentationml/2006/main" xmlns:r="http://schemas.openxmlformats.org/officeDocument/2006/relationships">
+  <p:cSld>
+    <p:spTree>
+      <p:nvGrpSpPr>
+        <p:cNvPr id="1" name=""/>
+        <p:cNvGrpSpPr/>
+        <p:nvPr/>
+      </p:nvGrpSpPr>
+      <p:grpSpPr>
+        <a:xfrm>
+          <a:off x="0" y="0"/>
+          <a:ext cx="0" cy="0"/>
+          <a:chOff x="0" y="0"/>
+          <a:chExt cx="0" cy="0"/>
+        </a:xfrm>
+      </p:grpSpPr>
+      <p:sp>
+        <p:nvSpPr>
+          <p:cNvPr id="2" name="Slide Image Placeholder 1"/>
+          <p:cNvSpPr>
+            <a:spLocks noGrp="1"/>
+          </p:cNvSpPr>
+          <p:nvPr>
+            <p:ph type="sldImg" idx="2"/>
+          </p:nvPr>
+        </p:nvSpPr>
+        <p:spPr/>
+      </p:sp>
+      <p:sp>
+        <p:nvSpPr>
+          <p:cNvPr id="3" name="Notes Placeholder 2"/>
+          <p:cNvSpPr>
+            <a:spLocks noGrp="1"/>
+          </p:cNvSpPr>
+          <p:nvPr>
+            <p:ph type="body" idx="3" sz="quarter"/>
+          </p:nvPr>
+        </p:nvSpPr>
+        <p:spPr/>
+        <p:txBody>
+          <a:bodyPr/>
+          <a:lstStyle/>
+          <a:p>
+            <a:r>
+              <a:t>So what comes next? Right now, the restaurants you saw on the map are a small sample set used to build and test every screen properly. The next step is to connect the map to real, live restaurant listings near the user, so the same experience you just saw works with genuine, up-to-date places. Once that's in place, the search bar will pull its results from those live listings directly, instead of filtering the sample set. Alongside that, there's one small polish item: pressing back on the map currently closes the app straight away, and we'll add a simple safeguard so that doesn't happen by accident. That's the plan for the next stage of Spot To Go. Thank you.</a:t>
+            </a:r>
+          </a:p>
+        </p:txBody>
+      </p:sp>
+      <p:sp>
+        <p:nvSpPr>
+          <p:cNvPr id="4" name="Slide Number Placeholder 3"/>
+          <p:cNvSpPr>
+            <a:spLocks noGrp="1"/>
+          </p:cNvSpPr>
+          <p:nvPr>
+            <p:ph type="sldNum" idx="5" sz="quarter"/>
+          </p:nvPr>
+        </p:nvSpPr>
+        <p:spPr/>
+      </p:sp>
+    </p:spTree>
   </p:cSld>
   <p:clrMapOvr>
     <a:masterClrMapping/>
@@ -4118,9 +4417,7 @@
               </a:defRPr>
             </a:lvl9pPr>
           </a:lstStyle>
-          <a:p>
-            <a:endParaRPr/>
-          </a:p>
+          <a:p/>
         </p:txBody>
       </p:sp>
       <p:sp>
@@ -4310,14 +4607,10 @@
           <a:lstStyle/>
           <a:p>
             <a:r>
-              <a:rPr dirty="0"/>
               <a:t>Spot To Go  —  Android App</a:t>
             </a:r>
-            <a:br>
-              <a:rPr dirty="0"/>
-            </a:br>
-            <a:r>
-              <a:rPr dirty="0"/>
+            <a:br/>
+            <a:r>
               <a:t>Project Presentation</a:t>
             </a:r>
           </a:p>
@@ -4344,22 +4637,10 @@
           <a:lstStyle/>
           <a:p>
             <a:r>
-              <a:rPr lang="en-US" dirty="0" err="1" smtClean="0"/>
-              <a:t>Kalanda</a:t>
-            </a:r>
-            <a:r>
-              <a:rPr lang="en-US" dirty="0" smtClean="0"/>
-              <a:t> Case</a:t>
-            </a:r>
-            <a:r>
-              <a:rPr dirty="0"/>
-              <a:t/>
-            </a:r>
-            <a:br>
-              <a:rPr dirty="0"/>
-            </a:br>
-            <a:r>
-              <a:rPr dirty="0"/>
+              <a:t>Nagenthiran Nagarajah</a:t>
+            </a:r>
+            <a:br/>
+            <a:r>
               <a:t>University of East Anglia</a:t>
             </a:r>
           </a:p>
@@ -4369,6 +4650,756 @@
     <p:extLst>
       <p:ext uri="{BB962C8B-B14F-4D97-AF65-F5344CB8AC3E}">
         <p14:creationId xmlns:p14="http://schemas.microsoft.com/office/powerpoint/2010/main" val="3093261743"/>
+      </p:ext>
+    </p:extLst>
+  </p:cSld>
+  <p:clrMapOvr>
+    <a:masterClrMapping/>
+  </p:clrMapOvr>
+</p:sld>
+</file>
+
+<file path=ppt/slides/slide10.xml><?xml version="1.0" encoding="utf-8"?>
+<p:sld xmlns:a="http://schemas.openxmlformats.org/drawingml/2006/main" xmlns:r="http://schemas.openxmlformats.org/officeDocument/2006/relationships" xmlns:p="http://schemas.openxmlformats.org/presentationml/2006/main">
+  <p:cSld>
+    <p:spTree>
+      <p:nvGrpSpPr>
+        <p:cNvPr id="1" name=""/>
+        <p:cNvGrpSpPr/>
+        <p:nvPr/>
+      </p:nvGrpSpPr>
+      <p:grpSpPr>
+        <a:xfrm>
+          <a:off x="0" y="0"/>
+          <a:ext cx="0" cy="0"/>
+          <a:chOff x="0" y="0"/>
+          <a:chExt cx="0" cy="0"/>
+        </a:xfrm>
+      </p:grpSpPr>
+      <p:sp>
+        <p:nvSpPr>
+          <p:cNvPr id="2" name="Title 1"/>
+          <p:cNvSpPr>
+            <a:spLocks noGrp="1"/>
+          </p:cNvSpPr>
+          <p:nvPr>
+            <p:ph type="title"/>
+          </p:nvPr>
+        </p:nvSpPr>
+        <p:spPr/>
+        <p:txBody>
+          <a:bodyPr/>
+          <a:lstStyle/>
+          <a:p>
+            <a:r>
+              <a:rPr lang="en-US" altLang="zh-TW" sz="2800" dirty="0"/>
+              <a:t>Progress Overview For The Last Week</a:t>
+            </a:r>
+            <a:endParaRPr lang="zh-TW" altLang="en-US" sz="2800" dirty="0"/>
+          </a:p>
+        </p:txBody>
+      </p:sp>
+      <p:sp>
+        <p:nvSpPr>
+          <p:cNvPr id="3" name="Content Placeholder 2"/>
+          <p:cNvSpPr>
+            <a:spLocks noGrp="1"/>
+          </p:cNvSpPr>
+          <p:nvPr>
+            <p:ph idx="1"/>
+          </p:nvPr>
+        </p:nvSpPr>
+        <p:spPr/>
+        <p:txBody>
+          <a:bodyPr/>
+          <a:lstStyle/>
+          <a:p>
+            <a:r>
+              <a:rPr lang="en-US" altLang="zh-TW" strike="sngStrike" dirty="0">
+                <a:solidFill>
+                  <a:schemeClr val="bg1">
+                    <a:lumMod val="65000"/>
+                  </a:schemeClr>
+                </a:solidFill>
+              </a:rPr>
+              <a:t>Task one  </a:t>
+            </a:r>
+          </a:p>
+          <a:p>
+            <a:pPr lvl="1"/>
+            <a:r>
+              <a:rPr lang="en-GB" altLang="zh-TW" dirty="0">
+                <a:solidFill>
+                  <a:srgbClr val="C00000"/>
+                </a:solidFill>
+              </a:rPr>
+              <a:t>In this slide, please use strike line and grey </a:t>
+            </a:r>
+            <a:r>
+              <a:rPr lang="en-GB" altLang="zh-TW" dirty="0" err="1">
+                <a:solidFill>
+                  <a:srgbClr val="C00000"/>
+                </a:solidFill>
+              </a:rPr>
+              <a:t>color</a:t>
+            </a:r>
+            <a:r>
+              <a:rPr lang="en-GB" altLang="zh-TW" dirty="0">
+                <a:solidFill>
+                  <a:srgbClr val="C00000"/>
+                </a:solidFill>
+              </a:rPr>
+              <a:t> to mark finished tasks</a:t>
+            </a:r>
+          </a:p>
+          <a:p>
+            <a:pPr lvl="1"/>
+            <a:r>
+              <a:rPr lang="en-US" altLang="zh-TW" strike="sngStrike" dirty="0">
+                <a:solidFill>
+                  <a:schemeClr val="bg1">
+                    <a:lumMod val="65000"/>
+                  </a:schemeClr>
+                </a:solidFill>
+              </a:rPr>
+              <a:t>Subtask 2</a:t>
+            </a:r>
+          </a:p>
+          <a:p>
+            <a:r>
+              <a:rPr lang="en-US" altLang="zh-TW" strike="sngStrike" dirty="0">
+                <a:solidFill>
+                  <a:schemeClr val="bg1">
+                    <a:lumMod val="65000"/>
+                  </a:schemeClr>
+                </a:solidFill>
+              </a:rPr>
+              <a:t>Task two</a:t>
+            </a:r>
+          </a:p>
+          <a:p>
+            <a:pPr lvl="1"/>
+            <a:r>
+              <a:rPr lang="en-US" altLang="zh-TW" strike="sngStrike" dirty="0">
+                <a:solidFill>
+                  <a:schemeClr val="bg1">
+                    <a:lumMod val="65000"/>
+                  </a:schemeClr>
+                </a:solidFill>
+              </a:rPr>
+              <a:t>Subtask 1</a:t>
+            </a:r>
+          </a:p>
+          <a:p>
+            <a:pPr lvl="1"/>
+            <a:r>
+              <a:rPr lang="en-US" altLang="zh-TW" dirty="0"/>
+              <a:t>Subtask 2</a:t>
+            </a:r>
+          </a:p>
+          <a:p>
+            <a:r>
+              <a:rPr lang="en-US" altLang="zh-TW" strike="sngStrike" dirty="0">
+                <a:solidFill>
+                  <a:schemeClr val="bg1">
+                    <a:lumMod val="65000"/>
+                  </a:schemeClr>
+                </a:solidFill>
+              </a:rPr>
+              <a:t>Task three</a:t>
+            </a:r>
+          </a:p>
+          <a:p>
+            <a:pPr lvl="1"/>
+            <a:r>
+              <a:rPr lang="en-US" altLang="zh-TW" strike="sngStrike" dirty="0">
+                <a:solidFill>
+                  <a:schemeClr val="bg1">
+                    <a:lumMod val="65000"/>
+                  </a:schemeClr>
+                </a:solidFill>
+              </a:rPr>
+              <a:t>Subtask 1</a:t>
+            </a:r>
+          </a:p>
+          <a:p>
+            <a:pPr lvl="1"/>
+            <a:r>
+              <a:rPr lang="en-US" altLang="zh-TW" strike="sngStrike" dirty="0">
+                <a:solidFill>
+                  <a:schemeClr val="bg1">
+                    <a:lumMod val="65000"/>
+                  </a:schemeClr>
+                </a:solidFill>
+              </a:rPr>
+              <a:t>Subtask 2</a:t>
+            </a:r>
+          </a:p>
+          <a:p>
+            <a:endParaRPr lang="zh-TW" altLang="en-US" dirty="0"/>
+          </a:p>
+        </p:txBody>
+      </p:sp>
+      <p:sp>
+        <p:nvSpPr>
+          <p:cNvPr id="4" name="Date Placeholder 3"/>
+          <p:cNvSpPr>
+            <a:spLocks noGrp="1"/>
+          </p:cNvSpPr>
+          <p:nvPr>
+            <p:ph type="dt" sz="half" idx="10"/>
+          </p:nvPr>
+        </p:nvSpPr>
+        <p:spPr/>
+        <p:txBody>
+          <a:bodyPr/>
+          <a:lstStyle/>
+          <a:p>
+            <a:pPr>
+              <a:defRPr/>
+            </a:pPr>
+            <a:fld id="{476C0DD9-7BCE-4413-BE54-9A75DE555C7B}" type="datetime1">
+              <a:rPr lang="en-US" altLang="zh-TW" smtClean="0"/>
+              <a:pPr>
+                <a:defRPr/>
+              </a:pPr>
+              <a:t>10/9/2025</a:t>
+            </a:fld>
+            <a:endParaRPr lang="zh-TW" altLang="en-US"/>
+          </a:p>
+        </p:txBody>
+      </p:sp>
+      <p:sp>
+        <p:nvSpPr>
+          <p:cNvPr id="5" name="Slide Number Placeholder 4"/>
+          <p:cNvSpPr>
+            <a:spLocks noGrp="1"/>
+          </p:cNvSpPr>
+          <p:nvPr>
+            <p:ph type="sldNum" sz="quarter" idx="12"/>
+          </p:nvPr>
+        </p:nvSpPr>
+        <p:spPr/>
+        <p:txBody>
+          <a:bodyPr/>
+          <a:lstStyle/>
+          <a:p>
+            <a:pPr>
+              <a:defRPr/>
+            </a:pPr>
+            <a:fld id="{8AF5A669-E021-420B-B33A-88CB5B8E39F6}" type="slidenum">
+              <a:rPr lang="zh-TW" altLang="en-US" smtClean="0"/>
+              <a:pPr>
+                <a:defRPr/>
+              </a:pPr>
+              <a:t>10</a:t>
+            </a:fld>
+            <a:endParaRPr lang="zh-TW" altLang="en-US"/>
+          </a:p>
+        </p:txBody>
+      </p:sp>
+    </p:spTree>
+    <p:extLst>
+      <p:ext uri="{BB962C8B-B14F-4D97-AF65-F5344CB8AC3E}">
+        <p14:creationId xmlns:p14="http://schemas.microsoft.com/office/powerpoint/2010/main" val="379363086"/>
+      </p:ext>
+    </p:extLst>
+  </p:cSld>
+  <p:clrMapOvr>
+    <a:masterClrMapping/>
+  </p:clrMapOvr>
+</p:sld>
+</file>
+
+<file path=ppt/slides/slide11.xml><?xml version="1.0" encoding="utf-8"?>
+<p:sld xmlns:a="http://schemas.openxmlformats.org/drawingml/2006/main" xmlns:r="http://schemas.openxmlformats.org/officeDocument/2006/relationships" xmlns:p="http://schemas.openxmlformats.org/presentationml/2006/main">
+  <p:cSld>
+    <p:spTree>
+      <p:nvGrpSpPr>
+        <p:cNvPr id="1" name=""/>
+        <p:cNvGrpSpPr/>
+        <p:nvPr/>
+      </p:nvGrpSpPr>
+      <p:grpSpPr>
+        <a:xfrm>
+          <a:off x="0" y="0"/>
+          <a:ext cx="0" cy="0"/>
+          <a:chOff x="0" y="0"/>
+          <a:chExt cx="0" cy="0"/>
+        </a:xfrm>
+      </p:grpSpPr>
+      <p:sp>
+        <p:nvSpPr>
+          <p:cNvPr id="2" name="Title 1"/>
+          <p:cNvSpPr>
+            <a:spLocks noGrp="1"/>
+          </p:cNvSpPr>
+          <p:nvPr>
+            <p:ph type="title"/>
+          </p:nvPr>
+        </p:nvSpPr>
+        <p:spPr/>
+        <p:txBody>
+          <a:bodyPr/>
+          <a:lstStyle/>
+          <a:p>
+            <a:r>
+              <a:rPr lang="en-US" altLang="zh-TW" dirty="0"/>
+              <a:t>Progress For The Last Week</a:t>
+            </a:r>
+            <a:endParaRPr lang="zh-TW" altLang="en-US" dirty="0"/>
+          </a:p>
+        </p:txBody>
+      </p:sp>
+      <p:sp>
+        <p:nvSpPr>
+          <p:cNvPr id="3" name="Content Placeholder 2"/>
+          <p:cNvSpPr>
+            <a:spLocks noGrp="1"/>
+          </p:cNvSpPr>
+          <p:nvPr>
+            <p:ph idx="1"/>
+          </p:nvPr>
+        </p:nvSpPr>
+        <p:spPr/>
+        <p:txBody>
+          <a:bodyPr/>
+          <a:lstStyle/>
+          <a:p>
+            <a:r>
+              <a:rPr lang="en-US" altLang="zh-TW" dirty="0"/>
+              <a:t>Task one…..</a:t>
+            </a:r>
+          </a:p>
+          <a:p>
+            <a:r>
+              <a:rPr lang="en-US" altLang="zh-TW" dirty="0">
+                <a:solidFill>
+                  <a:srgbClr val="C00000"/>
+                </a:solidFill>
+              </a:rPr>
+              <a:t>In this slide, please explain finished task one in detail.</a:t>
+            </a:r>
+            <a:endParaRPr lang="zh-TW" altLang="en-US" dirty="0">
+              <a:solidFill>
+                <a:srgbClr val="C00000"/>
+              </a:solidFill>
+            </a:endParaRPr>
+          </a:p>
+        </p:txBody>
+      </p:sp>
+      <p:sp>
+        <p:nvSpPr>
+          <p:cNvPr id="4" name="Date Placeholder 3"/>
+          <p:cNvSpPr>
+            <a:spLocks noGrp="1"/>
+          </p:cNvSpPr>
+          <p:nvPr>
+            <p:ph type="dt" sz="half" idx="10"/>
+          </p:nvPr>
+        </p:nvSpPr>
+        <p:spPr/>
+        <p:txBody>
+          <a:bodyPr/>
+          <a:lstStyle/>
+          <a:p>
+            <a:pPr>
+              <a:defRPr/>
+            </a:pPr>
+            <a:fld id="{476C0DD9-7BCE-4413-BE54-9A75DE555C7B}" type="datetime1">
+              <a:rPr lang="en-US" altLang="zh-TW" smtClean="0"/>
+              <a:pPr>
+                <a:defRPr/>
+              </a:pPr>
+              <a:t>10/9/2025</a:t>
+            </a:fld>
+            <a:endParaRPr lang="zh-TW" altLang="en-US"/>
+          </a:p>
+        </p:txBody>
+      </p:sp>
+      <p:sp>
+        <p:nvSpPr>
+          <p:cNvPr id="5" name="Slide Number Placeholder 4"/>
+          <p:cNvSpPr>
+            <a:spLocks noGrp="1"/>
+          </p:cNvSpPr>
+          <p:nvPr>
+            <p:ph type="sldNum" sz="quarter" idx="12"/>
+          </p:nvPr>
+        </p:nvSpPr>
+        <p:spPr/>
+        <p:txBody>
+          <a:bodyPr/>
+          <a:lstStyle/>
+          <a:p>
+            <a:pPr>
+              <a:defRPr/>
+            </a:pPr>
+            <a:fld id="{8AF5A669-E021-420B-B33A-88CB5B8E39F6}" type="slidenum">
+              <a:rPr lang="zh-TW" altLang="en-US" smtClean="0"/>
+              <a:pPr>
+                <a:defRPr/>
+              </a:pPr>
+              <a:t>11</a:t>
+            </a:fld>
+            <a:endParaRPr lang="zh-TW" altLang="en-US"/>
+          </a:p>
+        </p:txBody>
+      </p:sp>
+    </p:spTree>
+    <p:extLst>
+      <p:ext uri="{BB962C8B-B14F-4D97-AF65-F5344CB8AC3E}">
+        <p14:creationId xmlns:p14="http://schemas.microsoft.com/office/powerpoint/2010/main" val="3105693836"/>
+      </p:ext>
+    </p:extLst>
+  </p:cSld>
+  <p:clrMapOvr>
+    <a:masterClrMapping/>
+  </p:clrMapOvr>
+</p:sld>
+</file>
+
+<file path=ppt/slides/slide12.xml><?xml version="1.0" encoding="utf-8"?>
+<p:sld xmlns:a="http://schemas.openxmlformats.org/drawingml/2006/main" xmlns:r="http://schemas.openxmlformats.org/officeDocument/2006/relationships" xmlns:p="http://schemas.openxmlformats.org/presentationml/2006/main">
+  <p:cSld>
+    <p:spTree>
+      <p:nvGrpSpPr>
+        <p:cNvPr id="1" name=""/>
+        <p:cNvGrpSpPr/>
+        <p:nvPr/>
+      </p:nvGrpSpPr>
+      <p:grpSpPr>
+        <a:xfrm>
+          <a:off x="0" y="0"/>
+          <a:ext cx="0" cy="0"/>
+          <a:chOff x="0" y="0"/>
+          <a:chExt cx="0" cy="0"/>
+        </a:xfrm>
+      </p:grpSpPr>
+      <p:sp>
+        <p:nvSpPr>
+          <p:cNvPr id="2" name="Title 1"/>
+          <p:cNvSpPr>
+            <a:spLocks noGrp="1"/>
+          </p:cNvSpPr>
+          <p:nvPr>
+            <p:ph type="title"/>
+          </p:nvPr>
+        </p:nvSpPr>
+        <p:spPr/>
+        <p:txBody>
+          <a:bodyPr/>
+          <a:lstStyle/>
+          <a:p>
+            <a:r>
+              <a:rPr lang="en-US" altLang="zh-TW" sz="3200" dirty="0"/>
+              <a:t>Progress For The Last Week (cont.)</a:t>
+            </a:r>
+            <a:endParaRPr lang="zh-TW" altLang="en-US" dirty="0"/>
+          </a:p>
+        </p:txBody>
+      </p:sp>
+      <p:sp>
+        <p:nvSpPr>
+          <p:cNvPr id="3" name="Content Placeholder 2"/>
+          <p:cNvSpPr>
+            <a:spLocks noGrp="1"/>
+          </p:cNvSpPr>
+          <p:nvPr>
+            <p:ph idx="1"/>
+          </p:nvPr>
+        </p:nvSpPr>
+        <p:spPr/>
+        <p:txBody>
+          <a:bodyPr/>
+          <a:lstStyle/>
+          <a:p>
+            <a:r>
+              <a:rPr lang="en-US" altLang="zh-TW" dirty="0"/>
+              <a:t>Task two…</a:t>
+            </a:r>
+          </a:p>
+          <a:p>
+            <a:r>
+              <a:rPr lang="en-GB" altLang="zh-TW" dirty="0">
+                <a:solidFill>
+                  <a:srgbClr val="C00000"/>
+                </a:solidFill>
+              </a:rPr>
+              <a:t>In this slide, please explain finished task two in detail.</a:t>
+            </a:r>
+            <a:endParaRPr lang="zh-TW" altLang="en-US" dirty="0">
+              <a:solidFill>
+                <a:srgbClr val="C00000"/>
+              </a:solidFill>
+            </a:endParaRPr>
+          </a:p>
+        </p:txBody>
+      </p:sp>
+      <p:sp>
+        <p:nvSpPr>
+          <p:cNvPr id="4" name="Date Placeholder 3"/>
+          <p:cNvSpPr>
+            <a:spLocks noGrp="1"/>
+          </p:cNvSpPr>
+          <p:nvPr>
+            <p:ph type="dt" sz="half" idx="10"/>
+          </p:nvPr>
+        </p:nvSpPr>
+        <p:spPr/>
+        <p:txBody>
+          <a:bodyPr/>
+          <a:lstStyle/>
+          <a:p>
+            <a:pPr>
+              <a:defRPr/>
+            </a:pPr>
+            <a:fld id="{476C0DD9-7BCE-4413-BE54-9A75DE555C7B}" type="datetime1">
+              <a:rPr lang="en-US" altLang="zh-TW" smtClean="0"/>
+              <a:pPr>
+                <a:defRPr/>
+              </a:pPr>
+              <a:t>10/9/2025</a:t>
+            </a:fld>
+            <a:endParaRPr lang="zh-TW" altLang="en-US"/>
+          </a:p>
+        </p:txBody>
+      </p:sp>
+      <p:sp>
+        <p:nvSpPr>
+          <p:cNvPr id="5" name="Slide Number Placeholder 4"/>
+          <p:cNvSpPr>
+            <a:spLocks noGrp="1"/>
+          </p:cNvSpPr>
+          <p:nvPr>
+            <p:ph type="sldNum" sz="quarter" idx="12"/>
+          </p:nvPr>
+        </p:nvSpPr>
+        <p:spPr/>
+        <p:txBody>
+          <a:bodyPr/>
+          <a:lstStyle/>
+          <a:p>
+            <a:pPr>
+              <a:defRPr/>
+            </a:pPr>
+            <a:fld id="{8AF5A669-E021-420B-B33A-88CB5B8E39F6}" type="slidenum">
+              <a:rPr lang="zh-TW" altLang="en-US" smtClean="0"/>
+              <a:pPr>
+                <a:defRPr/>
+              </a:pPr>
+              <a:t>12</a:t>
+            </a:fld>
+            <a:endParaRPr lang="zh-TW" altLang="en-US"/>
+          </a:p>
+        </p:txBody>
+      </p:sp>
+    </p:spTree>
+    <p:extLst>
+      <p:ext uri="{BB962C8B-B14F-4D97-AF65-F5344CB8AC3E}">
+        <p14:creationId xmlns:p14="http://schemas.microsoft.com/office/powerpoint/2010/main" val="312794099"/>
+      </p:ext>
+    </p:extLst>
+  </p:cSld>
+  <p:clrMapOvr>
+    <a:masterClrMapping/>
+  </p:clrMapOvr>
+</p:sld>
+</file>
+
+<file path=ppt/slides/slide13.xml><?xml version="1.0" encoding="utf-8"?>
+<p:sld xmlns:a="http://schemas.openxmlformats.org/drawingml/2006/main" xmlns:r="http://schemas.openxmlformats.org/officeDocument/2006/relationships" xmlns:p="http://schemas.openxmlformats.org/presentationml/2006/main">
+  <p:cSld>
+    <p:spTree>
+      <p:nvGrpSpPr>
+        <p:cNvPr id="1" name=""/>
+        <p:cNvGrpSpPr/>
+        <p:nvPr/>
+      </p:nvGrpSpPr>
+      <p:grpSpPr>
+        <a:xfrm>
+          <a:off x="0" y="0"/>
+          <a:ext cx="0" cy="0"/>
+          <a:chOff x="0" y="0"/>
+          <a:chExt cx="0" cy="0"/>
+        </a:xfrm>
+      </p:grpSpPr>
+      <p:sp>
+        <p:nvSpPr>
+          <p:cNvPr id="2" name="Title 1"/>
+          <p:cNvSpPr>
+            <a:spLocks noGrp="1"/>
+          </p:cNvSpPr>
+          <p:nvPr>
+            <p:ph type="title"/>
+          </p:nvPr>
+        </p:nvSpPr>
+        <p:spPr/>
+        <p:txBody>
+          <a:bodyPr/>
+          <a:lstStyle/>
+          <a:p>
+            <a:r>
+              <a:rPr lang="en-US" altLang="zh-TW" dirty="0"/>
+              <a:t>Actions for the Next Week</a:t>
+            </a:r>
+            <a:endParaRPr lang="zh-TW" altLang="en-US" dirty="0"/>
+          </a:p>
+        </p:txBody>
+      </p:sp>
+      <p:sp>
+        <p:nvSpPr>
+          <p:cNvPr id="3" name="Content Placeholder 2"/>
+          <p:cNvSpPr>
+            <a:spLocks noGrp="1"/>
+          </p:cNvSpPr>
+          <p:nvPr>
+            <p:ph idx="1"/>
+          </p:nvPr>
+        </p:nvSpPr>
+        <p:spPr/>
+        <p:txBody>
+          <a:bodyPr/>
+          <a:lstStyle/>
+          <a:p>
+            <a:r>
+              <a:rPr lang="en-US" altLang="zh-TW" dirty="0"/>
+              <a:t>Milestones</a:t>
+            </a:r>
+          </a:p>
+          <a:p>
+            <a:pPr lvl="1"/>
+            <a:r>
+              <a:rPr lang="en-US" altLang="zh-TW" dirty="0"/>
+              <a:t>Proposal?</a:t>
+            </a:r>
+          </a:p>
+          <a:p>
+            <a:pPr lvl="1"/>
+            <a:r>
+              <a:rPr lang="en-US" altLang="zh-TW" dirty="0"/>
+              <a:t>Progress report?</a:t>
+            </a:r>
+          </a:p>
+          <a:p>
+            <a:pPr lvl="1"/>
+            <a:r>
+              <a:rPr lang="en-US" altLang="zh-TW" dirty="0"/>
+              <a:t>Project Inspection/report submission?</a:t>
+            </a:r>
+          </a:p>
+          <a:p>
+            <a:r>
+              <a:rPr lang="en-US" altLang="zh-TW" dirty="0"/>
+              <a:t>Regular meetings with Eden (Edwin joins once per two weeks)</a:t>
+            </a:r>
+          </a:p>
+          <a:p>
+            <a:pPr lvl="1"/>
+            <a:r>
+              <a:rPr lang="en-US" altLang="zh-TW" dirty="0"/>
+              <a:t>4pm Thursday</a:t>
+            </a:r>
+          </a:p>
+          <a:p>
+            <a:r>
+              <a:rPr lang="en-US" altLang="zh-TW" dirty="0"/>
+              <a:t>Use the progress report template</a:t>
+            </a:r>
+          </a:p>
+          <a:p>
+            <a:r>
+              <a:rPr lang="en-US" altLang="zh-TW" dirty="0"/>
+              <a:t>Spend some time to know the project</a:t>
+            </a:r>
+          </a:p>
+          <a:p>
+            <a:r>
+              <a:rPr lang="en-US" altLang="zh-TW" dirty="0"/>
+              <a:t>Eden share the zip file to Max and Richard</a:t>
+            </a:r>
+          </a:p>
+          <a:p>
+            <a:r>
+              <a:rPr lang="en-US" altLang="zh-TW" dirty="0"/>
+              <a:t>Send GitHub account to Eden</a:t>
+            </a:r>
+          </a:p>
+          <a:p>
+            <a:pPr lvl="1"/>
+            <a:r>
+              <a:rPr lang="en-US" altLang="zh-TW" dirty="0"/>
+              <a:t>Eden shares GitHub to them</a:t>
+            </a:r>
+          </a:p>
+          <a:p>
+            <a:pPr lvl="1"/>
+            <a:endParaRPr lang="en-US" altLang="zh-TW" dirty="0"/>
+          </a:p>
+        </p:txBody>
+      </p:sp>
+      <p:sp>
+        <p:nvSpPr>
+          <p:cNvPr id="4" name="Date Placeholder 3"/>
+          <p:cNvSpPr>
+            <a:spLocks noGrp="1"/>
+          </p:cNvSpPr>
+          <p:nvPr>
+            <p:ph type="dt" sz="half" idx="10"/>
+          </p:nvPr>
+        </p:nvSpPr>
+        <p:spPr/>
+        <p:txBody>
+          <a:bodyPr/>
+          <a:lstStyle/>
+          <a:p>
+            <a:pPr>
+              <a:defRPr/>
+            </a:pPr>
+            <a:fld id="{476C0DD9-7BCE-4413-BE54-9A75DE555C7B}" type="datetime1">
+              <a:rPr lang="en-US" altLang="zh-TW" smtClean="0"/>
+              <a:pPr>
+                <a:defRPr/>
+              </a:pPr>
+              <a:t>10/9/2025</a:t>
+            </a:fld>
+            <a:endParaRPr lang="zh-TW" altLang="en-US"/>
+          </a:p>
+        </p:txBody>
+      </p:sp>
+      <p:sp>
+        <p:nvSpPr>
+          <p:cNvPr id="5" name="Slide Number Placeholder 4"/>
+          <p:cNvSpPr>
+            <a:spLocks noGrp="1"/>
+          </p:cNvSpPr>
+          <p:nvPr>
+            <p:ph type="sldNum" sz="quarter" idx="12"/>
+          </p:nvPr>
+        </p:nvSpPr>
+        <p:spPr/>
+        <p:txBody>
+          <a:bodyPr/>
+          <a:lstStyle/>
+          <a:p>
+            <a:pPr>
+              <a:defRPr/>
+            </a:pPr>
+            <a:fld id="{8AF5A669-E021-420B-B33A-88CB5B8E39F6}" type="slidenum">
+              <a:rPr lang="zh-TW" altLang="en-US" smtClean="0"/>
+              <a:pPr>
+                <a:defRPr/>
+              </a:pPr>
+              <a:t>13</a:t>
+            </a:fld>
+            <a:endParaRPr lang="zh-TW" altLang="en-US" dirty="0"/>
+          </a:p>
+        </p:txBody>
+      </p:sp>
+    </p:spTree>
+    <p:extLst>
+      <p:ext uri="{BB962C8B-B14F-4D97-AF65-F5344CB8AC3E}">
+        <p14:creationId xmlns:p14="http://schemas.microsoft.com/office/powerpoint/2010/main" val="3853517451"/>
       </p:ext>
     </p:extLst>
   </p:cSld>
@@ -4432,32 +5463,37 @@
           <a:bodyPr/>
           <a:lstStyle/>
           <a:p>
-            <a:r>
-              <a:rPr sz="1400" b="0" i="0"/>
+            <a:pPr/>
+            <a:r>
+              <a:rPr b="0" i="0" sz="1400"/>
               <a:t>Helps users discover restaurants near their current location</a:t>
             </a:r>
           </a:p>
           <a:p>
-            <a:r>
-              <a:rPr sz="1400" b="0" i="0"/>
+            <a:pPr/>
+            <a:r>
+              <a:rPr b="0" i="0" sz="1400"/>
               <a:t>Shows each restaurant's name, rating, distance, and cuisine type</a:t>
             </a:r>
           </a:p>
           <a:p>
-            <a:r>
-              <a:rPr sz="1400" b="0" i="0"/>
+            <a:pPr/>
+            <a:r>
+              <a:rPr b="0" i="0" sz="1400"/>
               <a:t>Lets users watch a real video preview (YouTube or TikTok) before visiting</a:t>
             </a:r>
           </a:p>
           <a:p>
-            <a:r>
-              <a:rPr sz="1400" b="0" i="0"/>
+            <a:pPr/>
+            <a:r>
+              <a:rPr b="0" i="0" sz="1400"/>
               <a:t>Gives instant turn-by-turn directions to the restaurant</a:t>
             </a:r>
           </a:p>
           <a:p>
-            <a:r>
-              <a:rPr sz="1400" b="0" i="0"/>
+            <a:pPr/>
+            <a:r>
+              <a:rPr b="0" i="0" sz="1400"/>
               <a:t>Built as a modern Android app using Kotlin and Jetpack Compose</a:t>
             </a:r>
           </a:p>
@@ -4477,9 +5513,7 @@
         <p:txBody>
           <a:bodyPr/>
           <a:lstStyle/>
-          <a:p>
-            <a:endParaRPr/>
-          </a:p>
+          <a:p/>
         </p:txBody>
       </p:sp>
       <p:sp>
@@ -4557,7 +5591,6 @@
           <a:lstStyle/>
           <a:p>
             <a:r>
-              <a:rPr dirty="0"/>
               <a:t>All App Screens</a:t>
             </a:r>
             <a:endParaRPr lang="zh-TW" altLang="en-US" sz="2800" dirty="0"/>
@@ -4580,7 +5613,7 @@
           <a:lstStyle/>
           <a:p>
             <a:r>
-              <a:rPr sz="1100" i="1"/>
+              <a:rPr i="1" sz="1100"/>
               <a:t>Every screen has been designed and built to match a simple, easy-to-follow flow.</a:t>
             </a:r>
           </a:p>
@@ -4600,9 +5633,7 @@
         <p:txBody>
           <a:bodyPr/>
           <a:lstStyle/>
-          <a:p>
-            <a:endParaRPr/>
-          </a:p>
+          <a:p/>
         </p:txBody>
       </p:sp>
       <p:sp>
@@ -4643,7 +5674,7 @@
           <p:nvPr/>
         </p:nvPicPr>
         <p:blipFill>
-          <a:blip r:embed="rId3"/>
+          <a:blip r:embed="rId2"/>
           <a:stretch>
             <a:fillRect/>
           </a:stretch>
@@ -4667,7 +5698,7 @@
           <p:nvPr/>
         </p:nvPicPr>
         <p:blipFill>
-          <a:blip r:embed="rId4"/>
+          <a:blip r:embed="rId3"/>
           <a:stretch>
             <a:fillRect/>
           </a:stretch>
@@ -4691,7 +5722,7 @@
           <p:nvPr/>
         </p:nvPicPr>
         <p:blipFill>
-          <a:blip r:embed="rId5"/>
+          <a:blip r:embed="rId4"/>
           <a:stretch>
             <a:fillRect/>
           </a:stretch>
@@ -4715,7 +5746,7 @@
           <p:nvPr/>
         </p:nvPicPr>
         <p:blipFill>
-          <a:blip r:embed="rId6"/>
+          <a:blip r:embed="rId5"/>
           <a:stretch>
             <a:fillRect/>
           </a:stretch>
@@ -4739,7 +5770,7 @@
           <p:nvPr/>
         </p:nvPicPr>
         <p:blipFill>
-          <a:blip r:embed="rId7"/>
+          <a:blip r:embed="rId6"/>
           <a:stretch>
             <a:fillRect/>
           </a:stretch>
@@ -4763,7 +5794,7 @@
           <p:nvPr/>
         </p:nvPicPr>
         <p:blipFill>
-          <a:blip r:embed="rId8"/>
+          <a:blip r:embed="rId7"/>
           <a:stretch>
             <a:fillRect/>
           </a:stretch>
@@ -4787,7 +5818,7 @@
           <p:nvPr/>
         </p:nvPicPr>
         <p:blipFill>
-          <a:blip r:embed="rId9"/>
+          <a:blip r:embed="rId8"/>
           <a:stretch>
             <a:fillRect/>
           </a:stretch>
@@ -4811,7 +5842,7 @@
           <p:nvPr/>
         </p:nvPicPr>
         <p:blipFill>
-          <a:blip r:embed="rId10"/>
+          <a:blip r:embed="rId9"/>
           <a:stretch>
             <a:fillRect/>
           </a:stretch>
@@ -4835,7 +5866,7 @@
           <p:nvPr/>
         </p:nvPicPr>
         <p:blipFill>
-          <a:blip r:embed="rId11"/>
+          <a:blip r:embed="rId10"/>
           <a:stretch>
             <a:fillRect/>
           </a:stretch>
@@ -4859,7 +5890,7 @@
           <p:nvPr/>
         </p:nvPicPr>
         <p:blipFill>
-          <a:blip r:embed="rId12"/>
+          <a:blip r:embed="rId11"/>
           <a:stretch>
             <a:fillRect/>
           </a:stretch>
@@ -4883,7 +5914,7 @@
           <p:nvPr/>
         </p:nvPicPr>
         <p:blipFill>
-          <a:blip r:embed="rId13"/>
+          <a:blip r:embed="rId12"/>
           <a:stretch>
             <a:fillRect/>
           </a:stretch>
@@ -4965,44 +5996,51 @@
           <a:bodyPr/>
           <a:lstStyle/>
           <a:p>
-            <a:r>
-              <a:rPr sz="1300" b="0" i="0"/>
+            <a:pPr/>
+            <a:r>
+              <a:rPr b="0" i="0" sz="1300"/>
               <a:t>Splash Screen — a quick loading screen when the app opens</a:t>
             </a:r>
           </a:p>
           <a:p>
-            <a:r>
-              <a:rPr sz="1300" b="0" i="0"/>
+            <a:pPr/>
+            <a:r>
+              <a:rPr b="0" i="0" sz="1300"/>
               <a:t>Login or Register — sign in, create an account, or continue as a guest</a:t>
             </a:r>
           </a:p>
           <a:p>
-            <a:r>
-              <a:rPr sz="1300" b="0" i="0"/>
+            <a:pPr/>
+            <a:r>
+              <a:rPr b="0" i="0" sz="1300"/>
               <a:t>Home Page — search bar and quick access to nearby restaurants</a:t>
             </a:r>
           </a:p>
           <a:p>
-            <a:r>
-              <a:rPr sz="1300" b="0" i="0"/>
+            <a:pPr/>
+            <a:r>
+              <a:rPr b="0" i="0" sz="1300"/>
               <a:t>Map Screen — restaurants shown near the user's real location</a:t>
             </a:r>
           </a:p>
           <a:p>
-            <a:r>
-              <a:rPr sz="1300" b="0" i="0"/>
+            <a:pPr/>
+            <a:r>
+              <a:rPr b="0" i="0" sz="1300"/>
               <a:t>Restaurant Detail — name, rating, distance, and cuisine type</a:t>
             </a:r>
           </a:p>
           <a:p>
-            <a:r>
-              <a:rPr sz="1300" b="0" i="0"/>
+            <a:pPr/>
+            <a:r>
+              <a:rPr b="0" i="0" sz="1300"/>
               <a:t>Watch Video — a real preview video of the restaurant</a:t>
             </a:r>
           </a:p>
           <a:p>
-            <a:r>
-              <a:rPr sz="1300" b="0" i="0"/>
+            <a:pPr/>
+            <a:r>
+              <a:rPr b="0" i="0" sz="1300"/>
               <a:t>Directions — step-by-step navigation to the restaurant</a:t>
             </a:r>
           </a:p>
@@ -5022,9 +6060,7 @@
         <p:txBody>
           <a:bodyPr/>
           <a:lstStyle/>
-          <a:p>
-            <a:endParaRPr/>
-          </a:p>
+          <a:p/>
         </p:txBody>
       </p:sp>
       <p:sp>
@@ -5123,80 +6159,86 @@
           <a:bodyPr/>
           <a:lstStyle/>
           <a:p>
-            <a:r>
-              <a:rPr sz="1300" b="1" i="0"/>
+            <a:pPr/>
+            <a:r>
+              <a:rPr b="1" i="0" sz="1300"/>
               <a:t>Real GPS Location</a:t>
             </a:r>
           </a:p>
           <a:p>
             <a:pPr lvl="1"/>
             <a:r>
-              <a:rPr sz="1100" b="0" i="0"/>
+              <a:rPr b="0" i="0" sz="1100"/>
               <a:t>Finds restaurants near the user's actual position, not a fixed test location</a:t>
             </a:r>
           </a:p>
           <a:p>
-            <a:r>
-              <a:rPr sz="1300" b="1" i="0"/>
+            <a:pPr/>
+            <a:r>
+              <a:rPr b="1" i="0" sz="1300"/>
               <a:t>Live Google Map</a:t>
             </a:r>
           </a:p>
           <a:p>
             <a:pPr lvl="1"/>
             <a:r>
-              <a:rPr sz="1100" b="0" i="0"/>
+              <a:rPr b="0" i="0" sz="1100"/>
               <a:t>An interactive map with a real marker for every restaurant</a:t>
             </a:r>
           </a:p>
           <a:p>
-            <a:r>
-              <a:rPr sz="1300" b="1" i="0"/>
+            <a:pPr/>
+            <a:r>
+              <a:rPr b="1" i="0" sz="1300"/>
               <a:t>Account System</a:t>
             </a:r>
           </a:p>
           <a:p>
             <a:pPr lvl="1"/>
             <a:r>
-              <a:rPr sz="1100" b="0" i="0"/>
+              <a:rPr b="0" i="0" sz="1100"/>
               <a:t>Secure login and registration, tested on a real phone</a:t>
             </a:r>
           </a:p>
           <a:p>
-            <a:r>
-              <a:rPr sz="1300" b="1" i="0"/>
+            <a:pPr/>
+            <a:r>
+              <a:rPr b="1" i="0" sz="1300"/>
               <a:t>Screen Navigation</a:t>
             </a:r>
           </a:p>
           <a:p>
             <a:pPr lvl="1"/>
             <a:r>
-              <a:rPr sz="1100" b="0" i="0"/>
+              <a:rPr b="0" i="0" sz="1100"/>
               <a:t>Smooth movement between every screen, including a working back button</a:t>
             </a:r>
           </a:p>
           <a:p>
-            <a:r>
-              <a:rPr sz="1300" b="1" i="0"/>
+            <a:pPr/>
+            <a:r>
+              <a:rPr b="1" i="0" sz="1300"/>
               <a:t>Opens Other Apps</a:t>
             </a:r>
           </a:p>
           <a:p>
             <a:pPr lvl="1"/>
             <a:r>
-              <a:rPr sz="1100" b="0" i="0"/>
+              <a:rPr b="0" i="0" sz="1100"/>
               <a:t>The video button opens YouTube or TikTok, and directions open Google Maps</a:t>
             </a:r>
           </a:p>
           <a:p>
-            <a:r>
-              <a:rPr sz="1300" b="1" i="0"/>
+            <a:pPr/>
+            <a:r>
+              <a:rPr b="1" i="0" sz="1300"/>
               <a:t>Smart Search</a:t>
             </a:r>
           </a:p>
           <a:p>
             <a:pPr lvl="1"/>
             <a:r>
-              <a:rPr sz="1100" b="0" i="0"/>
+              <a:rPr b="0" i="0" sz="1100"/>
               <a:t>Typing in the search bar instantly filters which restaurants are shown</a:t>
             </a:r>
           </a:p>
@@ -5216,9 +6258,7 @@
         <p:txBody>
           <a:bodyPr/>
           <a:lstStyle/>
-          <a:p>
-            <a:endParaRPr/>
-          </a:p>
+          <a:p/>
         </p:txBody>
       </p:sp>
       <p:sp>
@@ -5317,32 +6357,37 @@
           <a:bodyPr/>
           <a:lstStyle/>
           <a:p>
-            <a:r>
-              <a:rPr sz="1400" b="0" i="0"/>
+            <a:pPr/>
+            <a:r>
+              <a:rPr b="0" i="0" sz="1400"/>
               <a:t>Users can register a new account or log in with an existing one</a:t>
             </a:r>
           </a:p>
           <a:p>
-            <a:r>
-              <a:rPr sz="1400" b="0" i="0"/>
+            <a:pPr/>
+            <a:r>
+              <a:rPr b="0" i="0" sz="1400"/>
               <a:t>Accounts are stored securely, not just kept on the phone</a:t>
             </a:r>
           </a:p>
           <a:p>
-            <a:r>
-              <a:rPr sz="1400" b="0" i="0"/>
+            <a:pPr/>
+            <a:r>
+              <a:rPr b="0" i="0" sz="1400"/>
               <a:t>Users can also continue as a guest without creating an account</a:t>
             </a:r>
           </a:p>
           <a:p>
-            <a:r>
-              <a:rPr sz="1400" b="0" i="0"/>
+            <a:pPr/>
+            <a:r>
+              <a:rPr b="0" i="0" sz="1400"/>
               <a:t>The map and restaurant features only unlock once a user is signed in</a:t>
             </a:r>
           </a:p>
           <a:p>
-            <a:r>
-              <a:rPr sz="1400" b="0" i="0"/>
+            <a:pPr/>
+            <a:r>
+              <a:rPr b="0" i="0" sz="1400"/>
               <a:t>Tested end-to-end on a real Android phone</a:t>
             </a:r>
           </a:p>
@@ -5362,9 +6407,7 @@
         <p:txBody>
           <a:bodyPr/>
           <a:lstStyle/>
-          <a:p>
-            <a:endParaRPr/>
-          </a:p>
+          <a:p/>
         </p:txBody>
       </p:sp>
       <p:sp>
@@ -5417,7 +6460,7 @@
         <p:cNvPr id="1" name="">
           <a:extLst>
             <a:ext uri="{FF2B5EF4-FFF2-40B4-BE49-F238E27FC236}">
-              <a16:creationId xmlns:a16="http://schemas.microsoft.com/office/drawing/2014/main" xmlns="" id="{9DCAAF8A-320C-4F88-CEAA-80EA17C59917}"/>
+              <a16:creationId xmlns:a16="http://schemas.microsoft.com/office/drawing/2014/main" id="{9DCAAF8A-320C-4F88-CEAA-80EA17C59917}"/>
             </a:ext>
           </a:extLst>
         </p:cNvPr>
@@ -5437,7 +6480,7 @@
           <p:cNvPr id="2" name="Title 1">
             <a:extLst>
               <a:ext uri="{FF2B5EF4-FFF2-40B4-BE49-F238E27FC236}">
-                <a16:creationId xmlns:a16="http://schemas.microsoft.com/office/drawing/2014/main" xmlns="" id="{1CF74DC2-AAF4-9A34-C6C0-D92F4C4BBF71}"/>
+                <a16:creationId xmlns:a16="http://schemas.microsoft.com/office/drawing/2014/main" id="{1CF74DC2-AAF4-9A34-C6C0-D92F4C4BBF71}"/>
               </a:ext>
             </a:extLst>
           </p:cNvPr>
@@ -5465,7 +6508,7 @@
           <p:cNvPr id="3" name="Content Placeholder 2">
             <a:extLst>
               <a:ext uri="{FF2B5EF4-FFF2-40B4-BE49-F238E27FC236}">
-                <a16:creationId xmlns:a16="http://schemas.microsoft.com/office/drawing/2014/main" xmlns="" id="{9832DCBD-57EA-B27E-9539-004208707827}"/>
+                <a16:creationId xmlns:a16="http://schemas.microsoft.com/office/drawing/2014/main" id="{9832DCBD-57EA-B27E-9539-004208707827}"/>
               </a:ext>
             </a:extLst>
           </p:cNvPr>
@@ -5481,32 +6524,37 @@
           <a:bodyPr/>
           <a:lstStyle/>
           <a:p>
-            <a:r>
-              <a:rPr sz="1400" b="0" i="0"/>
+            <a:pPr/>
+            <a:r>
+              <a:rPr b="0" i="0" sz="1400"/>
               <a:t>All app screens are designed and fully working</a:t>
             </a:r>
           </a:p>
           <a:p>
-            <a:r>
-              <a:rPr sz="1400" b="0" i="0"/>
+            <a:pPr/>
+            <a:r>
+              <a:rPr b="0" i="0" sz="1400"/>
               <a:t>A real login and account system is in place and tested</a:t>
             </a:r>
           </a:p>
           <a:p>
-            <a:r>
-              <a:rPr sz="1400" b="0" i="0"/>
+            <a:pPr/>
+            <a:r>
+              <a:rPr b="0" i="0" sz="1400"/>
               <a:t>The map shows restaurants using the user's real location</a:t>
             </a:r>
           </a:p>
           <a:p>
-            <a:r>
-              <a:rPr sz="1400" b="0" i="0"/>
+            <a:pPr/>
+            <a:r>
+              <a:rPr b="0" i="0" sz="1400"/>
               <a:t>Users can preview restaurants with real videos before visiting</a:t>
             </a:r>
           </a:p>
           <a:p>
-            <a:r>
-              <a:rPr sz="1400" b="0" i="0"/>
+            <a:pPr/>
+            <a:r>
+              <a:rPr b="0" i="0" sz="1400"/>
               <a:t>One tap gives directions straight to the restaurant</a:t>
             </a:r>
           </a:p>
@@ -5517,7 +6565,7 @@
           <p:cNvPr id="4" name="Date Placeholder 3">
             <a:extLst>
               <a:ext uri="{FF2B5EF4-FFF2-40B4-BE49-F238E27FC236}">
-                <a16:creationId xmlns:a16="http://schemas.microsoft.com/office/drawing/2014/main" xmlns="" id="{ADD7124F-9A31-F596-A902-B9AC5F0935DA}"/>
+                <a16:creationId xmlns:a16="http://schemas.microsoft.com/office/drawing/2014/main" id="{ADD7124F-9A31-F596-A902-B9AC5F0935DA}"/>
               </a:ext>
             </a:extLst>
           </p:cNvPr>
@@ -5532,9 +6580,7 @@
         <p:txBody>
           <a:bodyPr/>
           <a:lstStyle/>
-          <a:p>
-            <a:endParaRPr/>
-          </a:p>
+          <a:p/>
         </p:txBody>
       </p:sp>
       <p:sp>
@@ -5542,7 +6588,7 @@
           <p:cNvPr id="5" name="Slide Number Placeholder 4">
             <a:extLst>
               <a:ext uri="{FF2B5EF4-FFF2-40B4-BE49-F238E27FC236}">
-                <a16:creationId xmlns:a16="http://schemas.microsoft.com/office/drawing/2014/main" xmlns="" id="{3D2EA6C1-1DE3-2059-68F9-EB41166475C9}"/>
+                <a16:creationId xmlns:a16="http://schemas.microsoft.com/office/drawing/2014/main" id="{3D2EA6C1-1DE3-2059-68F9-EB41166475C9}"/>
               </a:ext>
             </a:extLst>
           </p:cNvPr>
@@ -5576,6 +6622,598 @@
     <p:extLst>
       <p:ext uri="{BB962C8B-B14F-4D97-AF65-F5344CB8AC3E}">
         <p14:creationId xmlns:p14="http://schemas.microsoft.com/office/powerpoint/2010/main" val="1871137901"/>
+      </p:ext>
+    </p:extLst>
+  </p:cSld>
+  <p:clrMapOvr>
+    <a:masterClrMapping/>
+  </p:clrMapOvr>
+</p:sld>
+</file>
+
+<file path=ppt/slides/slide8.xml><?xml version="1.0" encoding="utf-8"?>
+<p:sld xmlns:a="http://schemas.openxmlformats.org/drawingml/2006/main" xmlns:r="http://schemas.openxmlformats.org/officeDocument/2006/relationships" xmlns:p="http://schemas.openxmlformats.org/presentationml/2006/main">
+  <p:cSld>
+    <p:spTree>
+      <p:nvGrpSpPr>
+        <p:cNvPr id="1" name=""/>
+        <p:cNvGrpSpPr/>
+        <p:nvPr/>
+      </p:nvGrpSpPr>
+      <p:grpSpPr>
+        <a:xfrm>
+          <a:off x="0" y="0"/>
+          <a:ext cx="0" cy="0"/>
+          <a:chOff x="0" y="0"/>
+          <a:chExt cx="0" cy="0"/>
+        </a:xfrm>
+      </p:grpSpPr>
+      <p:sp>
+        <p:nvSpPr>
+          <p:cNvPr id="2050" name="Date Placeholder 3"/>
+          <p:cNvSpPr>
+            <a:spLocks noGrp="1"/>
+          </p:cNvSpPr>
+          <p:nvPr>
+            <p:ph type="dt" sz="quarter" idx="4294967295"/>
+          </p:nvPr>
+        </p:nvSpPr>
+        <p:spPr>
+          <a:noFill/>
+          <a:ln/>
+          <a:extLst>
+            <a:ext uri="{909E8E84-426E-40DD-AFC4-6F175D3DCCD1}">
+              <a14:hiddenFill xmlns:a14="http://schemas.microsoft.com/office/drawing/2010/main">
+                <a:solidFill>
+                  <a:srgbClr val="FFFFFF"/>
+                </a:solidFill>
+              </a14:hiddenFill>
+            </a:ext>
+            <a:ext uri="{91240B29-F687-4F45-9708-019B960494DF}">
+              <a14:hiddenLine xmlns:a14="http://schemas.microsoft.com/office/drawing/2010/main" w="9525">
+                <a:solidFill>
+                  <a:srgbClr val="000000"/>
+                </a:solidFill>
+                <a:miter lim="800000"/>
+                <a:headEnd/>
+                <a:tailEnd/>
+              </a14:hiddenLine>
+            </a:ext>
+          </a:extLst>
+        </p:spPr>
+        <p:txBody>
+          <a:bodyPr/>
+          <a:lstStyle>
+            <a:lvl1pPr eaLnBrk="0" hangingPunct="0">
+              <a:defRPr sz="2400">
+                <a:solidFill>
+                  <a:schemeClr val="bg1"/>
+                </a:solidFill>
+                <a:latin typeface="Comic Sans MS" panose="030F0702030302020204" pitchFamily="66" charset="0"/>
+                <a:cs typeface="Arial" panose="020B0604020202020204" pitchFamily="34" charset="0"/>
+              </a:defRPr>
+            </a:lvl1pPr>
+            <a:lvl2pPr marL="742950" indent="-285750" eaLnBrk="0" hangingPunct="0">
+              <a:defRPr sz="2400">
+                <a:solidFill>
+                  <a:schemeClr val="bg1"/>
+                </a:solidFill>
+                <a:latin typeface="Comic Sans MS" panose="030F0702030302020204" pitchFamily="66" charset="0"/>
+                <a:cs typeface="Arial" panose="020B0604020202020204" pitchFamily="34" charset="0"/>
+              </a:defRPr>
+            </a:lvl2pPr>
+            <a:lvl3pPr marL="1143000" indent="-228600" eaLnBrk="0" hangingPunct="0">
+              <a:defRPr sz="2400">
+                <a:solidFill>
+                  <a:schemeClr val="bg1"/>
+                </a:solidFill>
+                <a:latin typeface="Comic Sans MS" panose="030F0702030302020204" pitchFamily="66" charset="0"/>
+                <a:cs typeface="Arial" panose="020B0604020202020204" pitchFamily="34" charset="0"/>
+              </a:defRPr>
+            </a:lvl3pPr>
+            <a:lvl4pPr marL="1600200" indent="-228600" eaLnBrk="0" hangingPunct="0">
+              <a:defRPr sz="2400">
+                <a:solidFill>
+                  <a:schemeClr val="bg1"/>
+                </a:solidFill>
+                <a:latin typeface="Comic Sans MS" panose="030F0702030302020204" pitchFamily="66" charset="0"/>
+                <a:cs typeface="Arial" panose="020B0604020202020204" pitchFamily="34" charset="0"/>
+              </a:defRPr>
+            </a:lvl4pPr>
+            <a:lvl5pPr marL="2057400" indent="-228600" eaLnBrk="0" hangingPunct="0">
+              <a:defRPr sz="2400">
+                <a:solidFill>
+                  <a:schemeClr val="bg1"/>
+                </a:solidFill>
+                <a:latin typeface="Comic Sans MS" panose="030F0702030302020204" pitchFamily="66" charset="0"/>
+                <a:cs typeface="Arial" panose="020B0604020202020204" pitchFamily="34" charset="0"/>
+              </a:defRPr>
+            </a:lvl5pPr>
+            <a:lvl6pPr marL="2514600" indent="-228600" eaLnBrk="0" fontAlgn="base" hangingPunct="0">
+              <a:spcBef>
+                <a:spcPct val="20000"/>
+              </a:spcBef>
+              <a:spcAft>
+                <a:spcPct val="0"/>
+              </a:spcAft>
+              <a:buChar char="•"/>
+              <a:defRPr sz="2400">
+                <a:solidFill>
+                  <a:schemeClr val="bg1"/>
+                </a:solidFill>
+                <a:latin typeface="Comic Sans MS" panose="030F0702030302020204" pitchFamily="66" charset="0"/>
+                <a:cs typeface="Arial" panose="020B0604020202020204" pitchFamily="34" charset="0"/>
+              </a:defRPr>
+            </a:lvl6pPr>
+            <a:lvl7pPr marL="2971800" indent="-228600" eaLnBrk="0" fontAlgn="base" hangingPunct="0">
+              <a:spcBef>
+                <a:spcPct val="20000"/>
+              </a:spcBef>
+              <a:spcAft>
+                <a:spcPct val="0"/>
+              </a:spcAft>
+              <a:buChar char="•"/>
+              <a:defRPr sz="2400">
+                <a:solidFill>
+                  <a:schemeClr val="bg1"/>
+                </a:solidFill>
+                <a:latin typeface="Comic Sans MS" panose="030F0702030302020204" pitchFamily="66" charset="0"/>
+                <a:cs typeface="Arial" panose="020B0604020202020204" pitchFamily="34" charset="0"/>
+              </a:defRPr>
+            </a:lvl7pPr>
+            <a:lvl8pPr marL="3429000" indent="-228600" eaLnBrk="0" fontAlgn="base" hangingPunct="0">
+              <a:spcBef>
+                <a:spcPct val="20000"/>
+              </a:spcBef>
+              <a:spcAft>
+                <a:spcPct val="0"/>
+              </a:spcAft>
+              <a:buChar char="•"/>
+              <a:defRPr sz="2400">
+                <a:solidFill>
+                  <a:schemeClr val="bg1"/>
+                </a:solidFill>
+                <a:latin typeface="Comic Sans MS" panose="030F0702030302020204" pitchFamily="66" charset="0"/>
+                <a:cs typeface="Arial" panose="020B0604020202020204" pitchFamily="34" charset="0"/>
+              </a:defRPr>
+            </a:lvl8pPr>
+            <a:lvl9pPr marL="3886200" indent="-228600" eaLnBrk="0" fontAlgn="base" hangingPunct="0">
+              <a:spcBef>
+                <a:spcPct val="20000"/>
+              </a:spcBef>
+              <a:spcAft>
+                <a:spcPct val="0"/>
+              </a:spcAft>
+              <a:buChar char="•"/>
+              <a:defRPr sz="2400">
+                <a:solidFill>
+                  <a:schemeClr val="bg1"/>
+                </a:solidFill>
+                <a:latin typeface="Comic Sans MS" panose="030F0702030302020204" pitchFamily="66" charset="0"/>
+                <a:cs typeface="Arial" panose="020B0604020202020204" pitchFamily="34" charset="0"/>
+              </a:defRPr>
+            </a:lvl9pPr>
+          </a:lstStyle>
+          <a:p>
+            <a:r>
+              <a:rPr lang="en-US" altLang="en-US" sz="1400">
+                <a:latin typeface="Verdana" panose="020B0604030504040204" pitchFamily="34" charset="0"/>
+              </a:rPr>
+              <a:t>© copyright UEA</a:t>
+            </a:r>
+            <a:endParaRPr lang="en-GB" altLang="en-US" sz="1400">
+              <a:latin typeface="Times New Roman" panose="02020603050405020304" pitchFamily="18" charset="0"/>
+            </a:endParaRPr>
+          </a:p>
+        </p:txBody>
+      </p:sp>
+      <p:sp>
+        <p:nvSpPr>
+          <p:cNvPr id="2052" name="Slide Number Placeholder 5"/>
+          <p:cNvSpPr>
+            <a:spLocks noGrp="1"/>
+          </p:cNvSpPr>
+          <p:nvPr>
+            <p:ph type="sldNum" sz="quarter" idx="4294967295"/>
+          </p:nvPr>
+        </p:nvSpPr>
+        <p:spPr>
+          <a:noFill/>
+          <a:ln/>
+          <a:extLst>
+            <a:ext uri="{909E8E84-426E-40DD-AFC4-6F175D3DCCD1}">
+              <a14:hiddenFill xmlns:a14="http://schemas.microsoft.com/office/drawing/2010/main">
+                <a:solidFill>
+                  <a:srgbClr val="FFFFFF"/>
+                </a:solidFill>
+              </a14:hiddenFill>
+            </a:ext>
+            <a:ext uri="{91240B29-F687-4F45-9708-019B960494DF}">
+              <a14:hiddenLine xmlns:a14="http://schemas.microsoft.com/office/drawing/2010/main" w="9525">
+                <a:solidFill>
+                  <a:srgbClr val="000000"/>
+                </a:solidFill>
+                <a:miter lim="800000"/>
+                <a:headEnd/>
+                <a:tailEnd/>
+              </a14:hiddenLine>
+            </a:ext>
+          </a:extLst>
+        </p:spPr>
+        <p:txBody>
+          <a:bodyPr/>
+          <a:lstStyle>
+            <a:lvl1pPr eaLnBrk="0" hangingPunct="0">
+              <a:defRPr sz="2400">
+                <a:solidFill>
+                  <a:schemeClr val="bg1"/>
+                </a:solidFill>
+                <a:latin typeface="Comic Sans MS" panose="030F0702030302020204" pitchFamily="66" charset="0"/>
+                <a:cs typeface="Arial" panose="020B0604020202020204" pitchFamily="34" charset="0"/>
+              </a:defRPr>
+            </a:lvl1pPr>
+            <a:lvl2pPr marL="742950" indent="-285750" eaLnBrk="0" hangingPunct="0">
+              <a:defRPr sz="2400">
+                <a:solidFill>
+                  <a:schemeClr val="bg1"/>
+                </a:solidFill>
+                <a:latin typeface="Comic Sans MS" panose="030F0702030302020204" pitchFamily="66" charset="0"/>
+                <a:cs typeface="Arial" panose="020B0604020202020204" pitchFamily="34" charset="0"/>
+              </a:defRPr>
+            </a:lvl2pPr>
+            <a:lvl3pPr marL="1143000" indent="-228600" eaLnBrk="0" hangingPunct="0">
+              <a:defRPr sz="2400">
+                <a:solidFill>
+                  <a:schemeClr val="bg1"/>
+                </a:solidFill>
+                <a:latin typeface="Comic Sans MS" panose="030F0702030302020204" pitchFamily="66" charset="0"/>
+                <a:cs typeface="Arial" panose="020B0604020202020204" pitchFamily="34" charset="0"/>
+              </a:defRPr>
+            </a:lvl3pPr>
+            <a:lvl4pPr marL="1600200" indent="-228600" eaLnBrk="0" hangingPunct="0">
+              <a:defRPr sz="2400">
+                <a:solidFill>
+                  <a:schemeClr val="bg1"/>
+                </a:solidFill>
+                <a:latin typeface="Comic Sans MS" panose="030F0702030302020204" pitchFamily="66" charset="0"/>
+                <a:cs typeface="Arial" panose="020B0604020202020204" pitchFamily="34" charset="0"/>
+              </a:defRPr>
+            </a:lvl4pPr>
+            <a:lvl5pPr marL="2057400" indent="-228600" eaLnBrk="0" hangingPunct="0">
+              <a:defRPr sz="2400">
+                <a:solidFill>
+                  <a:schemeClr val="bg1"/>
+                </a:solidFill>
+                <a:latin typeface="Comic Sans MS" panose="030F0702030302020204" pitchFamily="66" charset="0"/>
+                <a:cs typeface="Arial" panose="020B0604020202020204" pitchFamily="34" charset="0"/>
+              </a:defRPr>
+            </a:lvl5pPr>
+            <a:lvl6pPr marL="2514600" indent="-228600" eaLnBrk="0" fontAlgn="base" hangingPunct="0">
+              <a:spcBef>
+                <a:spcPct val="20000"/>
+              </a:spcBef>
+              <a:spcAft>
+                <a:spcPct val="0"/>
+              </a:spcAft>
+              <a:buChar char="•"/>
+              <a:defRPr sz="2400">
+                <a:solidFill>
+                  <a:schemeClr val="bg1"/>
+                </a:solidFill>
+                <a:latin typeface="Comic Sans MS" panose="030F0702030302020204" pitchFamily="66" charset="0"/>
+                <a:cs typeface="Arial" panose="020B0604020202020204" pitchFamily="34" charset="0"/>
+              </a:defRPr>
+            </a:lvl6pPr>
+            <a:lvl7pPr marL="2971800" indent="-228600" eaLnBrk="0" fontAlgn="base" hangingPunct="0">
+              <a:spcBef>
+                <a:spcPct val="20000"/>
+              </a:spcBef>
+              <a:spcAft>
+                <a:spcPct val="0"/>
+              </a:spcAft>
+              <a:buChar char="•"/>
+              <a:defRPr sz="2400">
+                <a:solidFill>
+                  <a:schemeClr val="bg1"/>
+                </a:solidFill>
+                <a:latin typeface="Comic Sans MS" panose="030F0702030302020204" pitchFamily="66" charset="0"/>
+                <a:cs typeface="Arial" panose="020B0604020202020204" pitchFamily="34" charset="0"/>
+              </a:defRPr>
+            </a:lvl7pPr>
+            <a:lvl8pPr marL="3429000" indent="-228600" eaLnBrk="0" fontAlgn="base" hangingPunct="0">
+              <a:spcBef>
+                <a:spcPct val="20000"/>
+              </a:spcBef>
+              <a:spcAft>
+                <a:spcPct val="0"/>
+              </a:spcAft>
+              <a:buChar char="•"/>
+              <a:defRPr sz="2400">
+                <a:solidFill>
+                  <a:schemeClr val="bg1"/>
+                </a:solidFill>
+                <a:latin typeface="Comic Sans MS" panose="030F0702030302020204" pitchFamily="66" charset="0"/>
+                <a:cs typeface="Arial" panose="020B0604020202020204" pitchFamily="34" charset="0"/>
+              </a:defRPr>
+            </a:lvl8pPr>
+            <a:lvl9pPr marL="3886200" indent="-228600" eaLnBrk="0" fontAlgn="base" hangingPunct="0">
+              <a:spcBef>
+                <a:spcPct val="20000"/>
+              </a:spcBef>
+              <a:spcAft>
+                <a:spcPct val="0"/>
+              </a:spcAft>
+              <a:buChar char="•"/>
+              <a:defRPr sz="2400">
+                <a:solidFill>
+                  <a:schemeClr val="bg1"/>
+                </a:solidFill>
+                <a:latin typeface="Comic Sans MS" panose="030F0702030302020204" pitchFamily="66" charset="0"/>
+                <a:cs typeface="Arial" panose="020B0604020202020204" pitchFamily="34" charset="0"/>
+              </a:defRPr>
+            </a:lvl9pPr>
+          </a:lstStyle>
+          <a:p>
+            <a:r>
+              <a:rPr lang="en-GB" altLang="en-US" sz="1400">
+                <a:latin typeface="Times New Roman" panose="02020603050405020304" pitchFamily="18" charset="0"/>
+              </a:rPr>
+              <a:t>slide </a:t>
+            </a:r>
+            <a:fld id="{1010D064-77DF-4B55-80BD-1876EBCED9D8}" type="slidenum">
+              <a:rPr lang="en-GB" altLang="en-US" sz="1400">
+                <a:latin typeface="Times New Roman" panose="02020603050405020304" pitchFamily="18" charset="0"/>
+              </a:rPr>
+              <a:pPr/>
+              <a:t>8</a:t>
+            </a:fld>
+            <a:endParaRPr lang="en-GB" altLang="en-US" sz="1400">
+              <a:latin typeface="Times New Roman" panose="02020603050405020304" pitchFamily="18" charset="0"/>
+            </a:endParaRPr>
+          </a:p>
+        </p:txBody>
+      </p:sp>
+      <p:sp>
+        <p:nvSpPr>
+          <p:cNvPr id="2053" name="Rectangle 2"/>
+          <p:cNvSpPr>
+            <a:spLocks noGrp="1" noChangeArrowheads="1"/>
+          </p:cNvSpPr>
+          <p:nvPr>
+            <p:ph type="ctrTitle"/>
+          </p:nvPr>
+        </p:nvSpPr>
+        <p:spPr>
+          <a:xfrm>
+            <a:off x="179512" y="1052736"/>
+            <a:ext cx="8784976" cy="1537518"/>
+          </a:xfrm>
+        </p:spPr>
+        <p:txBody>
+          <a:bodyPr/>
+          <a:lstStyle/>
+          <a:p>
+            <a:r>
+              <a:rPr lang="en-GB" altLang="en-US" sz="4400" dirty="0"/>
+              <a:t>Progress Report</a:t>
+            </a:r>
+            <a:br>
+              <a:rPr lang="en-GB" altLang="en-US" sz="3200" dirty="0"/>
+            </a:br>
+            <a:r>
+              <a:rPr lang="en-GB" altLang="en-US" sz="3200" dirty="0"/>
+              <a:t>15 Apr-22 Apr 2024</a:t>
+            </a:r>
+          </a:p>
+        </p:txBody>
+      </p:sp>
+      <p:sp>
+        <p:nvSpPr>
+          <p:cNvPr id="2054" name="Rectangle 3"/>
+          <p:cNvSpPr>
+            <a:spLocks noGrp="1" noChangeArrowheads="1"/>
+          </p:cNvSpPr>
+          <p:nvPr>
+            <p:ph type="subTitle" idx="1"/>
+          </p:nvPr>
+        </p:nvSpPr>
+        <p:spPr>
+          <a:xfrm>
+            <a:off x="1187624" y="4077072"/>
+            <a:ext cx="6912768" cy="1800200"/>
+          </a:xfrm>
+        </p:spPr>
+        <p:txBody>
+          <a:bodyPr/>
+          <a:lstStyle/>
+          <a:p>
+            <a:r>
+              <a:rPr lang="en-GB" altLang="en-US" b="1" dirty="0">
+                <a:solidFill>
+                  <a:schemeClr val="tx2"/>
+                </a:solidFill>
+                <a:latin typeface="+mj-lt"/>
+                <a:ea typeface="微軟正黑體" panose="020B0604030504040204" pitchFamily="34" charset="-120"/>
+                <a:cs typeface="微軟正黑體" panose="020B0604030504040204" pitchFamily="34" charset="-120"/>
+              </a:rPr>
+              <a:t>For example: Adam Cook</a:t>
+            </a:r>
+            <a:br>
+              <a:rPr lang="en-GB" altLang="en-US" b="1" dirty="0">
+                <a:solidFill>
+                  <a:schemeClr val="tx2"/>
+                </a:solidFill>
+                <a:latin typeface="+mj-lt"/>
+                <a:ea typeface="微軟正黑體" panose="020B0604030504040204" pitchFamily="34" charset="-120"/>
+                <a:cs typeface="微軟正黑體" panose="020B0604030504040204" pitchFamily="34" charset="-120"/>
+              </a:rPr>
+            </a:br>
+            <a:r>
+              <a:rPr lang="en-GB" altLang="en-US" b="1" dirty="0">
+                <a:solidFill>
+                  <a:schemeClr val="tx2"/>
+                </a:solidFill>
+                <a:latin typeface="+mj-lt"/>
+                <a:ea typeface="微軟正黑體" panose="020B0604030504040204" pitchFamily="34" charset="-120"/>
+                <a:cs typeface="微軟正黑體" panose="020B0604030504040204" pitchFamily="34" charset="-120"/>
+              </a:rPr>
+              <a:t>University of East Anglia</a:t>
+            </a:r>
+          </a:p>
+          <a:p>
+            <a:r>
+              <a:rPr lang="en-GB" altLang="en-US" b="1" dirty="0">
+                <a:solidFill>
+                  <a:schemeClr val="tx2"/>
+                </a:solidFill>
+                <a:latin typeface="+mj-lt"/>
+                <a:ea typeface="微軟正黑體" panose="020B0604030504040204" pitchFamily="34" charset="-120"/>
+                <a:cs typeface="微軟正黑體" panose="020B0604030504040204" pitchFamily="34" charset="-120"/>
+              </a:rPr>
+              <a:t>05-Mar-2023</a:t>
+            </a:r>
+          </a:p>
+        </p:txBody>
+      </p:sp>
+    </p:spTree>
+    <p:extLst>
+      <p:ext uri="{BB962C8B-B14F-4D97-AF65-F5344CB8AC3E}">
+        <p14:creationId xmlns:p14="http://schemas.microsoft.com/office/powerpoint/2010/main" val="3238939438"/>
+      </p:ext>
+    </p:extLst>
+  </p:cSld>
+  <p:clrMapOvr>
+    <a:masterClrMapping/>
+  </p:clrMapOvr>
+</p:sld>
+</file>
+
+<file path=ppt/slides/slide9.xml><?xml version="1.0" encoding="utf-8"?>
+<p:sld xmlns:a="http://schemas.openxmlformats.org/drawingml/2006/main" xmlns:r="http://schemas.openxmlformats.org/officeDocument/2006/relationships" xmlns:p="http://schemas.openxmlformats.org/presentationml/2006/main">
+  <p:cSld>
+    <p:spTree>
+      <p:nvGrpSpPr>
+        <p:cNvPr id="1" name=""/>
+        <p:cNvGrpSpPr/>
+        <p:nvPr/>
+      </p:nvGrpSpPr>
+      <p:grpSpPr>
+        <a:xfrm>
+          <a:off x="0" y="0"/>
+          <a:ext cx="0" cy="0"/>
+          <a:chOff x="0" y="0"/>
+          <a:chExt cx="0" cy="0"/>
+        </a:xfrm>
+      </p:grpSpPr>
+      <p:sp>
+        <p:nvSpPr>
+          <p:cNvPr id="2" name="Title 1"/>
+          <p:cNvSpPr>
+            <a:spLocks noGrp="1"/>
+          </p:cNvSpPr>
+          <p:nvPr>
+            <p:ph type="title"/>
+          </p:nvPr>
+        </p:nvSpPr>
+        <p:spPr/>
+        <p:txBody>
+          <a:bodyPr/>
+          <a:lstStyle/>
+          <a:p>
+            <a:r>
+              <a:t>What's Coming Next</a:t>
+            </a:r>
+            <a:endParaRPr lang="zh-TW" altLang="en-US" dirty="0"/>
+          </a:p>
+        </p:txBody>
+      </p:sp>
+      <p:sp>
+        <p:nvSpPr>
+          <p:cNvPr id="3" name="Content Placeholder 2"/>
+          <p:cNvSpPr>
+            <a:spLocks noGrp="1"/>
+          </p:cNvSpPr>
+          <p:nvPr>
+            <p:ph idx="1"/>
+          </p:nvPr>
+        </p:nvSpPr>
+        <p:spPr/>
+        <p:txBody>
+          <a:bodyPr/>
+          <a:lstStyle/>
+          <a:p>
+            <a:pPr/>
+            <a:r>
+              <a:rPr b="0" i="0" sz="1400"/>
+              <a:t>Connect the map to real, live restaurant listings nearby</a:t>
+            </a:r>
+          </a:p>
+          <a:p>
+            <a:pPr/>
+            <a:r>
+              <a:rPr b="0" i="0" sz="1400"/>
+              <a:t>Make the search bar pull results directly from those live listings</a:t>
+            </a:r>
+          </a:p>
+          <a:p>
+            <a:pPr/>
+            <a:r>
+              <a:rPr b="0" i="0" sz="1400"/>
+              <a:t>Add a small safeguard so pressing back on the map doesn't close the app by accident</a:t>
+            </a:r>
+          </a:p>
+        </p:txBody>
+      </p:sp>
+      <p:sp>
+        <p:nvSpPr>
+          <p:cNvPr id="4" name="Date Placeholder 3"/>
+          <p:cNvSpPr>
+            <a:spLocks noGrp="1"/>
+          </p:cNvSpPr>
+          <p:nvPr>
+            <p:ph type="dt" sz="half" idx="10"/>
+          </p:nvPr>
+        </p:nvSpPr>
+        <p:spPr/>
+        <p:txBody>
+          <a:bodyPr/>
+          <a:lstStyle/>
+          <a:p/>
+        </p:txBody>
+      </p:sp>
+      <p:sp>
+        <p:nvSpPr>
+          <p:cNvPr id="5" name="Slide Number Placeholder 4"/>
+          <p:cNvSpPr>
+            <a:spLocks noGrp="1"/>
+          </p:cNvSpPr>
+          <p:nvPr>
+            <p:ph type="sldNum" sz="quarter" idx="12"/>
+          </p:nvPr>
+        </p:nvSpPr>
+        <p:spPr/>
+        <p:txBody>
+          <a:bodyPr/>
+          <a:lstStyle/>
+          <a:p>
+            <a:pPr>
+              <a:defRPr/>
+            </a:pPr>
+            <a:fld id="{8AF5A669-E021-420B-B33A-88CB5B8E39F6}" type="slidenum">
+              <a:rPr lang="zh-TW" altLang="en-US" smtClean="0"/>
+              <a:pPr>
+                <a:defRPr/>
+              </a:pPr>
+              <a:t>9</a:t>
+            </a:fld>
+            <a:endParaRPr lang="zh-TW" altLang="en-US"/>
+          </a:p>
+        </p:txBody>
+      </p:sp>
+    </p:spTree>
+    <p:extLst>
+      <p:ext uri="{BB962C8B-B14F-4D97-AF65-F5344CB8AC3E}">
+        <p14:creationId xmlns:p14="http://schemas.microsoft.com/office/powerpoint/2010/main" val="1650411722"/>
       </p:ext>
     </p:extLst>
   </p:cSld>

</xml_diff>

<commit_message>
fix: swap mislabeled Register/Contact Us screenshots, commit Firebase config
The final report's screenshot gallery had these two files swapped: the
image saved as "registration page.jpeg" was actually the Contact Us
screen, and "contact us page.jpeg" was actually the Register screen.
This made the compiled report look like the registration/auth work was
missing when it was never lost — just mislabeled on disk.

Also note in the Testing section that the Login screenshot predates the
removal of the broken "Continue as Guest" button (see commit 09e6a23),
and commit google-services.json, which was never in version control
even though Firebase Auth depends on it to build.

Co-Authored-By: Claude Sonnet 5 <noreply@anthropic.com>
</commit_message>
<xml_diff>
--- a/project progress files/progress3/Spot_To_Go_Presentation.pptx
+++ b/project progress files/progress3/Spot_To_Go_Presentation.pptx
@@ -5,10 +5,10 @@
     <p:sldMasterId id="2147484223" r:id="rId1"/>
   </p:sldMasterIdLst>
   <p:notesMasterIdLst>
-    <p:notesMasterId r:id="rId15"/>
+    <p:notesMasterId r:id="rId10"/>
   </p:notesMasterIdLst>
   <p:handoutMasterIdLst>
-    <p:handoutMasterId r:id="rId16"/>
+    <p:handoutMasterId r:id="rId11"/>
   </p:handoutMasterIdLst>
   <p:sldIdLst>
     <p:sldId id="834" r:id="rId2"/>
@@ -18,7 +18,7 @@
     <p:sldId id="898" r:id="rId6"/>
     <p:sldId id="900" r:id="rId7"/>
     <p:sldId id="907" r:id="rId8"/>
-    <p:sldId id="902" r:id="rId10"/>
+    <p:sldId id="902" r:id="rId9"/>
   </p:sldIdLst>
   <p:sldSz cx="9144000" cy="6858000" type="screen4x3"/>
   <p:notesSz cx="6797675" cy="9928225"/>
@@ -133,12 +133,7 @@
         </p14:section>
         <p14:section name="11-Oct-2023" id="{FC326422-0757-454E-981C-31F2C251ABD4}">
           <p14:sldIdLst>
-            <p14:sldId id="901"/>
             <p14:sldId id="902"/>
-            <p14:sldId id="903"/>
-            <p14:sldId id="904"/>
-            <p14:sldId id="905"/>
-            <p14:sldId id="906"/>
           </p14:sldIdLst>
         </p14:section>
       </p14:sectionLst>
@@ -243,7 +238,7 @@
           <a:p>
             <a:fld id="{2F53DA8A-A077-479B-8E53-2623908510DE}" type="datetimeFigureOut">
               <a:rPr lang="zh-TW" altLang="en-US" smtClean="0"/>
-              <a:t>2025/10/9</a:t>
+              <a:t>2026/7/13</a:t>
             </a:fld>
             <a:endParaRPr lang="zh-TW" altLang="en-US"/>
           </a:p>
@@ -408,7 +403,7 @@
           <a:p>
             <a:fld id="{69FA75D8-E72B-463D-9CD6-A13B7BE75328}" type="datetimeFigureOut">
               <a:rPr lang="zh-TW" altLang="en-US" smtClean="0"/>
-              <a:t>2025/10/9</a:t>
+              <a:t>2026/7/13</a:t>
             </a:fld>
             <a:endParaRPr lang="zh-TW" altLang="en-US"/>
           </a:p>
@@ -915,7 +910,20 @@
           <a:lstStyle/>
           <a:p>
             <a:r>
-              <a:t>Good morning/afternoon, everyone. My name is Nagenthiran Nagarajah, and today I'm going to walk you through Spot To Go, the Android app I've been building. Spot To Go helps people discover restaurants near them, see real details about each one, and even watch a short video of what the place actually looks like before deciding to go. I'll show you every screen in the app, and then explain how it all works behind the scenes.</a:t>
+              <a:rPr dirty="0"/>
+              <a:t>Good morning/afternoon, everyone. My name is </a:t>
+            </a:r>
+            <a:r>
+              <a:rPr lang="en-US" smtClean="0"/>
+              <a:t>Paithiyam</a:t>
+            </a:r>
+            <a:r>
+              <a:rPr smtClean="0"/>
+              <a:t>, </a:t>
+            </a:r>
+            <a:r>
+              <a:rPr dirty="0"/>
+              <a:t>and today I'm going to walk you through Spot To Go, the Android app I've been building. Spot To Go helps people discover restaurants near them, see real details about each one, and even watch a short video of what the place actually looks like before deciding to go. I'll show you every screen in the app, and then explain how it all works behind the scenes.</a:t>
             </a:r>
           </a:p>
         </p:txBody>
@@ -952,259 +960,53 @@
       </p:grpSpPr>
       <p:sp>
         <p:nvSpPr>
-          <p:cNvPr id="35842" name="Rectangle 7"/>
-          <p:cNvSpPr>
-            <a:spLocks noGrp="1" noChangeArrowheads="1"/>
-          </p:cNvSpPr>
-          <p:nvPr>
-            <p:ph type="sldNum" sz="quarter" idx="5"/>
-          </p:nvPr>
-        </p:nvSpPr>
-        <p:spPr>
-          <a:noFill/>
-          <a:ln/>
-          <a:extLst>
-            <a:ext uri="{909E8E84-426E-40DD-AFC4-6F175D3DCCD1}">
-              <a14:hiddenFill xmlns:a14="http://schemas.microsoft.com/office/drawing/2010/main">
-                <a:solidFill>
-                  <a:srgbClr val="FFFFFF"/>
-                </a:solidFill>
-              </a14:hiddenFill>
-            </a:ext>
-            <a:ext uri="{91240B29-F687-4F45-9708-019B960494DF}">
-              <a14:hiddenLine xmlns:a14="http://schemas.microsoft.com/office/drawing/2010/main" w="9525">
-                <a:solidFill>
-                  <a:srgbClr val="000000"/>
-                </a:solidFill>
-                <a:miter lim="800000"/>
-                <a:headEnd/>
-                <a:tailEnd/>
-              </a14:hiddenLine>
-            </a:ext>
-          </a:extLst>
-        </p:spPr>
-        <p:txBody>
-          <a:bodyPr/>
-          <a:lstStyle>
-            <a:lvl1pPr defTabSz="990600" eaLnBrk="0" hangingPunct="0">
-              <a:defRPr sz="2400">
-                <a:solidFill>
-                  <a:schemeClr val="bg1"/>
-                </a:solidFill>
-                <a:latin typeface="Comic Sans MS" panose="030F0702030302020204" pitchFamily="66" charset="0"/>
-                <a:cs typeface="Arial" panose="020B0604020202020204" pitchFamily="34" charset="0"/>
-              </a:defRPr>
-            </a:lvl1pPr>
-            <a:lvl2pPr marL="742950" indent="-285750" defTabSz="990600" eaLnBrk="0" hangingPunct="0">
-              <a:defRPr sz="2400">
-                <a:solidFill>
-                  <a:schemeClr val="bg1"/>
-                </a:solidFill>
-                <a:latin typeface="Comic Sans MS" panose="030F0702030302020204" pitchFamily="66" charset="0"/>
-                <a:cs typeface="Arial" panose="020B0604020202020204" pitchFamily="34" charset="0"/>
-              </a:defRPr>
-            </a:lvl2pPr>
-            <a:lvl3pPr marL="1143000" indent="-228600" defTabSz="990600" eaLnBrk="0" hangingPunct="0">
-              <a:defRPr sz="2400">
-                <a:solidFill>
-                  <a:schemeClr val="bg1"/>
-                </a:solidFill>
-                <a:latin typeface="Comic Sans MS" panose="030F0702030302020204" pitchFamily="66" charset="0"/>
-                <a:cs typeface="Arial" panose="020B0604020202020204" pitchFamily="34" charset="0"/>
-              </a:defRPr>
-            </a:lvl3pPr>
-            <a:lvl4pPr marL="1600200" indent="-228600" defTabSz="990600" eaLnBrk="0" hangingPunct="0">
-              <a:defRPr sz="2400">
-                <a:solidFill>
-                  <a:schemeClr val="bg1"/>
-                </a:solidFill>
-                <a:latin typeface="Comic Sans MS" panose="030F0702030302020204" pitchFamily="66" charset="0"/>
-                <a:cs typeface="Arial" panose="020B0604020202020204" pitchFamily="34" charset="0"/>
-              </a:defRPr>
-            </a:lvl4pPr>
-            <a:lvl5pPr marL="2057400" indent="-228600" defTabSz="990600" eaLnBrk="0" hangingPunct="0">
-              <a:defRPr sz="2400">
-                <a:solidFill>
-                  <a:schemeClr val="bg1"/>
-                </a:solidFill>
-                <a:latin typeface="Comic Sans MS" panose="030F0702030302020204" pitchFamily="66" charset="0"/>
-                <a:cs typeface="Arial" panose="020B0604020202020204" pitchFamily="34" charset="0"/>
-              </a:defRPr>
-            </a:lvl5pPr>
-            <a:lvl6pPr marL="2514600" indent="-228600" defTabSz="990600" eaLnBrk="0" fontAlgn="base" hangingPunct="0">
-              <a:spcBef>
-                <a:spcPct val="20000"/>
-              </a:spcBef>
-              <a:spcAft>
-                <a:spcPct val="0"/>
-              </a:spcAft>
-              <a:buChar char="•"/>
-              <a:defRPr sz="2400">
-                <a:solidFill>
-                  <a:schemeClr val="bg1"/>
-                </a:solidFill>
-                <a:latin typeface="Comic Sans MS" panose="030F0702030302020204" pitchFamily="66" charset="0"/>
-                <a:cs typeface="Arial" panose="020B0604020202020204" pitchFamily="34" charset="0"/>
-              </a:defRPr>
-            </a:lvl6pPr>
-            <a:lvl7pPr marL="2971800" indent="-228600" defTabSz="990600" eaLnBrk="0" fontAlgn="base" hangingPunct="0">
-              <a:spcBef>
-                <a:spcPct val="20000"/>
-              </a:spcBef>
-              <a:spcAft>
-                <a:spcPct val="0"/>
-              </a:spcAft>
-              <a:buChar char="•"/>
-              <a:defRPr sz="2400">
-                <a:solidFill>
-                  <a:schemeClr val="bg1"/>
-                </a:solidFill>
-                <a:latin typeface="Comic Sans MS" panose="030F0702030302020204" pitchFamily="66" charset="0"/>
-                <a:cs typeface="Arial" panose="020B0604020202020204" pitchFamily="34" charset="0"/>
-              </a:defRPr>
-            </a:lvl7pPr>
-            <a:lvl8pPr marL="3429000" indent="-228600" defTabSz="990600" eaLnBrk="0" fontAlgn="base" hangingPunct="0">
-              <a:spcBef>
-                <a:spcPct val="20000"/>
-              </a:spcBef>
-              <a:spcAft>
-                <a:spcPct val="0"/>
-              </a:spcAft>
-              <a:buChar char="•"/>
-              <a:defRPr sz="2400">
-                <a:solidFill>
-                  <a:schemeClr val="bg1"/>
-                </a:solidFill>
-                <a:latin typeface="Comic Sans MS" panose="030F0702030302020204" pitchFamily="66" charset="0"/>
-                <a:cs typeface="Arial" panose="020B0604020202020204" pitchFamily="34" charset="0"/>
-              </a:defRPr>
-            </a:lvl8pPr>
-            <a:lvl9pPr marL="3886200" indent="-228600" defTabSz="990600" eaLnBrk="0" fontAlgn="base" hangingPunct="0">
-              <a:spcBef>
-                <a:spcPct val="20000"/>
-              </a:spcBef>
-              <a:spcAft>
-                <a:spcPct val="0"/>
-              </a:spcAft>
-              <a:buChar char="•"/>
-              <a:defRPr sz="2400">
-                <a:solidFill>
-                  <a:schemeClr val="bg1"/>
-                </a:solidFill>
-                <a:latin typeface="Comic Sans MS" panose="030F0702030302020204" pitchFamily="66" charset="0"/>
-                <a:cs typeface="Arial" panose="020B0604020202020204" pitchFamily="34" charset="0"/>
-              </a:defRPr>
-            </a:lvl9pPr>
-          </a:lstStyle>
-          <a:p>
-            <a:pPr eaLnBrk="1" hangingPunct="1"/>
-            <a:fld id="{F6B2CF12-DB6C-4AA5-A68A-5E5F13459CDE}" type="slidenum">
-              <a:rPr lang="en-GB" altLang="en-US" sz="1300">
-                <a:solidFill>
-                  <a:schemeClr val="tx1"/>
-                </a:solidFill>
-                <a:latin typeface="Arial" panose="020B0604020202020204" pitchFamily="34" charset="0"/>
-              </a:rPr>
-              <a:pPr eaLnBrk="1" hangingPunct="1"/>
-              <a:t>8</a:t>
-            </a:fld>
-            <a:endParaRPr lang="en-GB" altLang="en-US" sz="1300">
-              <a:solidFill>
-                <a:schemeClr val="tx1"/>
-              </a:solidFill>
-              <a:latin typeface="Arial" panose="020B0604020202020204" pitchFamily="34" charset="0"/>
-            </a:endParaRPr>
-          </a:p>
-        </p:txBody>
-      </p:sp>
-      <p:sp>
-        <p:nvSpPr>
-          <p:cNvPr id="35843" name="Rectangle 2"/>
-          <p:cNvSpPr>
-            <a:spLocks noGrp="1" noRot="1" noChangeAspect="1" noChangeArrowheads="1" noTextEdit="1"/>
-          </p:cNvSpPr>
-          <p:nvPr>
-            <p:ph type="sldImg"/>
-          </p:nvPr>
-        </p:nvSpPr>
-        <p:spPr>
-          <a:xfrm>
-            <a:off x="992188" y="768350"/>
-            <a:ext cx="5114925" cy="3836988"/>
-          </a:xfrm>
-          <a:ln/>
-        </p:spPr>
-      </p:sp>
-      <p:sp>
-        <p:nvSpPr>
-          <p:cNvPr id="35844" name="Rectangle 3"/>
-          <p:cNvSpPr>
-            <a:spLocks noGrp="1" noChangeArrowheads="1"/>
-          </p:cNvSpPr>
-          <p:nvPr>
-            <p:ph type="body" idx="1"/>
-          </p:nvPr>
-        </p:nvSpPr>
-        <p:spPr>
-          <a:noFill/>
-          <a:ln/>
-          <a:extLst>
-            <a:ext uri="{909E8E84-426E-40DD-AFC4-6F175D3DCCD1}">
-              <a14:hiddenFill xmlns:a14="http://schemas.microsoft.com/office/drawing/2010/main">
-                <a:solidFill>
-                  <a:srgbClr val="FFFFFF"/>
-                </a:solidFill>
-              </a14:hiddenFill>
-            </a:ext>
-            <a:ext uri="{91240B29-F687-4F45-9708-019B960494DF}">
-              <a14:hiddenLine xmlns:a14="http://schemas.microsoft.com/office/drawing/2010/main" w="9525">
-                <a:solidFill>
-                  <a:srgbClr val="000000"/>
-                </a:solidFill>
-                <a:miter lim="800000"/>
-                <a:headEnd/>
-                <a:tailEnd/>
-              </a14:hiddenLine>
-            </a:ext>
-          </a:extLst>
-        </p:spPr>
+          <p:cNvPr id="2" name="Slide Image Placeholder 1"/>
+          <p:cNvSpPr>
+            <a:spLocks noGrp="1" noRot="1" noChangeAspect="1"/>
+          </p:cNvSpPr>
+          <p:nvPr>
+            <p:ph type="sldImg" idx="2"/>
+          </p:nvPr>
+        </p:nvSpPr>
+        <p:spPr/>
+      </p:sp>
+      <p:sp>
+        <p:nvSpPr>
+          <p:cNvPr id="3" name="Notes Placeholder 2"/>
+          <p:cNvSpPr>
+            <a:spLocks noGrp="1"/>
+          </p:cNvSpPr>
+          <p:nvPr>
+            <p:ph type="body" sz="quarter" idx="3"/>
+          </p:nvPr>
+        </p:nvSpPr>
+        <p:spPr/>
         <p:txBody>
           <a:bodyPr/>
           <a:lstStyle/>
           <a:p>
-            <a:pPr eaLnBrk="1" hangingPunct="1"/>
-            <a:r>
-              <a:rPr lang="en-US" altLang="en-US" dirty="0">
-                <a:latin typeface="Arial" panose="020B0604020202020204" pitchFamily="34" charset="0"/>
-                <a:cs typeface="Arial" panose="020B0604020202020204" pitchFamily="34" charset="0"/>
-              </a:rPr>
-              <a:t>Section one takes about ? min. </a:t>
-            </a:r>
-            <a:endParaRPr lang="en-US" altLang="en-US" baseline="0" dirty="0">
-              <a:latin typeface="Arial" panose="020B0604020202020204" pitchFamily="34" charset="0"/>
-              <a:cs typeface="Arial" panose="020B0604020202020204" pitchFamily="34" charset="0"/>
-            </a:endParaRPr>
-          </a:p>
-          <a:p>
-            <a:pPr eaLnBrk="1" hangingPunct="1"/>
-            <a:r>
-              <a:rPr lang="en-US" altLang="en-US" baseline="0" dirty="0">
-                <a:latin typeface="Arial" panose="020B0604020202020204" pitchFamily="34" charset="0"/>
-                <a:cs typeface="Arial" panose="020B0604020202020204" pitchFamily="34" charset="0"/>
-              </a:rPr>
-              <a:t>Section two takes about ? min.</a:t>
-            </a:r>
-            <a:endParaRPr lang="en-US" altLang="en-US" dirty="0">
-              <a:latin typeface="Arial" panose="020B0604020202020204" pitchFamily="34" charset="0"/>
-              <a:cs typeface="Arial" panose="020B0604020202020204" pitchFamily="34" charset="0"/>
-            </a:endParaRPr>
-          </a:p>
-        </p:txBody>
+            <a:r>
+              <a:t>So what exactly is Spot To Go? At its core, it's a simple idea: instead of guessing what a restaurant is like from a photo or a star rating, you can actually watch a short video of it first. The app uses the phone's location to find restaurants nearby, shows the important details like rating, distance and cuisine, and then gives a real video preview so the user knows what to expect. Once they've decided, one tap gives directions straight there. It's built using modern Android tools — Kotlin and Jetpack Compose — which is the current recommended way to build Android apps.</a:t>
+            </a:r>
+          </a:p>
+        </p:txBody>
+      </p:sp>
+      <p:sp>
+        <p:nvSpPr>
+          <p:cNvPr id="4" name="Slide Number Placeholder 3"/>
+          <p:cNvSpPr>
+            <a:spLocks noGrp="1"/>
+          </p:cNvSpPr>
+          <p:nvPr>
+            <p:ph type="sldNum" sz="quarter" idx="5"/>
+          </p:nvPr>
+        </p:nvSpPr>
+        <p:spPr/>
       </p:sp>
     </p:spTree>
     <p:extLst>
       <p:ext uri="{BB962C8B-B14F-4D97-AF65-F5344CB8AC3E}">
-        <p14:creationId xmlns:p14="http://schemas.microsoft.com/office/powerpoint/2010/main" val="376139957"/>
+        <p14:creationId xmlns:p14="http://schemas.microsoft.com/office/powerpoint/2010/main" val="3618399025"/>
       </p:ext>
     </p:extLst>
   </p:cSld>
@@ -1215,7 +1017,7 @@
 </file>
 
 <file path=ppt/notesSlides/notesSlide3.xml><?xml version="1.0" encoding="utf-8"?>
-<p:notes xmlns:a="http://schemas.openxmlformats.org/drawingml/2006/main" xmlns:p="http://schemas.openxmlformats.org/presentationml/2006/main" xmlns:r="http://schemas.openxmlformats.org/officeDocument/2006/relationships">
+<p:notes xmlns:a="http://schemas.openxmlformats.org/drawingml/2006/main" xmlns:r="http://schemas.openxmlformats.org/officeDocument/2006/relationships" xmlns:p="http://schemas.openxmlformats.org/presentationml/2006/main">
   <p:cSld>
     <p:spTree>
       <p:nvGrpSpPr>
@@ -1235,22 +1037,22 @@
         <p:nvSpPr>
           <p:cNvPr id="2" name="Slide Image Placeholder 1"/>
           <p:cNvSpPr>
+            <a:spLocks noGrp="1" noRot="1" noChangeAspect="1"/>
+          </p:cNvSpPr>
+          <p:nvPr>
+            <p:ph type="sldImg" idx="2"/>
+          </p:nvPr>
+        </p:nvSpPr>
+        <p:spPr/>
+      </p:sp>
+      <p:sp>
+        <p:nvSpPr>
+          <p:cNvPr id="3" name="Notes Placeholder 2"/>
+          <p:cNvSpPr>
             <a:spLocks noGrp="1"/>
           </p:cNvSpPr>
           <p:nvPr>
-            <p:ph type="sldImg" idx="2"/>
-          </p:nvPr>
-        </p:nvSpPr>
-        <p:spPr/>
-      </p:sp>
-      <p:sp>
-        <p:nvSpPr>
-          <p:cNvPr id="3" name="Notes Placeholder 2"/>
-          <p:cNvSpPr>
-            <a:spLocks noGrp="1"/>
-          </p:cNvSpPr>
-          <p:nvPr>
-            <p:ph type="body" idx="3" sz="quarter"/>
+            <p:ph type="body" sz="quarter" idx="3"/>
           </p:nvPr>
         </p:nvSpPr>
         <p:spPr/>
@@ -1259,7 +1061,7 @@
           <a:lstStyle/>
           <a:p>
             <a:r>
-              <a:t>So what exactly is Spot To Go? At its core, it's a simple idea: instead of guessing what a restaurant is like from a photo or a star rating, you can actually watch a short video of it first. The app uses the phone's location to find restaurants nearby, shows the important details like rating, distance and cuisine, and then gives a real video preview so the user knows what to expect. Once they've decided, one tap gives directions straight there. It's built using modern Android tools — Kotlin and Jetpack Compose — which is the current recommended way to build Android apps.</a:t>
+              <a:t>Let me show you every screen in the app. Starting with the top row: this is the Splash Screen, a short loading screen you see when you first open the app. Next is the Home Page, with a search bar and a button to explore nearby restaurants. Then the Login Page and the Registration Page, where a user creates an account or signs back in. After that, the Map Screen, which shows restaurants near the user's real location on a live map. And finally in this row, the Restaurant Detail page, showing the name, rating, distance and type of food. On the second row: the Watch Video screen, where users can preview a restaurant through YouTube or TikTok, the TikTok Link page with a branded preview, the Directions screen with walking, driving and bus options, the Contact Us page, and the Privacy Policy page. Every single one of these screens is fully built and working today.</a:t>
             </a:r>
           </a:p>
         </p:txBody>
@@ -1271,12 +1073,17 @@
             <a:spLocks noGrp="1"/>
           </p:cNvSpPr>
           <p:nvPr>
-            <p:ph type="sldNum" idx="5" sz="quarter"/>
+            <p:ph type="sldNum" sz="quarter" idx="5"/>
           </p:nvPr>
         </p:nvSpPr>
         <p:spPr/>
       </p:sp>
     </p:spTree>
+    <p:extLst>
+      <p:ext uri="{BB962C8B-B14F-4D97-AF65-F5344CB8AC3E}">
+        <p14:creationId xmlns:p14="http://schemas.microsoft.com/office/powerpoint/2010/main" val="927752500"/>
+      </p:ext>
+    </p:extLst>
   </p:cSld>
   <p:clrMapOvr>
     <a:masterClrMapping/>
@@ -1285,7 +1092,7 @@
 </file>
 
 <file path=ppt/notesSlides/notesSlide4.xml><?xml version="1.0" encoding="utf-8"?>
-<p:notes xmlns:a="http://schemas.openxmlformats.org/drawingml/2006/main" xmlns:p="http://schemas.openxmlformats.org/presentationml/2006/main" xmlns:r="http://schemas.openxmlformats.org/officeDocument/2006/relationships">
+<p:notes xmlns:a="http://schemas.openxmlformats.org/drawingml/2006/main" xmlns:r="http://schemas.openxmlformats.org/officeDocument/2006/relationships" xmlns:p="http://schemas.openxmlformats.org/presentationml/2006/main">
   <p:cSld>
     <p:spTree>
       <p:nvGrpSpPr>
@@ -1305,22 +1112,22 @@
         <p:nvSpPr>
           <p:cNvPr id="2" name="Slide Image Placeholder 1"/>
           <p:cNvSpPr>
+            <a:spLocks noGrp="1" noRot="1" noChangeAspect="1"/>
+          </p:cNvSpPr>
+          <p:nvPr>
+            <p:ph type="sldImg" idx="2"/>
+          </p:nvPr>
+        </p:nvSpPr>
+        <p:spPr/>
+      </p:sp>
+      <p:sp>
+        <p:nvSpPr>
+          <p:cNvPr id="3" name="Notes Placeholder 2"/>
+          <p:cNvSpPr>
             <a:spLocks noGrp="1"/>
           </p:cNvSpPr>
           <p:nvPr>
-            <p:ph type="sldImg" idx="2"/>
-          </p:nvPr>
-        </p:nvSpPr>
-        <p:spPr/>
-      </p:sp>
-      <p:sp>
-        <p:nvSpPr>
-          <p:cNvPr id="3" name="Notes Placeholder 2"/>
-          <p:cNvSpPr>
-            <a:spLocks noGrp="1"/>
-          </p:cNvSpPr>
-          <p:nvPr>
-            <p:ph type="body" idx="3" sz="quarter"/>
+            <p:ph type="body" sz="quarter" idx="3"/>
           </p:nvPr>
         </p:nvSpPr>
         <p:spPr/>
@@ -1329,7 +1136,7 @@
           <a:lstStyle/>
           <a:p>
             <a:r>
-              <a:t>Let me show you every screen in the app. Starting with the top row: this is the Splash Screen, a short loading screen you see when you first open the app. Next is the Home Page, with a search bar and a button to explore nearby restaurants. Then the Login Page and the Registration Page, where a user creates an account or signs back in. After that, the Map Screen, which shows restaurants near the user's real location on a live map. And finally in this row, the Restaurant Detail page, showing the name, rating, distance and type of food. On the second row: the Watch Video screen, where users can preview a restaurant through YouTube or TikTok, the TikTok Link page with a branded preview, the Directions screen with walking, driving and bus options, the Contact Us page, and the Privacy Policy page. Every single one of these screens is fully built and working today.</a:t>
+              <a:t>Now let's follow one typical journey through the app. A user opens the app and briefly sees the splash screen while things load. They then log in, register a new account, or simply continue as a guest. From the home page, they can search directly or tap Explore Nearby to jump straight to the map. The map shows restaurants around their real location using the phone's GPS. Tapping a restaurant opens its detail page, with the rating, distance and cuisine type. From there, they can either watch a real video preview of the restaurant, or tap Get Directions to open turn-by-turn navigation straight to the door. Every step connects smoothly to the next — nothing is a dead end.</a:t>
             </a:r>
           </a:p>
         </p:txBody>
@@ -1341,12 +1148,17 @@
             <a:spLocks noGrp="1"/>
           </p:cNvSpPr>
           <p:nvPr>
-            <p:ph type="sldNum" idx="5" sz="quarter"/>
+            <p:ph type="sldNum" sz="quarter" idx="5"/>
           </p:nvPr>
         </p:nvSpPr>
         <p:spPr/>
       </p:sp>
     </p:spTree>
+    <p:extLst>
+      <p:ext uri="{BB962C8B-B14F-4D97-AF65-F5344CB8AC3E}">
+        <p14:creationId xmlns:p14="http://schemas.microsoft.com/office/powerpoint/2010/main" val="17708806"/>
+      </p:ext>
+    </p:extLst>
   </p:cSld>
   <p:clrMapOvr>
     <a:masterClrMapping/>
@@ -1355,7 +1167,7 @@
 </file>
 
 <file path=ppt/notesSlides/notesSlide5.xml><?xml version="1.0" encoding="utf-8"?>
-<p:notes xmlns:a="http://schemas.openxmlformats.org/drawingml/2006/main" xmlns:p="http://schemas.openxmlformats.org/presentationml/2006/main" xmlns:r="http://schemas.openxmlformats.org/officeDocument/2006/relationships">
+<p:notes xmlns:a="http://schemas.openxmlformats.org/drawingml/2006/main" xmlns:r="http://schemas.openxmlformats.org/officeDocument/2006/relationships" xmlns:p="http://schemas.openxmlformats.org/presentationml/2006/main">
   <p:cSld>
     <p:spTree>
       <p:nvGrpSpPr>
@@ -1375,22 +1187,22 @@
         <p:nvSpPr>
           <p:cNvPr id="2" name="Slide Image Placeholder 1"/>
           <p:cNvSpPr>
+            <a:spLocks noGrp="1" noRot="1" noChangeAspect="1"/>
+          </p:cNvSpPr>
+          <p:nvPr>
+            <p:ph type="sldImg" idx="2"/>
+          </p:nvPr>
+        </p:nvSpPr>
+        <p:spPr/>
+      </p:sp>
+      <p:sp>
+        <p:nvSpPr>
+          <p:cNvPr id="3" name="Notes Placeholder 2"/>
+          <p:cNvSpPr>
             <a:spLocks noGrp="1"/>
           </p:cNvSpPr>
           <p:nvPr>
-            <p:ph type="sldImg" idx="2"/>
-          </p:nvPr>
-        </p:nvSpPr>
-        <p:spPr/>
-      </p:sp>
-      <p:sp>
-        <p:nvSpPr>
-          <p:cNvPr id="3" name="Notes Placeholder 2"/>
-          <p:cNvSpPr>
-            <a:spLocks noGrp="1"/>
-          </p:cNvSpPr>
-          <p:nvPr>
-            <p:ph type="body" idx="3" sz="quarter"/>
+            <p:ph type="body" sz="quarter" idx="3"/>
           </p:nvPr>
         </p:nvSpPr>
         <p:spPr/>
@@ -1399,7 +1211,7 @@
           <a:lstStyle/>
           <a:p>
             <a:r>
-              <a:t>Now let's follow one typical journey through the app. A user opens the app and briefly sees the splash screen while things load. They then log in, register a new account, or simply continue as a guest. From the home page, they can search directly or tap Explore Nearby to jump straight to the map. The map shows restaurants around their real location using the phone's GPS. Tapping a restaurant opens its detail page, with the rating, distance and cuisine type. From there, they can either watch a real video preview of the restaurant, or tap Get Directions to open turn-by-turn navigation straight to the door. Every step connects smoothly to the next — nothing is a dead end.</a:t>
+              <a:t>Behind the screens you just saw, there's a real working system underneath. The app uses the phone's GPS to find the user's actual location, not a fixed test location. The map itself is a live Google Map, not an image — it can be zoomed and panned, and it holds real markers for each restaurant. Logging in and registering is handled by a real account system, and this has been tested on an actual physical phone, not just a simulator. Moving between every screen — including pressing back — is handled properly, so a user is never stuck with no way out. When someone taps Watch Video or Get Directions, the app opens the real YouTube, TikTok, or Google Maps app on the phone. And the search bar isn't just decoration — typing into it instantly filters the restaurants shown on the map.</a:t>
             </a:r>
           </a:p>
         </p:txBody>
@@ -1411,12 +1223,17 @@
             <a:spLocks noGrp="1"/>
           </p:cNvSpPr>
           <p:nvPr>
-            <p:ph type="sldNum" idx="5" sz="quarter"/>
+            <p:ph type="sldNum" sz="quarter" idx="5"/>
           </p:nvPr>
         </p:nvSpPr>
         <p:spPr/>
       </p:sp>
     </p:spTree>
+    <p:extLst>
+      <p:ext uri="{BB962C8B-B14F-4D97-AF65-F5344CB8AC3E}">
+        <p14:creationId xmlns:p14="http://schemas.microsoft.com/office/powerpoint/2010/main" val="3704446337"/>
+      </p:ext>
+    </p:extLst>
   </p:cSld>
   <p:clrMapOvr>
     <a:masterClrMapping/>
@@ -1425,7 +1242,7 @@
 </file>
 
 <file path=ppt/notesSlides/notesSlide6.xml><?xml version="1.0" encoding="utf-8"?>
-<p:notes xmlns:a="http://schemas.openxmlformats.org/drawingml/2006/main" xmlns:p="http://schemas.openxmlformats.org/presentationml/2006/main" xmlns:r="http://schemas.openxmlformats.org/officeDocument/2006/relationships">
+<p:notes xmlns:a="http://schemas.openxmlformats.org/drawingml/2006/main" xmlns:r="http://schemas.openxmlformats.org/officeDocument/2006/relationships" xmlns:p="http://schemas.openxmlformats.org/presentationml/2006/main">
   <p:cSld>
     <p:spTree>
       <p:nvGrpSpPr>
@@ -1445,22 +1262,22 @@
         <p:nvSpPr>
           <p:cNvPr id="2" name="Slide Image Placeholder 1"/>
           <p:cNvSpPr>
+            <a:spLocks noGrp="1" noRot="1" noChangeAspect="1"/>
+          </p:cNvSpPr>
+          <p:nvPr>
+            <p:ph type="sldImg" idx="2"/>
+          </p:nvPr>
+        </p:nvSpPr>
+        <p:spPr/>
+      </p:sp>
+      <p:sp>
+        <p:nvSpPr>
+          <p:cNvPr id="3" name="Notes Placeholder 2"/>
+          <p:cNvSpPr>
             <a:spLocks noGrp="1"/>
           </p:cNvSpPr>
           <p:nvPr>
-            <p:ph type="sldImg" idx="2"/>
-          </p:nvPr>
-        </p:nvSpPr>
-        <p:spPr/>
-      </p:sp>
-      <p:sp>
-        <p:nvSpPr>
-          <p:cNvPr id="3" name="Notes Placeholder 2"/>
-          <p:cNvSpPr>
-            <a:spLocks noGrp="1"/>
-          </p:cNvSpPr>
-          <p:nvPr>
-            <p:ph type="body" idx="3" sz="quarter"/>
+            <p:ph type="body" sz="quarter" idx="3"/>
           </p:nvPr>
         </p:nvSpPr>
         <p:spPr/>
@@ -1469,7 +1286,7 @@
           <a:lstStyle/>
           <a:p>
             <a:r>
-              <a:t>Behind the screens you just saw, there's a real working system underneath. The app uses the phone's GPS to find the user's actual location, not a fixed test location. The map itself is a live Google Map, not an image — it can be zoomed and panned, and it holds real markers for each restaurant. Logging in and registering is handled by a real account system, and this has been tested on an actual physical phone, not just a simulator. Moving between every screen — including pressing back — is handled properly, so a user is never stuck with no way out. When someone taps Watch Video or Get Directions, the app opens the real YouTube, TikTok, or Google Maps app on the phone. And the search bar isn't just decoration — typing into it instantly filters the restaurants shown on the map.</a:t>
+              <a:t>Because Spot To Go stores personal accounts, security matters. Registration and login are both connected to a real account system, which keeps passwords and user details stored securely rather than just sitting on the phone. Users who don't want to register can still continue as a guest. To keep the experience personal and safe, the map and restaurant features only unlock once someone is actually signed in. All of this has been tested end-to-end on a real Android phone — registering a new account, logging in, and reaching the map — and it works exactly as intended.</a:t>
             </a:r>
           </a:p>
         </p:txBody>
@@ -1481,12 +1298,17 @@
             <a:spLocks noGrp="1"/>
           </p:cNvSpPr>
           <p:nvPr>
-            <p:ph type="sldNum" idx="5" sz="quarter"/>
+            <p:ph type="sldNum" sz="quarter" idx="5"/>
           </p:nvPr>
         </p:nvSpPr>
         <p:spPr/>
       </p:sp>
     </p:spTree>
+    <p:extLst>
+      <p:ext uri="{BB962C8B-B14F-4D97-AF65-F5344CB8AC3E}">
+        <p14:creationId xmlns:p14="http://schemas.microsoft.com/office/powerpoint/2010/main" val="494911911"/>
+      </p:ext>
+    </p:extLst>
   </p:cSld>
   <p:clrMapOvr>
     <a:masterClrMapping/>
@@ -1495,7 +1317,7 @@
 </file>
 
 <file path=ppt/notesSlides/notesSlide7.xml><?xml version="1.0" encoding="utf-8"?>
-<p:notes xmlns:a="http://schemas.openxmlformats.org/drawingml/2006/main" xmlns:p="http://schemas.openxmlformats.org/presentationml/2006/main" xmlns:r="http://schemas.openxmlformats.org/officeDocument/2006/relationships">
+<p:notes xmlns:a="http://schemas.openxmlformats.org/drawingml/2006/main" xmlns:r="http://schemas.openxmlformats.org/officeDocument/2006/relationships" xmlns:p="http://schemas.openxmlformats.org/presentationml/2006/main">
   <p:cSld>
     <p:spTree>
       <p:nvGrpSpPr>
@@ -1515,22 +1337,22 @@
         <p:nvSpPr>
           <p:cNvPr id="2" name="Slide Image Placeholder 1"/>
           <p:cNvSpPr>
+            <a:spLocks noGrp="1" noRot="1" noChangeAspect="1"/>
+          </p:cNvSpPr>
+          <p:nvPr>
+            <p:ph type="sldImg" idx="2"/>
+          </p:nvPr>
+        </p:nvSpPr>
+        <p:spPr/>
+      </p:sp>
+      <p:sp>
+        <p:nvSpPr>
+          <p:cNvPr id="3" name="Notes Placeholder 2"/>
+          <p:cNvSpPr>
             <a:spLocks noGrp="1"/>
           </p:cNvSpPr>
           <p:nvPr>
-            <p:ph type="sldImg" idx="2"/>
-          </p:nvPr>
-        </p:nvSpPr>
-        <p:spPr/>
-      </p:sp>
-      <p:sp>
-        <p:nvSpPr>
-          <p:cNvPr id="3" name="Notes Placeholder 2"/>
-          <p:cNvSpPr>
-            <a:spLocks noGrp="1"/>
-          </p:cNvSpPr>
-          <p:nvPr>
-            <p:ph type="body" idx="3" sz="quarter"/>
+            <p:ph type="body" sz="quarter" idx="3"/>
           </p:nvPr>
         </p:nvSpPr>
         <p:spPr/>
@@ -1539,7 +1361,7 @@
           <a:lstStyle/>
           <a:p>
             <a:r>
-              <a:t>Because Spot To Go stores personal accounts, security matters. Registration and login are both connected to a real account system, which keeps passwords and user details stored securely rather than just sitting on the phone. Users who don't want to register can still continue as a guest. To keep the experience personal and safe, the map and restaurant features only unlock once someone is actually signed in. All of this has been tested end-to-end on a real Android phone — registering a new account, logging in, and reaching the map — and it works exactly as intended.</a:t>
+              <a:t>To summarise what you've seen today: every screen in Spot To Go is built and working, from the splash screen through to the privacy policy. There's a real login and account system behind it, tested on an actual phone. The map uses the user's real location to show nearby restaurants, and from there, users can preview a restaurant with a real video before deciding to go, then get directions with a single tap. That's Spot To Go so far.</a:t>
             </a:r>
           </a:p>
         </p:txBody>
@@ -1551,12 +1373,17 @@
             <a:spLocks noGrp="1"/>
           </p:cNvSpPr>
           <p:nvPr>
-            <p:ph type="sldNum" idx="5" sz="quarter"/>
+            <p:ph type="sldNum" sz="quarter" idx="5"/>
           </p:nvPr>
         </p:nvSpPr>
         <p:spPr/>
       </p:sp>
     </p:spTree>
+    <p:extLst>
+      <p:ext uri="{BB962C8B-B14F-4D97-AF65-F5344CB8AC3E}">
+        <p14:creationId xmlns:p14="http://schemas.microsoft.com/office/powerpoint/2010/main" val="1739477728"/>
+      </p:ext>
+    </p:extLst>
   </p:cSld>
   <p:clrMapOvr>
     <a:masterClrMapping/>
@@ -1565,7 +1392,7 @@
 </file>
 
 <file path=ppt/notesSlides/notesSlide8.xml><?xml version="1.0" encoding="utf-8"?>
-<p:notes xmlns:a="http://schemas.openxmlformats.org/drawingml/2006/main" xmlns:p="http://schemas.openxmlformats.org/presentationml/2006/main" xmlns:r="http://schemas.openxmlformats.org/officeDocument/2006/relationships">
+<p:notes xmlns:a="http://schemas.openxmlformats.org/drawingml/2006/main" xmlns:r="http://schemas.openxmlformats.org/officeDocument/2006/relationships" xmlns:p="http://schemas.openxmlformats.org/presentationml/2006/main">
   <p:cSld>
     <p:spTree>
       <p:nvGrpSpPr>
@@ -1585,22 +1412,22 @@
         <p:nvSpPr>
           <p:cNvPr id="2" name="Slide Image Placeholder 1"/>
           <p:cNvSpPr>
+            <a:spLocks noGrp="1" noRot="1" noChangeAspect="1"/>
+          </p:cNvSpPr>
+          <p:nvPr>
+            <p:ph type="sldImg" idx="2"/>
+          </p:nvPr>
+        </p:nvSpPr>
+        <p:spPr/>
+      </p:sp>
+      <p:sp>
+        <p:nvSpPr>
+          <p:cNvPr id="3" name="Notes Placeholder 2"/>
+          <p:cNvSpPr>
             <a:spLocks noGrp="1"/>
           </p:cNvSpPr>
           <p:nvPr>
-            <p:ph type="sldImg" idx="2"/>
-          </p:nvPr>
-        </p:nvSpPr>
-        <p:spPr/>
-      </p:sp>
-      <p:sp>
-        <p:nvSpPr>
-          <p:cNvPr id="3" name="Notes Placeholder 2"/>
-          <p:cNvSpPr>
-            <a:spLocks noGrp="1"/>
-          </p:cNvSpPr>
-          <p:nvPr>
-            <p:ph type="body" idx="3" sz="quarter"/>
+            <p:ph type="body" sz="quarter" idx="3"/>
           </p:nvPr>
         </p:nvSpPr>
         <p:spPr/>
@@ -1609,7 +1436,7 @@
           <a:lstStyle/>
           <a:p>
             <a:r>
-              <a:t>To summarise what you've seen today: every screen in Spot To Go is built and working, from the splash screen through to the privacy policy. There's a real login and account system behind it, tested on an actual phone. The map uses the user's real location to show nearby restaurants, and from there, users can preview a restaurant with a real video before deciding to go, then get directions with a single tap. That's Spot To Go so far.</a:t>
+              <a:t>So what comes next? Right now, the restaurants you saw on the map are a small sample set used to build and test every screen properly. The next step is to connect the map to real, live restaurant listings near the user, so the same experience you just saw works with genuine, up-to-date places. Once that's in place, the search bar will pull its results from those live listings directly, instead of filtering the sample set. Alongside that, there's one small polish item: pressing back on the map currently closes the app straight away, and we'll add a simple safeguard so that doesn't happen by accident. That's the plan for the next stage of Spot To Go. Thank you.</a:t>
             </a:r>
           </a:p>
         </p:txBody>
@@ -1621,82 +1448,17 @@
             <a:spLocks noGrp="1"/>
           </p:cNvSpPr>
           <p:nvPr>
-            <p:ph type="sldNum" idx="5" sz="quarter"/>
+            <p:ph type="sldNum" sz="quarter" idx="5"/>
           </p:nvPr>
         </p:nvSpPr>
         <p:spPr/>
       </p:sp>
     </p:spTree>
-  </p:cSld>
-  <p:clrMapOvr>
-    <a:masterClrMapping/>
-  </p:clrMapOvr>
-</p:notes>
-</file>
-
-<file path=ppt/notesSlides/notesSlide9.xml><?xml version="1.0" encoding="utf-8"?>
-<p:notes xmlns:a="http://schemas.openxmlformats.org/drawingml/2006/main" xmlns:p="http://schemas.openxmlformats.org/presentationml/2006/main" xmlns:r="http://schemas.openxmlformats.org/officeDocument/2006/relationships">
-  <p:cSld>
-    <p:spTree>
-      <p:nvGrpSpPr>
-        <p:cNvPr id="1" name=""/>
-        <p:cNvGrpSpPr/>
-        <p:nvPr/>
-      </p:nvGrpSpPr>
-      <p:grpSpPr>
-        <a:xfrm>
-          <a:off x="0" y="0"/>
-          <a:ext cx="0" cy="0"/>
-          <a:chOff x="0" y="0"/>
-          <a:chExt cx="0" cy="0"/>
-        </a:xfrm>
-      </p:grpSpPr>
-      <p:sp>
-        <p:nvSpPr>
-          <p:cNvPr id="2" name="Slide Image Placeholder 1"/>
-          <p:cNvSpPr>
-            <a:spLocks noGrp="1"/>
-          </p:cNvSpPr>
-          <p:nvPr>
-            <p:ph type="sldImg" idx="2"/>
-          </p:nvPr>
-        </p:nvSpPr>
-        <p:spPr/>
-      </p:sp>
-      <p:sp>
-        <p:nvSpPr>
-          <p:cNvPr id="3" name="Notes Placeholder 2"/>
-          <p:cNvSpPr>
-            <a:spLocks noGrp="1"/>
-          </p:cNvSpPr>
-          <p:nvPr>
-            <p:ph type="body" idx="3" sz="quarter"/>
-          </p:nvPr>
-        </p:nvSpPr>
-        <p:spPr/>
-        <p:txBody>
-          <a:bodyPr/>
-          <a:lstStyle/>
-          <a:p>
-            <a:r>
-              <a:t>So what comes next? Right now, the restaurants you saw on the map are a small sample set used to build and test every screen properly. The next step is to connect the map to real, live restaurant listings near the user, so the same experience you just saw works with genuine, up-to-date places. Once that's in place, the search bar will pull its results from those live listings directly, instead of filtering the sample set. Alongside that, there's one small polish item: pressing back on the map currently closes the app straight away, and we'll add a simple safeguard so that doesn't happen by accident. That's the plan for the next stage of Spot To Go. Thank you.</a:t>
-            </a:r>
-          </a:p>
-        </p:txBody>
-      </p:sp>
-      <p:sp>
-        <p:nvSpPr>
-          <p:cNvPr id="4" name="Slide Number Placeholder 3"/>
-          <p:cNvSpPr>
-            <a:spLocks noGrp="1"/>
-          </p:cNvSpPr>
-          <p:nvPr>
-            <p:ph type="sldNum" idx="5" sz="quarter"/>
-          </p:nvPr>
-        </p:nvSpPr>
-        <p:spPr/>
-      </p:sp>
-    </p:spTree>
+    <p:extLst>
+      <p:ext uri="{BB962C8B-B14F-4D97-AF65-F5344CB8AC3E}">
+        <p14:creationId xmlns:p14="http://schemas.microsoft.com/office/powerpoint/2010/main" val="3954423203"/>
+      </p:ext>
+    </p:extLst>
   </p:cSld>
   <p:clrMapOvr>
     <a:masterClrMapping/>
@@ -4417,7 +4179,9 @@
               </a:defRPr>
             </a:lvl9pPr>
           </a:lstStyle>
-          <a:p/>
+          <a:p>
+            <a:endParaRPr/>
+          </a:p>
         </p:txBody>
       </p:sp>
       <p:sp>
@@ -4637,10 +4401,18 @@
           <a:lstStyle/>
           <a:p>
             <a:r>
-              <a:t>Nagenthiran Nagarajah</a:t>
-            </a:r>
-            <a:br/>
-            <a:r>
+              <a:rPr lang="en-US" dirty="0" err="1" smtClean="0"/>
+              <a:t>Paithiyam</a:t>
+            </a:r>
+            <a:r>
+              <a:rPr dirty="0"/>
+              <a:t/>
+            </a:r>
+            <a:br>
+              <a:rPr dirty="0"/>
+            </a:br>
+            <a:r>
+              <a:rPr dirty="0"/>
               <a:t>University of East Anglia</a:t>
             </a:r>
           </a:p>
@@ -4650,756 +4422,6 @@
     <p:extLst>
       <p:ext uri="{BB962C8B-B14F-4D97-AF65-F5344CB8AC3E}">
         <p14:creationId xmlns:p14="http://schemas.microsoft.com/office/powerpoint/2010/main" val="3093261743"/>
-      </p:ext>
-    </p:extLst>
-  </p:cSld>
-  <p:clrMapOvr>
-    <a:masterClrMapping/>
-  </p:clrMapOvr>
-</p:sld>
-</file>
-
-<file path=ppt/slides/slide10.xml><?xml version="1.0" encoding="utf-8"?>
-<p:sld xmlns:a="http://schemas.openxmlformats.org/drawingml/2006/main" xmlns:r="http://schemas.openxmlformats.org/officeDocument/2006/relationships" xmlns:p="http://schemas.openxmlformats.org/presentationml/2006/main">
-  <p:cSld>
-    <p:spTree>
-      <p:nvGrpSpPr>
-        <p:cNvPr id="1" name=""/>
-        <p:cNvGrpSpPr/>
-        <p:nvPr/>
-      </p:nvGrpSpPr>
-      <p:grpSpPr>
-        <a:xfrm>
-          <a:off x="0" y="0"/>
-          <a:ext cx="0" cy="0"/>
-          <a:chOff x="0" y="0"/>
-          <a:chExt cx="0" cy="0"/>
-        </a:xfrm>
-      </p:grpSpPr>
-      <p:sp>
-        <p:nvSpPr>
-          <p:cNvPr id="2" name="Title 1"/>
-          <p:cNvSpPr>
-            <a:spLocks noGrp="1"/>
-          </p:cNvSpPr>
-          <p:nvPr>
-            <p:ph type="title"/>
-          </p:nvPr>
-        </p:nvSpPr>
-        <p:spPr/>
-        <p:txBody>
-          <a:bodyPr/>
-          <a:lstStyle/>
-          <a:p>
-            <a:r>
-              <a:rPr lang="en-US" altLang="zh-TW" sz="2800" dirty="0"/>
-              <a:t>Progress Overview For The Last Week</a:t>
-            </a:r>
-            <a:endParaRPr lang="zh-TW" altLang="en-US" sz="2800" dirty="0"/>
-          </a:p>
-        </p:txBody>
-      </p:sp>
-      <p:sp>
-        <p:nvSpPr>
-          <p:cNvPr id="3" name="Content Placeholder 2"/>
-          <p:cNvSpPr>
-            <a:spLocks noGrp="1"/>
-          </p:cNvSpPr>
-          <p:nvPr>
-            <p:ph idx="1"/>
-          </p:nvPr>
-        </p:nvSpPr>
-        <p:spPr/>
-        <p:txBody>
-          <a:bodyPr/>
-          <a:lstStyle/>
-          <a:p>
-            <a:r>
-              <a:rPr lang="en-US" altLang="zh-TW" strike="sngStrike" dirty="0">
-                <a:solidFill>
-                  <a:schemeClr val="bg1">
-                    <a:lumMod val="65000"/>
-                  </a:schemeClr>
-                </a:solidFill>
-              </a:rPr>
-              <a:t>Task one  </a:t>
-            </a:r>
-          </a:p>
-          <a:p>
-            <a:pPr lvl="1"/>
-            <a:r>
-              <a:rPr lang="en-GB" altLang="zh-TW" dirty="0">
-                <a:solidFill>
-                  <a:srgbClr val="C00000"/>
-                </a:solidFill>
-              </a:rPr>
-              <a:t>In this slide, please use strike line and grey </a:t>
-            </a:r>
-            <a:r>
-              <a:rPr lang="en-GB" altLang="zh-TW" dirty="0" err="1">
-                <a:solidFill>
-                  <a:srgbClr val="C00000"/>
-                </a:solidFill>
-              </a:rPr>
-              <a:t>color</a:t>
-            </a:r>
-            <a:r>
-              <a:rPr lang="en-GB" altLang="zh-TW" dirty="0">
-                <a:solidFill>
-                  <a:srgbClr val="C00000"/>
-                </a:solidFill>
-              </a:rPr>
-              <a:t> to mark finished tasks</a:t>
-            </a:r>
-          </a:p>
-          <a:p>
-            <a:pPr lvl="1"/>
-            <a:r>
-              <a:rPr lang="en-US" altLang="zh-TW" strike="sngStrike" dirty="0">
-                <a:solidFill>
-                  <a:schemeClr val="bg1">
-                    <a:lumMod val="65000"/>
-                  </a:schemeClr>
-                </a:solidFill>
-              </a:rPr>
-              <a:t>Subtask 2</a:t>
-            </a:r>
-          </a:p>
-          <a:p>
-            <a:r>
-              <a:rPr lang="en-US" altLang="zh-TW" strike="sngStrike" dirty="0">
-                <a:solidFill>
-                  <a:schemeClr val="bg1">
-                    <a:lumMod val="65000"/>
-                  </a:schemeClr>
-                </a:solidFill>
-              </a:rPr>
-              <a:t>Task two</a:t>
-            </a:r>
-          </a:p>
-          <a:p>
-            <a:pPr lvl="1"/>
-            <a:r>
-              <a:rPr lang="en-US" altLang="zh-TW" strike="sngStrike" dirty="0">
-                <a:solidFill>
-                  <a:schemeClr val="bg1">
-                    <a:lumMod val="65000"/>
-                  </a:schemeClr>
-                </a:solidFill>
-              </a:rPr>
-              <a:t>Subtask 1</a:t>
-            </a:r>
-          </a:p>
-          <a:p>
-            <a:pPr lvl="1"/>
-            <a:r>
-              <a:rPr lang="en-US" altLang="zh-TW" dirty="0"/>
-              <a:t>Subtask 2</a:t>
-            </a:r>
-          </a:p>
-          <a:p>
-            <a:r>
-              <a:rPr lang="en-US" altLang="zh-TW" strike="sngStrike" dirty="0">
-                <a:solidFill>
-                  <a:schemeClr val="bg1">
-                    <a:lumMod val="65000"/>
-                  </a:schemeClr>
-                </a:solidFill>
-              </a:rPr>
-              <a:t>Task three</a:t>
-            </a:r>
-          </a:p>
-          <a:p>
-            <a:pPr lvl="1"/>
-            <a:r>
-              <a:rPr lang="en-US" altLang="zh-TW" strike="sngStrike" dirty="0">
-                <a:solidFill>
-                  <a:schemeClr val="bg1">
-                    <a:lumMod val="65000"/>
-                  </a:schemeClr>
-                </a:solidFill>
-              </a:rPr>
-              <a:t>Subtask 1</a:t>
-            </a:r>
-          </a:p>
-          <a:p>
-            <a:pPr lvl="1"/>
-            <a:r>
-              <a:rPr lang="en-US" altLang="zh-TW" strike="sngStrike" dirty="0">
-                <a:solidFill>
-                  <a:schemeClr val="bg1">
-                    <a:lumMod val="65000"/>
-                  </a:schemeClr>
-                </a:solidFill>
-              </a:rPr>
-              <a:t>Subtask 2</a:t>
-            </a:r>
-          </a:p>
-          <a:p>
-            <a:endParaRPr lang="zh-TW" altLang="en-US" dirty="0"/>
-          </a:p>
-        </p:txBody>
-      </p:sp>
-      <p:sp>
-        <p:nvSpPr>
-          <p:cNvPr id="4" name="Date Placeholder 3"/>
-          <p:cNvSpPr>
-            <a:spLocks noGrp="1"/>
-          </p:cNvSpPr>
-          <p:nvPr>
-            <p:ph type="dt" sz="half" idx="10"/>
-          </p:nvPr>
-        </p:nvSpPr>
-        <p:spPr/>
-        <p:txBody>
-          <a:bodyPr/>
-          <a:lstStyle/>
-          <a:p>
-            <a:pPr>
-              <a:defRPr/>
-            </a:pPr>
-            <a:fld id="{476C0DD9-7BCE-4413-BE54-9A75DE555C7B}" type="datetime1">
-              <a:rPr lang="en-US" altLang="zh-TW" smtClean="0"/>
-              <a:pPr>
-                <a:defRPr/>
-              </a:pPr>
-              <a:t>10/9/2025</a:t>
-            </a:fld>
-            <a:endParaRPr lang="zh-TW" altLang="en-US"/>
-          </a:p>
-        </p:txBody>
-      </p:sp>
-      <p:sp>
-        <p:nvSpPr>
-          <p:cNvPr id="5" name="Slide Number Placeholder 4"/>
-          <p:cNvSpPr>
-            <a:spLocks noGrp="1"/>
-          </p:cNvSpPr>
-          <p:nvPr>
-            <p:ph type="sldNum" sz="quarter" idx="12"/>
-          </p:nvPr>
-        </p:nvSpPr>
-        <p:spPr/>
-        <p:txBody>
-          <a:bodyPr/>
-          <a:lstStyle/>
-          <a:p>
-            <a:pPr>
-              <a:defRPr/>
-            </a:pPr>
-            <a:fld id="{8AF5A669-E021-420B-B33A-88CB5B8E39F6}" type="slidenum">
-              <a:rPr lang="zh-TW" altLang="en-US" smtClean="0"/>
-              <a:pPr>
-                <a:defRPr/>
-              </a:pPr>
-              <a:t>10</a:t>
-            </a:fld>
-            <a:endParaRPr lang="zh-TW" altLang="en-US"/>
-          </a:p>
-        </p:txBody>
-      </p:sp>
-    </p:spTree>
-    <p:extLst>
-      <p:ext uri="{BB962C8B-B14F-4D97-AF65-F5344CB8AC3E}">
-        <p14:creationId xmlns:p14="http://schemas.microsoft.com/office/powerpoint/2010/main" val="379363086"/>
-      </p:ext>
-    </p:extLst>
-  </p:cSld>
-  <p:clrMapOvr>
-    <a:masterClrMapping/>
-  </p:clrMapOvr>
-</p:sld>
-</file>
-
-<file path=ppt/slides/slide11.xml><?xml version="1.0" encoding="utf-8"?>
-<p:sld xmlns:a="http://schemas.openxmlformats.org/drawingml/2006/main" xmlns:r="http://schemas.openxmlformats.org/officeDocument/2006/relationships" xmlns:p="http://schemas.openxmlformats.org/presentationml/2006/main">
-  <p:cSld>
-    <p:spTree>
-      <p:nvGrpSpPr>
-        <p:cNvPr id="1" name=""/>
-        <p:cNvGrpSpPr/>
-        <p:nvPr/>
-      </p:nvGrpSpPr>
-      <p:grpSpPr>
-        <a:xfrm>
-          <a:off x="0" y="0"/>
-          <a:ext cx="0" cy="0"/>
-          <a:chOff x="0" y="0"/>
-          <a:chExt cx="0" cy="0"/>
-        </a:xfrm>
-      </p:grpSpPr>
-      <p:sp>
-        <p:nvSpPr>
-          <p:cNvPr id="2" name="Title 1"/>
-          <p:cNvSpPr>
-            <a:spLocks noGrp="1"/>
-          </p:cNvSpPr>
-          <p:nvPr>
-            <p:ph type="title"/>
-          </p:nvPr>
-        </p:nvSpPr>
-        <p:spPr/>
-        <p:txBody>
-          <a:bodyPr/>
-          <a:lstStyle/>
-          <a:p>
-            <a:r>
-              <a:rPr lang="en-US" altLang="zh-TW" dirty="0"/>
-              <a:t>Progress For The Last Week</a:t>
-            </a:r>
-            <a:endParaRPr lang="zh-TW" altLang="en-US" dirty="0"/>
-          </a:p>
-        </p:txBody>
-      </p:sp>
-      <p:sp>
-        <p:nvSpPr>
-          <p:cNvPr id="3" name="Content Placeholder 2"/>
-          <p:cNvSpPr>
-            <a:spLocks noGrp="1"/>
-          </p:cNvSpPr>
-          <p:nvPr>
-            <p:ph idx="1"/>
-          </p:nvPr>
-        </p:nvSpPr>
-        <p:spPr/>
-        <p:txBody>
-          <a:bodyPr/>
-          <a:lstStyle/>
-          <a:p>
-            <a:r>
-              <a:rPr lang="en-US" altLang="zh-TW" dirty="0"/>
-              <a:t>Task one…..</a:t>
-            </a:r>
-          </a:p>
-          <a:p>
-            <a:r>
-              <a:rPr lang="en-US" altLang="zh-TW" dirty="0">
-                <a:solidFill>
-                  <a:srgbClr val="C00000"/>
-                </a:solidFill>
-              </a:rPr>
-              <a:t>In this slide, please explain finished task one in detail.</a:t>
-            </a:r>
-            <a:endParaRPr lang="zh-TW" altLang="en-US" dirty="0">
-              <a:solidFill>
-                <a:srgbClr val="C00000"/>
-              </a:solidFill>
-            </a:endParaRPr>
-          </a:p>
-        </p:txBody>
-      </p:sp>
-      <p:sp>
-        <p:nvSpPr>
-          <p:cNvPr id="4" name="Date Placeholder 3"/>
-          <p:cNvSpPr>
-            <a:spLocks noGrp="1"/>
-          </p:cNvSpPr>
-          <p:nvPr>
-            <p:ph type="dt" sz="half" idx="10"/>
-          </p:nvPr>
-        </p:nvSpPr>
-        <p:spPr/>
-        <p:txBody>
-          <a:bodyPr/>
-          <a:lstStyle/>
-          <a:p>
-            <a:pPr>
-              <a:defRPr/>
-            </a:pPr>
-            <a:fld id="{476C0DD9-7BCE-4413-BE54-9A75DE555C7B}" type="datetime1">
-              <a:rPr lang="en-US" altLang="zh-TW" smtClean="0"/>
-              <a:pPr>
-                <a:defRPr/>
-              </a:pPr>
-              <a:t>10/9/2025</a:t>
-            </a:fld>
-            <a:endParaRPr lang="zh-TW" altLang="en-US"/>
-          </a:p>
-        </p:txBody>
-      </p:sp>
-      <p:sp>
-        <p:nvSpPr>
-          <p:cNvPr id="5" name="Slide Number Placeholder 4"/>
-          <p:cNvSpPr>
-            <a:spLocks noGrp="1"/>
-          </p:cNvSpPr>
-          <p:nvPr>
-            <p:ph type="sldNum" sz="quarter" idx="12"/>
-          </p:nvPr>
-        </p:nvSpPr>
-        <p:spPr/>
-        <p:txBody>
-          <a:bodyPr/>
-          <a:lstStyle/>
-          <a:p>
-            <a:pPr>
-              <a:defRPr/>
-            </a:pPr>
-            <a:fld id="{8AF5A669-E021-420B-B33A-88CB5B8E39F6}" type="slidenum">
-              <a:rPr lang="zh-TW" altLang="en-US" smtClean="0"/>
-              <a:pPr>
-                <a:defRPr/>
-              </a:pPr>
-              <a:t>11</a:t>
-            </a:fld>
-            <a:endParaRPr lang="zh-TW" altLang="en-US"/>
-          </a:p>
-        </p:txBody>
-      </p:sp>
-    </p:spTree>
-    <p:extLst>
-      <p:ext uri="{BB962C8B-B14F-4D97-AF65-F5344CB8AC3E}">
-        <p14:creationId xmlns:p14="http://schemas.microsoft.com/office/powerpoint/2010/main" val="3105693836"/>
-      </p:ext>
-    </p:extLst>
-  </p:cSld>
-  <p:clrMapOvr>
-    <a:masterClrMapping/>
-  </p:clrMapOvr>
-</p:sld>
-</file>
-
-<file path=ppt/slides/slide12.xml><?xml version="1.0" encoding="utf-8"?>
-<p:sld xmlns:a="http://schemas.openxmlformats.org/drawingml/2006/main" xmlns:r="http://schemas.openxmlformats.org/officeDocument/2006/relationships" xmlns:p="http://schemas.openxmlformats.org/presentationml/2006/main">
-  <p:cSld>
-    <p:spTree>
-      <p:nvGrpSpPr>
-        <p:cNvPr id="1" name=""/>
-        <p:cNvGrpSpPr/>
-        <p:nvPr/>
-      </p:nvGrpSpPr>
-      <p:grpSpPr>
-        <a:xfrm>
-          <a:off x="0" y="0"/>
-          <a:ext cx="0" cy="0"/>
-          <a:chOff x="0" y="0"/>
-          <a:chExt cx="0" cy="0"/>
-        </a:xfrm>
-      </p:grpSpPr>
-      <p:sp>
-        <p:nvSpPr>
-          <p:cNvPr id="2" name="Title 1"/>
-          <p:cNvSpPr>
-            <a:spLocks noGrp="1"/>
-          </p:cNvSpPr>
-          <p:nvPr>
-            <p:ph type="title"/>
-          </p:nvPr>
-        </p:nvSpPr>
-        <p:spPr/>
-        <p:txBody>
-          <a:bodyPr/>
-          <a:lstStyle/>
-          <a:p>
-            <a:r>
-              <a:rPr lang="en-US" altLang="zh-TW" sz="3200" dirty="0"/>
-              <a:t>Progress For The Last Week (cont.)</a:t>
-            </a:r>
-            <a:endParaRPr lang="zh-TW" altLang="en-US" dirty="0"/>
-          </a:p>
-        </p:txBody>
-      </p:sp>
-      <p:sp>
-        <p:nvSpPr>
-          <p:cNvPr id="3" name="Content Placeholder 2"/>
-          <p:cNvSpPr>
-            <a:spLocks noGrp="1"/>
-          </p:cNvSpPr>
-          <p:nvPr>
-            <p:ph idx="1"/>
-          </p:nvPr>
-        </p:nvSpPr>
-        <p:spPr/>
-        <p:txBody>
-          <a:bodyPr/>
-          <a:lstStyle/>
-          <a:p>
-            <a:r>
-              <a:rPr lang="en-US" altLang="zh-TW" dirty="0"/>
-              <a:t>Task two…</a:t>
-            </a:r>
-          </a:p>
-          <a:p>
-            <a:r>
-              <a:rPr lang="en-GB" altLang="zh-TW" dirty="0">
-                <a:solidFill>
-                  <a:srgbClr val="C00000"/>
-                </a:solidFill>
-              </a:rPr>
-              <a:t>In this slide, please explain finished task two in detail.</a:t>
-            </a:r>
-            <a:endParaRPr lang="zh-TW" altLang="en-US" dirty="0">
-              <a:solidFill>
-                <a:srgbClr val="C00000"/>
-              </a:solidFill>
-            </a:endParaRPr>
-          </a:p>
-        </p:txBody>
-      </p:sp>
-      <p:sp>
-        <p:nvSpPr>
-          <p:cNvPr id="4" name="Date Placeholder 3"/>
-          <p:cNvSpPr>
-            <a:spLocks noGrp="1"/>
-          </p:cNvSpPr>
-          <p:nvPr>
-            <p:ph type="dt" sz="half" idx="10"/>
-          </p:nvPr>
-        </p:nvSpPr>
-        <p:spPr/>
-        <p:txBody>
-          <a:bodyPr/>
-          <a:lstStyle/>
-          <a:p>
-            <a:pPr>
-              <a:defRPr/>
-            </a:pPr>
-            <a:fld id="{476C0DD9-7BCE-4413-BE54-9A75DE555C7B}" type="datetime1">
-              <a:rPr lang="en-US" altLang="zh-TW" smtClean="0"/>
-              <a:pPr>
-                <a:defRPr/>
-              </a:pPr>
-              <a:t>10/9/2025</a:t>
-            </a:fld>
-            <a:endParaRPr lang="zh-TW" altLang="en-US"/>
-          </a:p>
-        </p:txBody>
-      </p:sp>
-      <p:sp>
-        <p:nvSpPr>
-          <p:cNvPr id="5" name="Slide Number Placeholder 4"/>
-          <p:cNvSpPr>
-            <a:spLocks noGrp="1"/>
-          </p:cNvSpPr>
-          <p:nvPr>
-            <p:ph type="sldNum" sz="quarter" idx="12"/>
-          </p:nvPr>
-        </p:nvSpPr>
-        <p:spPr/>
-        <p:txBody>
-          <a:bodyPr/>
-          <a:lstStyle/>
-          <a:p>
-            <a:pPr>
-              <a:defRPr/>
-            </a:pPr>
-            <a:fld id="{8AF5A669-E021-420B-B33A-88CB5B8E39F6}" type="slidenum">
-              <a:rPr lang="zh-TW" altLang="en-US" smtClean="0"/>
-              <a:pPr>
-                <a:defRPr/>
-              </a:pPr>
-              <a:t>12</a:t>
-            </a:fld>
-            <a:endParaRPr lang="zh-TW" altLang="en-US"/>
-          </a:p>
-        </p:txBody>
-      </p:sp>
-    </p:spTree>
-    <p:extLst>
-      <p:ext uri="{BB962C8B-B14F-4D97-AF65-F5344CB8AC3E}">
-        <p14:creationId xmlns:p14="http://schemas.microsoft.com/office/powerpoint/2010/main" val="312794099"/>
-      </p:ext>
-    </p:extLst>
-  </p:cSld>
-  <p:clrMapOvr>
-    <a:masterClrMapping/>
-  </p:clrMapOvr>
-</p:sld>
-</file>
-
-<file path=ppt/slides/slide13.xml><?xml version="1.0" encoding="utf-8"?>
-<p:sld xmlns:a="http://schemas.openxmlformats.org/drawingml/2006/main" xmlns:r="http://schemas.openxmlformats.org/officeDocument/2006/relationships" xmlns:p="http://schemas.openxmlformats.org/presentationml/2006/main">
-  <p:cSld>
-    <p:spTree>
-      <p:nvGrpSpPr>
-        <p:cNvPr id="1" name=""/>
-        <p:cNvGrpSpPr/>
-        <p:nvPr/>
-      </p:nvGrpSpPr>
-      <p:grpSpPr>
-        <a:xfrm>
-          <a:off x="0" y="0"/>
-          <a:ext cx="0" cy="0"/>
-          <a:chOff x="0" y="0"/>
-          <a:chExt cx="0" cy="0"/>
-        </a:xfrm>
-      </p:grpSpPr>
-      <p:sp>
-        <p:nvSpPr>
-          <p:cNvPr id="2" name="Title 1"/>
-          <p:cNvSpPr>
-            <a:spLocks noGrp="1"/>
-          </p:cNvSpPr>
-          <p:nvPr>
-            <p:ph type="title"/>
-          </p:nvPr>
-        </p:nvSpPr>
-        <p:spPr/>
-        <p:txBody>
-          <a:bodyPr/>
-          <a:lstStyle/>
-          <a:p>
-            <a:r>
-              <a:rPr lang="en-US" altLang="zh-TW" dirty="0"/>
-              <a:t>Actions for the Next Week</a:t>
-            </a:r>
-            <a:endParaRPr lang="zh-TW" altLang="en-US" dirty="0"/>
-          </a:p>
-        </p:txBody>
-      </p:sp>
-      <p:sp>
-        <p:nvSpPr>
-          <p:cNvPr id="3" name="Content Placeholder 2"/>
-          <p:cNvSpPr>
-            <a:spLocks noGrp="1"/>
-          </p:cNvSpPr>
-          <p:nvPr>
-            <p:ph idx="1"/>
-          </p:nvPr>
-        </p:nvSpPr>
-        <p:spPr/>
-        <p:txBody>
-          <a:bodyPr/>
-          <a:lstStyle/>
-          <a:p>
-            <a:r>
-              <a:rPr lang="en-US" altLang="zh-TW" dirty="0"/>
-              <a:t>Milestones</a:t>
-            </a:r>
-          </a:p>
-          <a:p>
-            <a:pPr lvl="1"/>
-            <a:r>
-              <a:rPr lang="en-US" altLang="zh-TW" dirty="0"/>
-              <a:t>Proposal?</a:t>
-            </a:r>
-          </a:p>
-          <a:p>
-            <a:pPr lvl="1"/>
-            <a:r>
-              <a:rPr lang="en-US" altLang="zh-TW" dirty="0"/>
-              <a:t>Progress report?</a:t>
-            </a:r>
-          </a:p>
-          <a:p>
-            <a:pPr lvl="1"/>
-            <a:r>
-              <a:rPr lang="en-US" altLang="zh-TW" dirty="0"/>
-              <a:t>Project Inspection/report submission?</a:t>
-            </a:r>
-          </a:p>
-          <a:p>
-            <a:r>
-              <a:rPr lang="en-US" altLang="zh-TW" dirty="0"/>
-              <a:t>Regular meetings with Eden (Edwin joins once per two weeks)</a:t>
-            </a:r>
-          </a:p>
-          <a:p>
-            <a:pPr lvl="1"/>
-            <a:r>
-              <a:rPr lang="en-US" altLang="zh-TW" dirty="0"/>
-              <a:t>4pm Thursday</a:t>
-            </a:r>
-          </a:p>
-          <a:p>
-            <a:r>
-              <a:rPr lang="en-US" altLang="zh-TW" dirty="0"/>
-              <a:t>Use the progress report template</a:t>
-            </a:r>
-          </a:p>
-          <a:p>
-            <a:r>
-              <a:rPr lang="en-US" altLang="zh-TW" dirty="0"/>
-              <a:t>Spend some time to know the project</a:t>
-            </a:r>
-          </a:p>
-          <a:p>
-            <a:r>
-              <a:rPr lang="en-US" altLang="zh-TW" dirty="0"/>
-              <a:t>Eden share the zip file to Max and Richard</a:t>
-            </a:r>
-          </a:p>
-          <a:p>
-            <a:r>
-              <a:rPr lang="en-US" altLang="zh-TW" dirty="0"/>
-              <a:t>Send GitHub account to Eden</a:t>
-            </a:r>
-          </a:p>
-          <a:p>
-            <a:pPr lvl="1"/>
-            <a:r>
-              <a:rPr lang="en-US" altLang="zh-TW" dirty="0"/>
-              <a:t>Eden shares GitHub to them</a:t>
-            </a:r>
-          </a:p>
-          <a:p>
-            <a:pPr lvl="1"/>
-            <a:endParaRPr lang="en-US" altLang="zh-TW" dirty="0"/>
-          </a:p>
-        </p:txBody>
-      </p:sp>
-      <p:sp>
-        <p:nvSpPr>
-          <p:cNvPr id="4" name="Date Placeholder 3"/>
-          <p:cNvSpPr>
-            <a:spLocks noGrp="1"/>
-          </p:cNvSpPr>
-          <p:nvPr>
-            <p:ph type="dt" sz="half" idx="10"/>
-          </p:nvPr>
-        </p:nvSpPr>
-        <p:spPr/>
-        <p:txBody>
-          <a:bodyPr/>
-          <a:lstStyle/>
-          <a:p>
-            <a:pPr>
-              <a:defRPr/>
-            </a:pPr>
-            <a:fld id="{476C0DD9-7BCE-4413-BE54-9A75DE555C7B}" type="datetime1">
-              <a:rPr lang="en-US" altLang="zh-TW" smtClean="0"/>
-              <a:pPr>
-                <a:defRPr/>
-              </a:pPr>
-              <a:t>10/9/2025</a:t>
-            </a:fld>
-            <a:endParaRPr lang="zh-TW" altLang="en-US"/>
-          </a:p>
-        </p:txBody>
-      </p:sp>
-      <p:sp>
-        <p:nvSpPr>
-          <p:cNvPr id="5" name="Slide Number Placeholder 4"/>
-          <p:cNvSpPr>
-            <a:spLocks noGrp="1"/>
-          </p:cNvSpPr>
-          <p:nvPr>
-            <p:ph type="sldNum" sz="quarter" idx="12"/>
-          </p:nvPr>
-        </p:nvSpPr>
-        <p:spPr/>
-        <p:txBody>
-          <a:bodyPr/>
-          <a:lstStyle/>
-          <a:p>
-            <a:pPr>
-              <a:defRPr/>
-            </a:pPr>
-            <a:fld id="{8AF5A669-E021-420B-B33A-88CB5B8E39F6}" type="slidenum">
-              <a:rPr lang="zh-TW" altLang="en-US" smtClean="0"/>
-              <a:pPr>
-                <a:defRPr/>
-              </a:pPr>
-              <a:t>13</a:t>
-            </a:fld>
-            <a:endParaRPr lang="zh-TW" altLang="en-US" dirty="0"/>
-          </a:p>
-        </p:txBody>
-      </p:sp>
-    </p:spTree>
-    <p:extLst>
-      <p:ext uri="{BB962C8B-B14F-4D97-AF65-F5344CB8AC3E}">
-        <p14:creationId xmlns:p14="http://schemas.microsoft.com/office/powerpoint/2010/main" val="3853517451"/>
       </p:ext>
     </p:extLst>
   </p:cSld>
@@ -5463,37 +4485,32 @@
           <a:bodyPr/>
           <a:lstStyle/>
           <a:p>
-            <a:pPr/>
-            <a:r>
-              <a:rPr b="0" i="0" sz="1400"/>
+            <a:r>
+              <a:rPr sz="1400" b="0" i="0"/>
               <a:t>Helps users discover restaurants near their current location</a:t>
             </a:r>
           </a:p>
           <a:p>
-            <a:pPr/>
-            <a:r>
-              <a:rPr b="0" i="0" sz="1400"/>
+            <a:r>
+              <a:rPr sz="1400" b="0" i="0"/>
               <a:t>Shows each restaurant's name, rating, distance, and cuisine type</a:t>
             </a:r>
           </a:p>
           <a:p>
-            <a:pPr/>
-            <a:r>
-              <a:rPr b="0" i="0" sz="1400"/>
+            <a:r>
+              <a:rPr sz="1400" b="0" i="0"/>
               <a:t>Lets users watch a real video preview (YouTube or TikTok) before visiting</a:t>
             </a:r>
           </a:p>
           <a:p>
-            <a:pPr/>
-            <a:r>
-              <a:rPr b="0" i="0" sz="1400"/>
+            <a:r>
+              <a:rPr sz="1400" b="0" i="0"/>
               <a:t>Gives instant turn-by-turn directions to the restaurant</a:t>
             </a:r>
           </a:p>
           <a:p>
-            <a:pPr/>
-            <a:r>
-              <a:rPr b="0" i="0" sz="1400"/>
+            <a:r>
+              <a:rPr sz="1400" b="0" i="0"/>
               <a:t>Built as a modern Android app using Kotlin and Jetpack Compose</a:t>
             </a:r>
           </a:p>
@@ -5513,7 +4530,9 @@
         <p:txBody>
           <a:bodyPr/>
           <a:lstStyle/>
-          <a:p/>
+          <a:p>
+            <a:endParaRPr/>
+          </a:p>
         </p:txBody>
       </p:sp>
       <p:sp>
@@ -5613,7 +4632,7 @@
           <a:lstStyle/>
           <a:p>
             <a:r>
-              <a:rPr i="1" sz="1100"/>
+              <a:rPr sz="1100" i="1"/>
               <a:t>Every screen has been designed and built to match a simple, easy-to-follow flow.</a:t>
             </a:r>
           </a:p>
@@ -5633,7 +4652,9 @@
         <p:txBody>
           <a:bodyPr/>
           <a:lstStyle/>
-          <a:p/>
+          <a:p>
+            <a:endParaRPr/>
+          </a:p>
         </p:txBody>
       </p:sp>
       <p:sp>
@@ -5674,7 +4695,7 @@
           <p:nvPr/>
         </p:nvPicPr>
         <p:blipFill>
-          <a:blip r:embed="rId2"/>
+          <a:blip r:embed="rId3"/>
           <a:stretch>
             <a:fillRect/>
           </a:stretch>
@@ -5698,7 +4719,7 @@
           <p:nvPr/>
         </p:nvPicPr>
         <p:blipFill>
-          <a:blip r:embed="rId3"/>
+          <a:blip r:embed="rId4"/>
           <a:stretch>
             <a:fillRect/>
           </a:stretch>
@@ -5722,7 +4743,7 @@
           <p:nvPr/>
         </p:nvPicPr>
         <p:blipFill>
-          <a:blip r:embed="rId4"/>
+          <a:blip r:embed="rId5"/>
           <a:stretch>
             <a:fillRect/>
           </a:stretch>
@@ -5746,7 +4767,7 @@
           <p:nvPr/>
         </p:nvPicPr>
         <p:blipFill>
-          <a:blip r:embed="rId5"/>
+          <a:blip r:embed="rId6"/>
           <a:stretch>
             <a:fillRect/>
           </a:stretch>
@@ -5770,7 +4791,7 @@
           <p:nvPr/>
         </p:nvPicPr>
         <p:blipFill>
-          <a:blip r:embed="rId6"/>
+          <a:blip r:embed="rId7"/>
           <a:stretch>
             <a:fillRect/>
           </a:stretch>
@@ -5794,7 +4815,7 @@
           <p:nvPr/>
         </p:nvPicPr>
         <p:blipFill>
-          <a:blip r:embed="rId7"/>
+          <a:blip r:embed="rId8"/>
           <a:stretch>
             <a:fillRect/>
           </a:stretch>
@@ -5818,7 +4839,7 @@
           <p:nvPr/>
         </p:nvPicPr>
         <p:blipFill>
-          <a:blip r:embed="rId8"/>
+          <a:blip r:embed="rId9"/>
           <a:stretch>
             <a:fillRect/>
           </a:stretch>
@@ -5842,7 +4863,7 @@
           <p:nvPr/>
         </p:nvPicPr>
         <p:blipFill>
-          <a:blip r:embed="rId9"/>
+          <a:blip r:embed="rId10"/>
           <a:stretch>
             <a:fillRect/>
           </a:stretch>
@@ -5866,7 +4887,7 @@
           <p:nvPr/>
         </p:nvPicPr>
         <p:blipFill>
-          <a:blip r:embed="rId10"/>
+          <a:blip r:embed="rId11"/>
           <a:stretch>
             <a:fillRect/>
           </a:stretch>
@@ -5890,7 +4911,7 @@
           <p:nvPr/>
         </p:nvPicPr>
         <p:blipFill>
-          <a:blip r:embed="rId11"/>
+          <a:blip r:embed="rId12"/>
           <a:stretch>
             <a:fillRect/>
           </a:stretch>
@@ -5914,7 +4935,7 @@
           <p:nvPr/>
         </p:nvPicPr>
         <p:blipFill>
-          <a:blip r:embed="rId12"/>
+          <a:blip r:embed="rId13"/>
           <a:stretch>
             <a:fillRect/>
           </a:stretch>
@@ -5996,51 +5017,44 @@
           <a:bodyPr/>
           <a:lstStyle/>
           <a:p>
-            <a:pPr/>
-            <a:r>
-              <a:rPr b="0" i="0" sz="1300"/>
+            <a:r>
+              <a:rPr sz="1300" b="0" i="0"/>
               <a:t>Splash Screen — a quick loading screen when the app opens</a:t>
             </a:r>
           </a:p>
           <a:p>
-            <a:pPr/>
-            <a:r>
-              <a:rPr b="0" i="0" sz="1300"/>
+            <a:r>
+              <a:rPr sz="1300" b="0" i="0"/>
               <a:t>Login or Register — sign in, create an account, or continue as a guest</a:t>
             </a:r>
           </a:p>
           <a:p>
-            <a:pPr/>
-            <a:r>
-              <a:rPr b="0" i="0" sz="1300"/>
+            <a:r>
+              <a:rPr sz="1300" b="0" i="0"/>
               <a:t>Home Page — search bar and quick access to nearby restaurants</a:t>
             </a:r>
           </a:p>
           <a:p>
-            <a:pPr/>
-            <a:r>
-              <a:rPr b="0" i="0" sz="1300"/>
+            <a:r>
+              <a:rPr sz="1300" b="0" i="0"/>
               <a:t>Map Screen — restaurants shown near the user's real location</a:t>
             </a:r>
           </a:p>
           <a:p>
-            <a:pPr/>
-            <a:r>
-              <a:rPr b="0" i="0" sz="1300"/>
+            <a:r>
+              <a:rPr sz="1300" b="0" i="0"/>
               <a:t>Restaurant Detail — name, rating, distance, and cuisine type</a:t>
             </a:r>
           </a:p>
           <a:p>
-            <a:pPr/>
-            <a:r>
-              <a:rPr b="0" i="0" sz="1300"/>
+            <a:r>
+              <a:rPr sz="1300" b="0" i="0"/>
               <a:t>Watch Video — a real preview video of the restaurant</a:t>
             </a:r>
           </a:p>
           <a:p>
-            <a:pPr/>
-            <a:r>
-              <a:rPr b="0" i="0" sz="1300"/>
+            <a:r>
+              <a:rPr sz="1300" b="0" i="0"/>
               <a:t>Directions — step-by-step navigation to the restaurant</a:t>
             </a:r>
           </a:p>
@@ -6060,7 +5074,9 @@
         <p:txBody>
           <a:bodyPr/>
           <a:lstStyle/>
-          <a:p/>
+          <a:p>
+            <a:endParaRPr/>
+          </a:p>
         </p:txBody>
       </p:sp>
       <p:sp>
@@ -6159,86 +5175,80 @@
           <a:bodyPr/>
           <a:lstStyle/>
           <a:p>
-            <a:pPr/>
-            <a:r>
-              <a:rPr b="1" i="0" sz="1300"/>
+            <a:r>
+              <a:rPr sz="1300" b="1" i="0"/>
               <a:t>Real GPS Location</a:t>
             </a:r>
           </a:p>
           <a:p>
             <a:pPr lvl="1"/>
             <a:r>
-              <a:rPr b="0" i="0" sz="1100"/>
+              <a:rPr sz="1100" b="0" i="0"/>
               <a:t>Finds restaurants near the user's actual position, not a fixed test location</a:t>
             </a:r>
           </a:p>
           <a:p>
-            <a:pPr/>
-            <a:r>
-              <a:rPr b="1" i="0" sz="1300"/>
+            <a:r>
+              <a:rPr sz="1300" b="1" i="0"/>
               <a:t>Live Google Map</a:t>
             </a:r>
           </a:p>
           <a:p>
             <a:pPr lvl="1"/>
             <a:r>
-              <a:rPr b="0" i="0" sz="1100"/>
+              <a:rPr sz="1100" b="0" i="0"/>
               <a:t>An interactive map with a real marker for every restaurant</a:t>
             </a:r>
           </a:p>
           <a:p>
-            <a:pPr/>
-            <a:r>
-              <a:rPr b="1" i="0" sz="1300"/>
+            <a:r>
+              <a:rPr sz="1300" b="1" i="0"/>
               <a:t>Account System</a:t>
             </a:r>
           </a:p>
           <a:p>
             <a:pPr lvl="1"/>
             <a:r>
-              <a:rPr b="0" i="0" sz="1100"/>
+              <a:rPr sz="1100" b="0" i="0"/>
               <a:t>Secure login and registration, tested on a real phone</a:t>
             </a:r>
           </a:p>
           <a:p>
-            <a:pPr/>
-            <a:r>
-              <a:rPr b="1" i="0" sz="1300"/>
+            <a:r>
+              <a:rPr sz="1300" b="1" i="0"/>
               <a:t>Screen Navigation</a:t>
             </a:r>
           </a:p>
           <a:p>
             <a:pPr lvl="1"/>
             <a:r>
-              <a:rPr b="0" i="0" sz="1100"/>
+              <a:rPr sz="1100" b="0" i="0"/>
               <a:t>Smooth movement between every screen, including a working back button</a:t>
             </a:r>
           </a:p>
           <a:p>
-            <a:pPr/>
-            <a:r>
-              <a:rPr b="1" i="0" sz="1300"/>
+            <a:r>
+              <a:rPr sz="1300" b="1" i="0"/>
               <a:t>Opens Other Apps</a:t>
             </a:r>
           </a:p>
           <a:p>
             <a:pPr lvl="1"/>
             <a:r>
-              <a:rPr b="0" i="0" sz="1100"/>
+              <a:rPr sz="1100" b="0" i="0"/>
               <a:t>The video button opens YouTube or TikTok, and directions open Google Maps</a:t>
             </a:r>
           </a:p>
           <a:p>
-            <a:pPr/>
-            <a:r>
-              <a:rPr b="1" i="0" sz="1300"/>
+            <a:r>
+              <a:rPr sz="1300" b="1" i="0"/>
               <a:t>Smart Search</a:t>
             </a:r>
           </a:p>
           <a:p>
             <a:pPr lvl="1"/>
             <a:r>
-              <a:rPr b="0" i="0" sz="1100"/>
+              <a:rPr sz="1100" b="0" i="0"/>
               <a:t>Typing in the search bar instantly filters which restaurants are shown</a:t>
             </a:r>
           </a:p>
@@ -6258,7 +5268,9 @@
         <p:txBody>
           <a:bodyPr/>
           <a:lstStyle/>
-          <a:p/>
+          <a:p>
+            <a:endParaRPr/>
+          </a:p>
         </p:txBody>
       </p:sp>
       <p:sp>
@@ -6357,37 +5369,32 @@
           <a:bodyPr/>
           <a:lstStyle/>
           <a:p>
-            <a:pPr/>
-            <a:r>
-              <a:rPr b="0" i="0" sz="1400"/>
+            <a:r>
+              <a:rPr sz="1400" b="0" i="0"/>
               <a:t>Users can register a new account or log in with an existing one</a:t>
             </a:r>
           </a:p>
           <a:p>
-            <a:pPr/>
-            <a:r>
-              <a:rPr b="0" i="0" sz="1400"/>
+            <a:r>
+              <a:rPr sz="1400" b="0" i="0"/>
               <a:t>Accounts are stored securely, not just kept on the phone</a:t>
             </a:r>
           </a:p>
           <a:p>
-            <a:pPr/>
-            <a:r>
-              <a:rPr b="0" i="0" sz="1400"/>
+            <a:r>
+              <a:rPr sz="1400" b="0" i="0"/>
               <a:t>Users can also continue as a guest without creating an account</a:t>
             </a:r>
           </a:p>
           <a:p>
-            <a:pPr/>
-            <a:r>
-              <a:rPr b="0" i="0" sz="1400"/>
+            <a:r>
+              <a:rPr sz="1400" b="0" i="0"/>
               <a:t>The map and restaurant features only unlock once a user is signed in</a:t>
             </a:r>
           </a:p>
           <a:p>
-            <a:pPr/>
-            <a:r>
-              <a:rPr b="0" i="0" sz="1400"/>
+            <a:r>
+              <a:rPr sz="1400" b="0" i="0"/>
               <a:t>Tested end-to-end on a real Android phone</a:t>
             </a:r>
           </a:p>
@@ -6407,7 +5414,9 @@
         <p:txBody>
           <a:bodyPr/>
           <a:lstStyle/>
-          <a:p/>
+          <a:p>
+            <a:endParaRPr/>
+          </a:p>
         </p:txBody>
       </p:sp>
       <p:sp>
@@ -6460,7 +5469,7 @@
         <p:cNvPr id="1" name="">
           <a:extLst>
             <a:ext uri="{FF2B5EF4-FFF2-40B4-BE49-F238E27FC236}">
-              <a16:creationId xmlns:a16="http://schemas.microsoft.com/office/drawing/2014/main" id="{9DCAAF8A-320C-4F88-CEAA-80EA17C59917}"/>
+              <a16:creationId xmlns:a16="http://schemas.microsoft.com/office/drawing/2014/main" xmlns="" id="{9DCAAF8A-320C-4F88-CEAA-80EA17C59917}"/>
             </a:ext>
           </a:extLst>
         </p:cNvPr>
@@ -6480,7 +5489,7 @@
           <p:cNvPr id="2" name="Title 1">
             <a:extLst>
               <a:ext uri="{FF2B5EF4-FFF2-40B4-BE49-F238E27FC236}">
-                <a16:creationId xmlns:a16="http://schemas.microsoft.com/office/drawing/2014/main" id="{1CF74DC2-AAF4-9A34-C6C0-D92F4C4BBF71}"/>
+                <a16:creationId xmlns:a16="http://schemas.microsoft.com/office/drawing/2014/main" xmlns="" id="{1CF74DC2-AAF4-9A34-C6C0-D92F4C4BBF71}"/>
               </a:ext>
             </a:extLst>
           </p:cNvPr>
@@ -6508,7 +5517,7 @@
           <p:cNvPr id="3" name="Content Placeholder 2">
             <a:extLst>
               <a:ext uri="{FF2B5EF4-FFF2-40B4-BE49-F238E27FC236}">
-                <a16:creationId xmlns:a16="http://schemas.microsoft.com/office/drawing/2014/main" id="{9832DCBD-57EA-B27E-9539-004208707827}"/>
+                <a16:creationId xmlns:a16="http://schemas.microsoft.com/office/drawing/2014/main" xmlns="" id="{9832DCBD-57EA-B27E-9539-004208707827}"/>
               </a:ext>
             </a:extLst>
           </p:cNvPr>
@@ -6524,37 +5533,32 @@
           <a:bodyPr/>
           <a:lstStyle/>
           <a:p>
-            <a:pPr/>
-            <a:r>
-              <a:rPr b="0" i="0" sz="1400"/>
+            <a:r>
+              <a:rPr sz="1400" b="0" i="0"/>
               <a:t>All app screens are designed and fully working</a:t>
             </a:r>
           </a:p>
           <a:p>
-            <a:pPr/>
-            <a:r>
-              <a:rPr b="0" i="0" sz="1400"/>
+            <a:r>
+              <a:rPr sz="1400" b="0" i="0"/>
               <a:t>A real login and account system is in place and tested</a:t>
             </a:r>
           </a:p>
           <a:p>
-            <a:pPr/>
-            <a:r>
-              <a:rPr b="0" i="0" sz="1400"/>
+            <a:r>
+              <a:rPr sz="1400" b="0" i="0"/>
               <a:t>The map shows restaurants using the user's real location</a:t>
             </a:r>
           </a:p>
           <a:p>
-            <a:pPr/>
-            <a:r>
-              <a:rPr b="0" i="0" sz="1400"/>
+            <a:r>
+              <a:rPr sz="1400" b="0" i="0"/>
               <a:t>Users can preview restaurants with real videos before visiting</a:t>
             </a:r>
           </a:p>
           <a:p>
-            <a:pPr/>
-            <a:r>
-              <a:rPr b="0" i="0" sz="1400"/>
+            <a:r>
+              <a:rPr sz="1400" b="0" i="0"/>
               <a:t>One tap gives directions straight to the restaurant</a:t>
             </a:r>
           </a:p>
@@ -6565,7 +5569,7 @@
           <p:cNvPr id="4" name="Date Placeholder 3">
             <a:extLst>
               <a:ext uri="{FF2B5EF4-FFF2-40B4-BE49-F238E27FC236}">
-                <a16:creationId xmlns:a16="http://schemas.microsoft.com/office/drawing/2014/main" id="{ADD7124F-9A31-F596-A902-B9AC5F0935DA}"/>
+                <a16:creationId xmlns:a16="http://schemas.microsoft.com/office/drawing/2014/main" xmlns="" id="{ADD7124F-9A31-F596-A902-B9AC5F0935DA}"/>
               </a:ext>
             </a:extLst>
           </p:cNvPr>
@@ -6580,7 +5584,9 @@
         <p:txBody>
           <a:bodyPr/>
           <a:lstStyle/>
-          <a:p/>
+          <a:p>
+            <a:endParaRPr/>
+          </a:p>
         </p:txBody>
       </p:sp>
       <p:sp>
@@ -6588,7 +5594,7 @@
           <p:cNvPr id="5" name="Slide Number Placeholder 4">
             <a:extLst>
               <a:ext uri="{FF2B5EF4-FFF2-40B4-BE49-F238E27FC236}">
-                <a16:creationId xmlns:a16="http://schemas.microsoft.com/office/drawing/2014/main" id="{3D2EA6C1-1DE3-2059-68F9-EB41166475C9}"/>
+                <a16:creationId xmlns:a16="http://schemas.microsoft.com/office/drawing/2014/main" xmlns="" id="{3D2EA6C1-1DE3-2059-68F9-EB41166475C9}"/>
               </a:ext>
             </a:extLst>
           </p:cNvPr>
@@ -6650,469 +5656,68 @@
       </p:grpSpPr>
       <p:sp>
         <p:nvSpPr>
-          <p:cNvPr id="2050" name="Date Placeholder 3"/>
+          <p:cNvPr id="2" name="Title 1"/>
           <p:cNvSpPr>
             <a:spLocks noGrp="1"/>
           </p:cNvSpPr>
           <p:nvPr>
-            <p:ph type="dt" sz="quarter" idx="4294967295"/>
-          </p:nvPr>
-        </p:nvSpPr>
-        <p:spPr>
-          <a:noFill/>
-          <a:ln/>
-          <a:extLst>
-            <a:ext uri="{909E8E84-426E-40DD-AFC4-6F175D3DCCD1}">
-              <a14:hiddenFill xmlns:a14="http://schemas.microsoft.com/office/drawing/2010/main">
-                <a:solidFill>
-                  <a:srgbClr val="FFFFFF"/>
-                </a:solidFill>
-              </a14:hiddenFill>
-            </a:ext>
-            <a:ext uri="{91240B29-F687-4F45-9708-019B960494DF}">
-              <a14:hiddenLine xmlns:a14="http://schemas.microsoft.com/office/drawing/2010/main" w="9525">
-                <a:solidFill>
-                  <a:srgbClr val="000000"/>
-                </a:solidFill>
-                <a:miter lim="800000"/>
-                <a:headEnd/>
-                <a:tailEnd/>
-              </a14:hiddenLine>
-            </a:ext>
-          </a:extLst>
-        </p:spPr>
-        <p:txBody>
-          <a:bodyPr/>
-          <a:lstStyle>
-            <a:lvl1pPr eaLnBrk="0" hangingPunct="0">
-              <a:defRPr sz="2400">
-                <a:solidFill>
-                  <a:schemeClr val="bg1"/>
-                </a:solidFill>
-                <a:latin typeface="Comic Sans MS" panose="030F0702030302020204" pitchFamily="66" charset="0"/>
-                <a:cs typeface="Arial" panose="020B0604020202020204" pitchFamily="34" charset="0"/>
-              </a:defRPr>
-            </a:lvl1pPr>
-            <a:lvl2pPr marL="742950" indent="-285750" eaLnBrk="0" hangingPunct="0">
-              <a:defRPr sz="2400">
-                <a:solidFill>
-                  <a:schemeClr val="bg1"/>
-                </a:solidFill>
-                <a:latin typeface="Comic Sans MS" panose="030F0702030302020204" pitchFamily="66" charset="0"/>
-                <a:cs typeface="Arial" panose="020B0604020202020204" pitchFamily="34" charset="0"/>
-              </a:defRPr>
-            </a:lvl2pPr>
-            <a:lvl3pPr marL="1143000" indent="-228600" eaLnBrk="0" hangingPunct="0">
-              <a:defRPr sz="2400">
-                <a:solidFill>
-                  <a:schemeClr val="bg1"/>
-                </a:solidFill>
-                <a:latin typeface="Comic Sans MS" panose="030F0702030302020204" pitchFamily="66" charset="0"/>
-                <a:cs typeface="Arial" panose="020B0604020202020204" pitchFamily="34" charset="0"/>
-              </a:defRPr>
-            </a:lvl3pPr>
-            <a:lvl4pPr marL="1600200" indent="-228600" eaLnBrk="0" hangingPunct="0">
-              <a:defRPr sz="2400">
-                <a:solidFill>
-                  <a:schemeClr val="bg1"/>
-                </a:solidFill>
-                <a:latin typeface="Comic Sans MS" panose="030F0702030302020204" pitchFamily="66" charset="0"/>
-                <a:cs typeface="Arial" panose="020B0604020202020204" pitchFamily="34" charset="0"/>
-              </a:defRPr>
-            </a:lvl4pPr>
-            <a:lvl5pPr marL="2057400" indent="-228600" eaLnBrk="0" hangingPunct="0">
-              <a:defRPr sz="2400">
-                <a:solidFill>
-                  <a:schemeClr val="bg1"/>
-                </a:solidFill>
-                <a:latin typeface="Comic Sans MS" panose="030F0702030302020204" pitchFamily="66" charset="0"/>
-                <a:cs typeface="Arial" panose="020B0604020202020204" pitchFamily="34" charset="0"/>
-              </a:defRPr>
-            </a:lvl5pPr>
-            <a:lvl6pPr marL="2514600" indent="-228600" eaLnBrk="0" fontAlgn="base" hangingPunct="0">
-              <a:spcBef>
-                <a:spcPct val="20000"/>
-              </a:spcBef>
-              <a:spcAft>
-                <a:spcPct val="0"/>
-              </a:spcAft>
-              <a:buChar char="•"/>
-              <a:defRPr sz="2400">
-                <a:solidFill>
-                  <a:schemeClr val="bg1"/>
-                </a:solidFill>
-                <a:latin typeface="Comic Sans MS" panose="030F0702030302020204" pitchFamily="66" charset="0"/>
-                <a:cs typeface="Arial" panose="020B0604020202020204" pitchFamily="34" charset="0"/>
-              </a:defRPr>
-            </a:lvl6pPr>
-            <a:lvl7pPr marL="2971800" indent="-228600" eaLnBrk="0" fontAlgn="base" hangingPunct="0">
-              <a:spcBef>
-                <a:spcPct val="20000"/>
-              </a:spcBef>
-              <a:spcAft>
-                <a:spcPct val="0"/>
-              </a:spcAft>
-              <a:buChar char="•"/>
-              <a:defRPr sz="2400">
-                <a:solidFill>
-                  <a:schemeClr val="bg1"/>
-                </a:solidFill>
-                <a:latin typeface="Comic Sans MS" panose="030F0702030302020204" pitchFamily="66" charset="0"/>
-                <a:cs typeface="Arial" panose="020B0604020202020204" pitchFamily="34" charset="0"/>
-              </a:defRPr>
-            </a:lvl7pPr>
-            <a:lvl8pPr marL="3429000" indent="-228600" eaLnBrk="0" fontAlgn="base" hangingPunct="0">
-              <a:spcBef>
-                <a:spcPct val="20000"/>
-              </a:spcBef>
-              <a:spcAft>
-                <a:spcPct val="0"/>
-              </a:spcAft>
-              <a:buChar char="•"/>
-              <a:defRPr sz="2400">
-                <a:solidFill>
-                  <a:schemeClr val="bg1"/>
-                </a:solidFill>
-                <a:latin typeface="Comic Sans MS" panose="030F0702030302020204" pitchFamily="66" charset="0"/>
-                <a:cs typeface="Arial" panose="020B0604020202020204" pitchFamily="34" charset="0"/>
-              </a:defRPr>
-            </a:lvl8pPr>
-            <a:lvl9pPr marL="3886200" indent="-228600" eaLnBrk="0" fontAlgn="base" hangingPunct="0">
-              <a:spcBef>
-                <a:spcPct val="20000"/>
-              </a:spcBef>
-              <a:spcAft>
-                <a:spcPct val="0"/>
-              </a:spcAft>
-              <a:buChar char="•"/>
-              <a:defRPr sz="2400">
-                <a:solidFill>
-                  <a:schemeClr val="bg1"/>
-                </a:solidFill>
-                <a:latin typeface="Comic Sans MS" panose="030F0702030302020204" pitchFamily="66" charset="0"/>
-                <a:cs typeface="Arial" panose="020B0604020202020204" pitchFamily="34" charset="0"/>
-              </a:defRPr>
-            </a:lvl9pPr>
-          </a:lstStyle>
-          <a:p>
-            <a:r>
-              <a:rPr lang="en-US" altLang="en-US" sz="1400">
-                <a:latin typeface="Verdana" panose="020B0604030504040204" pitchFamily="34" charset="0"/>
-              </a:rPr>
-              <a:t>© copyright UEA</a:t>
-            </a:r>
-            <a:endParaRPr lang="en-GB" altLang="en-US" sz="1400">
-              <a:latin typeface="Times New Roman" panose="02020603050405020304" pitchFamily="18" charset="0"/>
-            </a:endParaRPr>
-          </a:p>
-        </p:txBody>
-      </p:sp>
-      <p:sp>
-        <p:nvSpPr>
-          <p:cNvPr id="2052" name="Slide Number Placeholder 5"/>
-          <p:cNvSpPr>
-            <a:spLocks noGrp="1"/>
-          </p:cNvSpPr>
-          <p:nvPr>
-            <p:ph type="sldNum" sz="quarter" idx="4294967295"/>
-          </p:nvPr>
-        </p:nvSpPr>
-        <p:spPr>
-          <a:noFill/>
-          <a:ln/>
-          <a:extLst>
-            <a:ext uri="{909E8E84-426E-40DD-AFC4-6F175D3DCCD1}">
-              <a14:hiddenFill xmlns:a14="http://schemas.microsoft.com/office/drawing/2010/main">
-                <a:solidFill>
-                  <a:srgbClr val="FFFFFF"/>
-                </a:solidFill>
-              </a14:hiddenFill>
-            </a:ext>
-            <a:ext uri="{91240B29-F687-4F45-9708-019B960494DF}">
-              <a14:hiddenLine xmlns:a14="http://schemas.microsoft.com/office/drawing/2010/main" w="9525">
-                <a:solidFill>
-                  <a:srgbClr val="000000"/>
-                </a:solidFill>
-                <a:miter lim="800000"/>
-                <a:headEnd/>
-                <a:tailEnd/>
-              </a14:hiddenLine>
-            </a:ext>
-          </a:extLst>
-        </p:spPr>
-        <p:txBody>
-          <a:bodyPr/>
-          <a:lstStyle>
-            <a:lvl1pPr eaLnBrk="0" hangingPunct="0">
-              <a:defRPr sz="2400">
-                <a:solidFill>
-                  <a:schemeClr val="bg1"/>
-                </a:solidFill>
-                <a:latin typeface="Comic Sans MS" panose="030F0702030302020204" pitchFamily="66" charset="0"/>
-                <a:cs typeface="Arial" panose="020B0604020202020204" pitchFamily="34" charset="0"/>
-              </a:defRPr>
-            </a:lvl1pPr>
-            <a:lvl2pPr marL="742950" indent="-285750" eaLnBrk="0" hangingPunct="0">
-              <a:defRPr sz="2400">
-                <a:solidFill>
-                  <a:schemeClr val="bg1"/>
-                </a:solidFill>
-                <a:latin typeface="Comic Sans MS" panose="030F0702030302020204" pitchFamily="66" charset="0"/>
-                <a:cs typeface="Arial" panose="020B0604020202020204" pitchFamily="34" charset="0"/>
-              </a:defRPr>
-            </a:lvl2pPr>
-            <a:lvl3pPr marL="1143000" indent="-228600" eaLnBrk="0" hangingPunct="0">
-              <a:defRPr sz="2400">
-                <a:solidFill>
-                  <a:schemeClr val="bg1"/>
-                </a:solidFill>
-                <a:latin typeface="Comic Sans MS" panose="030F0702030302020204" pitchFamily="66" charset="0"/>
-                <a:cs typeface="Arial" panose="020B0604020202020204" pitchFamily="34" charset="0"/>
-              </a:defRPr>
-            </a:lvl3pPr>
-            <a:lvl4pPr marL="1600200" indent="-228600" eaLnBrk="0" hangingPunct="0">
-              <a:defRPr sz="2400">
-                <a:solidFill>
-                  <a:schemeClr val="bg1"/>
-                </a:solidFill>
-                <a:latin typeface="Comic Sans MS" panose="030F0702030302020204" pitchFamily="66" charset="0"/>
-                <a:cs typeface="Arial" panose="020B0604020202020204" pitchFamily="34" charset="0"/>
-              </a:defRPr>
-            </a:lvl4pPr>
-            <a:lvl5pPr marL="2057400" indent="-228600" eaLnBrk="0" hangingPunct="0">
-              <a:defRPr sz="2400">
-                <a:solidFill>
-                  <a:schemeClr val="bg1"/>
-                </a:solidFill>
-                <a:latin typeface="Comic Sans MS" panose="030F0702030302020204" pitchFamily="66" charset="0"/>
-                <a:cs typeface="Arial" panose="020B0604020202020204" pitchFamily="34" charset="0"/>
-              </a:defRPr>
-            </a:lvl5pPr>
-            <a:lvl6pPr marL="2514600" indent="-228600" eaLnBrk="0" fontAlgn="base" hangingPunct="0">
-              <a:spcBef>
-                <a:spcPct val="20000"/>
-              </a:spcBef>
-              <a:spcAft>
-                <a:spcPct val="0"/>
-              </a:spcAft>
-              <a:buChar char="•"/>
-              <a:defRPr sz="2400">
-                <a:solidFill>
-                  <a:schemeClr val="bg1"/>
-                </a:solidFill>
-                <a:latin typeface="Comic Sans MS" panose="030F0702030302020204" pitchFamily="66" charset="0"/>
-                <a:cs typeface="Arial" panose="020B0604020202020204" pitchFamily="34" charset="0"/>
-              </a:defRPr>
-            </a:lvl6pPr>
-            <a:lvl7pPr marL="2971800" indent="-228600" eaLnBrk="0" fontAlgn="base" hangingPunct="0">
-              <a:spcBef>
-                <a:spcPct val="20000"/>
-              </a:spcBef>
-              <a:spcAft>
-                <a:spcPct val="0"/>
-              </a:spcAft>
-              <a:buChar char="•"/>
-              <a:defRPr sz="2400">
-                <a:solidFill>
-                  <a:schemeClr val="bg1"/>
-                </a:solidFill>
-                <a:latin typeface="Comic Sans MS" panose="030F0702030302020204" pitchFamily="66" charset="0"/>
-                <a:cs typeface="Arial" panose="020B0604020202020204" pitchFamily="34" charset="0"/>
-              </a:defRPr>
-            </a:lvl7pPr>
-            <a:lvl8pPr marL="3429000" indent="-228600" eaLnBrk="0" fontAlgn="base" hangingPunct="0">
-              <a:spcBef>
-                <a:spcPct val="20000"/>
-              </a:spcBef>
-              <a:spcAft>
-                <a:spcPct val="0"/>
-              </a:spcAft>
-              <a:buChar char="•"/>
-              <a:defRPr sz="2400">
-                <a:solidFill>
-                  <a:schemeClr val="bg1"/>
-                </a:solidFill>
-                <a:latin typeface="Comic Sans MS" panose="030F0702030302020204" pitchFamily="66" charset="0"/>
-                <a:cs typeface="Arial" panose="020B0604020202020204" pitchFamily="34" charset="0"/>
-              </a:defRPr>
-            </a:lvl8pPr>
-            <a:lvl9pPr marL="3886200" indent="-228600" eaLnBrk="0" fontAlgn="base" hangingPunct="0">
-              <a:spcBef>
-                <a:spcPct val="20000"/>
-              </a:spcBef>
-              <a:spcAft>
-                <a:spcPct val="0"/>
-              </a:spcAft>
-              <a:buChar char="•"/>
-              <a:defRPr sz="2400">
-                <a:solidFill>
-                  <a:schemeClr val="bg1"/>
-                </a:solidFill>
-                <a:latin typeface="Comic Sans MS" panose="030F0702030302020204" pitchFamily="66" charset="0"/>
-                <a:cs typeface="Arial" panose="020B0604020202020204" pitchFamily="34" charset="0"/>
-              </a:defRPr>
-            </a:lvl9pPr>
-          </a:lstStyle>
-          <a:p>
-            <a:r>
-              <a:rPr lang="en-GB" altLang="en-US" sz="1400">
-                <a:latin typeface="Times New Roman" panose="02020603050405020304" pitchFamily="18" charset="0"/>
-              </a:rPr>
-              <a:t>slide </a:t>
-            </a:r>
-            <a:fld id="{1010D064-77DF-4B55-80BD-1876EBCED9D8}" type="slidenum">
-              <a:rPr lang="en-GB" altLang="en-US" sz="1400">
-                <a:latin typeface="Times New Roman" panose="02020603050405020304" pitchFamily="18" charset="0"/>
-              </a:rPr>
-              <a:pPr/>
-              <a:t>8</a:t>
-            </a:fld>
-            <a:endParaRPr lang="en-GB" altLang="en-US" sz="1400">
-              <a:latin typeface="Times New Roman" panose="02020603050405020304" pitchFamily="18" charset="0"/>
-            </a:endParaRPr>
-          </a:p>
-        </p:txBody>
-      </p:sp>
-      <p:sp>
-        <p:nvSpPr>
-          <p:cNvPr id="2053" name="Rectangle 2"/>
-          <p:cNvSpPr>
-            <a:spLocks noGrp="1" noChangeArrowheads="1"/>
-          </p:cNvSpPr>
-          <p:nvPr>
-            <p:ph type="ctrTitle"/>
-          </p:nvPr>
-        </p:nvSpPr>
-        <p:spPr>
-          <a:xfrm>
-            <a:off x="179512" y="1052736"/>
-            <a:ext cx="8784976" cy="1537518"/>
-          </a:xfrm>
-        </p:spPr>
+            <p:ph type="title"/>
+          </p:nvPr>
+        </p:nvSpPr>
+        <p:spPr/>
         <p:txBody>
           <a:bodyPr/>
           <a:lstStyle/>
           <a:p>
             <a:r>
-              <a:rPr lang="en-GB" altLang="en-US" sz="4400" dirty="0"/>
-              <a:t>Progress Report</a:t>
-            </a:r>
-            <a:br>
-              <a:rPr lang="en-GB" altLang="en-US" sz="3200" dirty="0"/>
-            </a:br>
-            <a:r>
-              <a:rPr lang="en-GB" altLang="en-US" sz="3200" dirty="0"/>
-              <a:t>15 Apr-22 Apr 2024</a:t>
-            </a:r>
-          </a:p>
-        </p:txBody>
-      </p:sp>
-      <p:sp>
-        <p:nvSpPr>
-          <p:cNvPr id="2054" name="Rectangle 3"/>
-          <p:cNvSpPr>
-            <a:spLocks noGrp="1" noChangeArrowheads="1"/>
-          </p:cNvSpPr>
-          <p:nvPr>
-            <p:ph type="subTitle" idx="1"/>
-          </p:nvPr>
-        </p:nvSpPr>
-        <p:spPr>
-          <a:xfrm>
-            <a:off x="1187624" y="4077072"/>
-            <a:ext cx="6912768" cy="1800200"/>
-          </a:xfrm>
-        </p:spPr>
+              <a:t>What's Coming Next</a:t>
+            </a:r>
+            <a:endParaRPr lang="zh-TW" altLang="en-US" dirty="0"/>
+          </a:p>
+        </p:txBody>
+      </p:sp>
+      <p:sp>
+        <p:nvSpPr>
+          <p:cNvPr id="3" name="Content Placeholder 2"/>
+          <p:cNvSpPr>
+            <a:spLocks noGrp="1"/>
+          </p:cNvSpPr>
+          <p:nvPr>
+            <p:ph idx="1"/>
+          </p:nvPr>
+        </p:nvSpPr>
+        <p:spPr/>
         <p:txBody>
           <a:bodyPr/>
           <a:lstStyle/>
           <a:p>
             <a:r>
-              <a:rPr lang="en-GB" altLang="en-US" b="1" dirty="0">
-                <a:solidFill>
-                  <a:schemeClr val="tx2"/>
-                </a:solidFill>
-                <a:latin typeface="+mj-lt"/>
-                <a:ea typeface="微軟正黑體" panose="020B0604030504040204" pitchFamily="34" charset="-120"/>
-                <a:cs typeface="微軟正黑體" panose="020B0604030504040204" pitchFamily="34" charset="-120"/>
-              </a:rPr>
-              <a:t>For example: Adam Cook</a:t>
-            </a:r>
-            <a:br>
-              <a:rPr lang="en-GB" altLang="en-US" b="1" dirty="0">
-                <a:solidFill>
-                  <a:schemeClr val="tx2"/>
-                </a:solidFill>
-                <a:latin typeface="+mj-lt"/>
-                <a:ea typeface="微軟正黑體" panose="020B0604030504040204" pitchFamily="34" charset="-120"/>
-                <a:cs typeface="微軟正黑體" panose="020B0604030504040204" pitchFamily="34" charset="-120"/>
-              </a:rPr>
-            </a:br>
-            <a:r>
-              <a:rPr lang="en-GB" altLang="en-US" b="1" dirty="0">
-                <a:solidFill>
-                  <a:schemeClr val="tx2"/>
-                </a:solidFill>
-                <a:latin typeface="+mj-lt"/>
-                <a:ea typeface="微軟正黑體" panose="020B0604030504040204" pitchFamily="34" charset="-120"/>
-                <a:cs typeface="微軟正黑體" panose="020B0604030504040204" pitchFamily="34" charset="-120"/>
-              </a:rPr>
-              <a:t>University of East Anglia</a:t>
-            </a:r>
-          </a:p>
-          <a:p>
-            <a:r>
-              <a:rPr lang="en-GB" altLang="en-US" b="1" dirty="0">
-                <a:solidFill>
-                  <a:schemeClr val="tx2"/>
-                </a:solidFill>
-                <a:latin typeface="+mj-lt"/>
-                <a:ea typeface="微軟正黑體" panose="020B0604030504040204" pitchFamily="34" charset="-120"/>
-                <a:cs typeface="微軟正黑體" panose="020B0604030504040204" pitchFamily="34" charset="-120"/>
-              </a:rPr>
-              <a:t>05-Mar-2023</a:t>
-            </a:r>
-          </a:p>
-        </p:txBody>
-      </p:sp>
-    </p:spTree>
-    <p:extLst>
-      <p:ext uri="{BB962C8B-B14F-4D97-AF65-F5344CB8AC3E}">
-        <p14:creationId xmlns:p14="http://schemas.microsoft.com/office/powerpoint/2010/main" val="3238939438"/>
-      </p:ext>
-    </p:extLst>
-  </p:cSld>
-  <p:clrMapOvr>
-    <a:masterClrMapping/>
-  </p:clrMapOvr>
-</p:sld>
-</file>
-
-<file path=ppt/slides/slide9.xml><?xml version="1.0" encoding="utf-8"?>
-<p:sld xmlns:a="http://schemas.openxmlformats.org/drawingml/2006/main" xmlns:r="http://schemas.openxmlformats.org/officeDocument/2006/relationships" xmlns:p="http://schemas.openxmlformats.org/presentationml/2006/main">
-  <p:cSld>
-    <p:spTree>
-      <p:nvGrpSpPr>
-        <p:cNvPr id="1" name=""/>
-        <p:cNvGrpSpPr/>
-        <p:nvPr/>
-      </p:nvGrpSpPr>
-      <p:grpSpPr>
-        <a:xfrm>
-          <a:off x="0" y="0"/>
-          <a:ext cx="0" cy="0"/>
-          <a:chOff x="0" y="0"/>
-          <a:chExt cx="0" cy="0"/>
-        </a:xfrm>
-      </p:grpSpPr>
-      <p:sp>
-        <p:nvSpPr>
-          <p:cNvPr id="2" name="Title 1"/>
+              <a:rPr sz="1400" b="0" i="0"/>
+              <a:t>Connect the map to real, live restaurant listings nearby</a:t>
+            </a:r>
+          </a:p>
+          <a:p>
+            <a:r>
+              <a:rPr sz="1400" b="0" i="0"/>
+              <a:t>Make the search bar pull results directly from those live listings</a:t>
+            </a:r>
+          </a:p>
+          <a:p>
+            <a:r>
+              <a:rPr sz="1400" b="0" i="0"/>
+              <a:t>Add a small safeguard so pressing back on the map doesn't close the app by accident</a:t>
+            </a:r>
+          </a:p>
+        </p:txBody>
+      </p:sp>
+      <p:sp>
+        <p:nvSpPr>
+          <p:cNvPr id="4" name="Date Placeholder 3"/>
           <p:cNvSpPr>
             <a:spLocks noGrp="1"/>
           </p:cNvSpPr>
           <p:nvPr>
-            <p:ph type="title"/>
+            <p:ph type="dt" sz="half" idx="10"/>
           </p:nvPr>
         </p:nvSpPr>
         <p:spPr/>
@@ -7120,65 +5725,8 @@
           <a:bodyPr/>
           <a:lstStyle/>
           <a:p>
-            <a:r>
-              <a:t>What's Coming Next</a:t>
-            </a:r>
-            <a:endParaRPr lang="zh-TW" altLang="en-US" dirty="0"/>
-          </a:p>
-        </p:txBody>
-      </p:sp>
-      <p:sp>
-        <p:nvSpPr>
-          <p:cNvPr id="3" name="Content Placeholder 2"/>
-          <p:cNvSpPr>
-            <a:spLocks noGrp="1"/>
-          </p:cNvSpPr>
-          <p:nvPr>
-            <p:ph idx="1"/>
-          </p:nvPr>
-        </p:nvSpPr>
-        <p:spPr/>
-        <p:txBody>
-          <a:bodyPr/>
-          <a:lstStyle/>
-          <a:p>
-            <a:pPr/>
-            <a:r>
-              <a:rPr b="0" i="0" sz="1400"/>
-              <a:t>Connect the map to real, live restaurant listings nearby</a:t>
-            </a:r>
-          </a:p>
-          <a:p>
-            <a:pPr/>
-            <a:r>
-              <a:rPr b="0" i="0" sz="1400"/>
-              <a:t>Make the search bar pull results directly from those live listings</a:t>
-            </a:r>
-          </a:p>
-          <a:p>
-            <a:pPr/>
-            <a:r>
-              <a:rPr b="0" i="0" sz="1400"/>
-              <a:t>Add a small safeguard so pressing back on the map doesn't close the app by accident</a:t>
-            </a:r>
-          </a:p>
-        </p:txBody>
-      </p:sp>
-      <p:sp>
-        <p:nvSpPr>
-          <p:cNvPr id="4" name="Date Placeholder 3"/>
-          <p:cNvSpPr>
-            <a:spLocks noGrp="1"/>
-          </p:cNvSpPr>
-          <p:nvPr>
-            <p:ph type="dt" sz="half" idx="10"/>
-          </p:nvPr>
-        </p:nvSpPr>
-        <p:spPr/>
-        <p:txBody>
-          <a:bodyPr/>
-          <a:lstStyle/>
-          <a:p/>
+            <a:endParaRPr/>
+          </a:p>
         </p:txBody>
       </p:sp>
       <p:sp>
@@ -7204,7 +5752,7 @@
               <a:pPr>
                 <a:defRPr/>
               </a:pPr>
-              <a:t>9</a:t>
+              <a:t>8</a:t>
             </a:fld>
             <a:endParaRPr lang="zh-TW" altLang="en-US"/>
           </a:p>

</xml_diff>